<commit_message>
simplify template: drop parchment bg and branch motif
Switch to a minimal white-background style per reference image: plain
white slides, Calibri throughout, a slim gold accent bar next to each
title, and a single gold rule below the logo header. Removed the
Pillow-generated parchment and tree-branch assets and the textures.py
generator they required.

Co-Authored-By: Claude Opus 4.7 (1M context) <noreply@anthropic.com>
</commit_message>
<xml_diff>
--- a/templates/tree_yellow_texture/KCLNLP_TreeYellow.pptx
+++ b/templates/tree_yellow_texture/KCLNLP_TreeYellow.pptx
@@ -3094,7 +3094,7 @@
       <p:grpSpPr/>
       <p:pic>
         <p:nvPicPr>
-          <p:cNvPr id="2" name="Picture 1" descr="parchment_bg.png"/>
+          <p:cNvPr id="2" name="Picture 1" descr="KCL.png"/>
           <p:cNvPicPr>
             <a:picLocks noChangeAspect="1"/>
           </p:cNvPicPr>
@@ -3108,8 +3108,8 @@
         </p:blipFill>
         <p:spPr>
           <a:xfrm>
-            <a:off x="0" y="0"/>
-            <a:ext cx="12191695" cy="6858000"/>
+            <a:off x="9111763" y="201168"/>
+            <a:ext cx="831046" cy="411480"/>
           </a:xfrm>
           <a:prstGeom prst="rect">
             <a:avLst/>
@@ -3118,7 +3118,7 @@
       </p:pic>
       <p:pic>
         <p:nvPicPr>
-          <p:cNvPr id="3" name="Picture 2" descr="tree_branch.png"/>
+          <p:cNvPr id="3" name="Picture 2" descr="KCLNLP.png"/>
           <p:cNvPicPr>
             <a:picLocks noChangeAspect="1"/>
           </p:cNvPicPr>
@@ -3132,8 +3132,8 @@
         </p:blipFill>
         <p:spPr>
           <a:xfrm>
-            <a:off x="5105096" y="1520191"/>
-            <a:ext cx="7360919" cy="5520689"/>
+            <a:off x="10125688" y="201168"/>
+            <a:ext cx="452782" cy="411480"/>
           </a:xfrm>
           <a:prstGeom prst="rect">
             <a:avLst/>
@@ -3142,7 +3142,7 @@
       </p:pic>
       <p:pic>
         <p:nvPicPr>
-          <p:cNvPr id="4" name="Picture 3" descr="KCL.png"/>
+          <p:cNvPr id="4" name="Picture 3" descr="Alan.png"/>
           <p:cNvPicPr>
             <a:picLocks noChangeAspect="1"/>
           </p:cNvPicPr>
@@ -3156,8 +3156,8 @@
         </p:blipFill>
         <p:spPr>
           <a:xfrm>
-            <a:off x="9298804" y="128016"/>
-            <a:ext cx="775643" cy="384048"/>
+            <a:off x="10761349" y="201168"/>
+            <a:ext cx="973146" cy="411480"/>
           </a:xfrm>
           <a:prstGeom prst="rect">
             <a:avLst/>
@@ -3172,15 +3172,15 @@
         </p:nvCxnSpPr>
         <p:spPr>
           <a:xfrm>
-            <a:off x="10156742" y="182880"/>
-            <a:ext cx="0" cy="274320"/>
+            <a:off x="457200" y="777240"/>
+            <a:ext cx="11277295" cy="0"/>
           </a:xfrm>
           <a:prstGeom prst="line">
             <a:avLst/>
           </a:prstGeom>
-          <a:ln w="4000">
+          <a:ln w="9525">
             <a:solidFill>
-              <a:srgbClr val="8A6A2E"/>
+              <a:srgbClr val="C8963E"/>
             </a:solidFill>
           </a:ln>
         </p:spPr>
@@ -3199,47 +3199,136 @@
           </a:fontRef>
         </p:style>
       </p:cxnSp>
-      <p:pic>
-        <p:nvPicPr>
-          <p:cNvPr id="6" name="Picture 5" descr="KCLNLP.png"/>
-          <p:cNvPicPr>
-            <a:picLocks noChangeAspect="1"/>
-          </p:cNvPicPr>
+      <p:sp>
+        <p:nvSpPr>
+          <p:cNvPr id="6" name="Rectangle 5"/>
+          <p:cNvSpPr/>
           <p:nvPr/>
-        </p:nvPicPr>
-        <p:blipFill>
-          <a:blip r:embed="rId5"/>
-          <a:stretch>
-            <a:fillRect/>
-          </a:stretch>
-        </p:blipFill>
-        <p:spPr>
-          <a:xfrm>
-            <a:off x="10239038" y="128016"/>
-            <a:ext cx="422596" cy="384048"/>
+        </p:nvSpPr>
+        <p:spPr>
+          <a:xfrm>
+            <a:off x="640080" y="2468880"/>
+            <a:ext cx="109728" cy="1280160"/>
           </a:xfrm>
           <a:prstGeom prst="rect">
             <a:avLst/>
           </a:prstGeom>
-        </p:spPr>
-      </p:pic>
+          <a:solidFill>
+            <a:srgbClr val="C8963E"/>
+          </a:solidFill>
+          <a:ln>
+            <a:noFill/>
+          </a:ln>
+        </p:spPr>
+        <p:style>
+          <a:lnRef idx="1">
+            <a:schemeClr val="accent1"/>
+          </a:lnRef>
+          <a:fillRef idx="3">
+            <a:schemeClr val="accent1"/>
+          </a:fillRef>
+          <a:effectRef idx="2">
+            <a:schemeClr val="accent1"/>
+          </a:effectRef>
+          <a:fontRef idx="minor">
+            <a:schemeClr val="lt1"/>
+          </a:fontRef>
+        </p:style>
+        <p:txBody>
+          <a:bodyPr rtlCol="0" anchor="ctr"/>
+          <a:lstStyle/>
+          <a:p>
+            <a:pPr algn="ctr"/>
+          </a:p>
+        </p:txBody>
+      </p:sp>
+      <p:sp>
+        <p:nvSpPr>
+          <p:cNvPr id="7" name="TextBox 6"/>
+          <p:cNvSpPr txBox="1"/>
+          <p:nvPr/>
+        </p:nvSpPr>
+        <p:spPr>
+          <a:xfrm>
+            <a:off x="960120" y="2377440"/>
+            <a:ext cx="10058400" cy="1463040"/>
+          </a:xfrm>
+          <a:prstGeom prst="rect">
+            <a:avLst/>
+          </a:prstGeom>
+          <a:noFill/>
+        </p:spPr>
+        <p:txBody>
+          <a:bodyPr wrap="square" lIns="0" rIns="0" tIns="0" bIns="0" anchor="t">
+            <a:spAutoFit/>
+          </a:bodyPr>
+          <a:lstStyle/>
+          <a:p>
+            <a:pPr algn="l"/>
+            <a:r>
+              <a:rPr sz="4000" b="1" i="0">
+                <a:solidFill>
+                  <a:srgbClr val="1F1F1F"/>
+                </a:solidFill>
+                <a:latin typeface="Calibri"/>
+              </a:rPr>
+              <a:t>Talk Title Goes Here</a:t>
+            </a:r>
+          </a:p>
+        </p:txBody>
+      </p:sp>
+      <p:sp>
+        <p:nvSpPr>
+          <p:cNvPr id="8" name="TextBox 7"/>
+          <p:cNvSpPr txBox="1"/>
+          <p:nvPr/>
+        </p:nvSpPr>
+        <p:spPr>
+          <a:xfrm>
+            <a:off x="960120" y="3749040"/>
+            <a:ext cx="10058400" cy="548640"/>
+          </a:xfrm>
+          <a:prstGeom prst="rect">
+            <a:avLst/>
+          </a:prstGeom>
+          <a:noFill/>
+        </p:spPr>
+        <p:txBody>
+          <a:bodyPr wrap="square" lIns="0" rIns="0" tIns="0" bIns="0" anchor="t">
+            <a:spAutoFit/>
+          </a:bodyPr>
+          <a:lstStyle/>
+          <a:p>
+            <a:pPr algn="l"/>
+            <a:r>
+              <a:rPr sz="1800" b="0" i="1">
+                <a:solidFill>
+                  <a:srgbClr val="707070"/>
+                </a:solidFill>
+                <a:latin typeface="Calibri"/>
+              </a:rPr>
+              <a:t>A concise subtitle or one-line abstract</a:t>
+            </a:r>
+          </a:p>
+        </p:txBody>
+      </p:sp>
       <p:cxnSp>
         <p:nvCxnSpPr>
-          <p:cNvPr id="7" name="Connector 6"/>
+          <p:cNvPr id="9" name="Connector 8"/>
           <p:cNvCxnSpPr/>
           <p:nvPr/>
         </p:nvCxnSpPr>
         <p:spPr>
           <a:xfrm>
-            <a:off x="10743930" y="182880"/>
-            <a:ext cx="0" cy="274320"/>
+            <a:off x="960120" y="4480560"/>
+            <a:ext cx="1691640" cy="0"/>
           </a:xfrm>
           <a:prstGeom prst="line">
             <a:avLst/>
           </a:prstGeom>
-          <a:ln w="4000">
+          <a:ln w="19050">
             <a:solidFill>
-              <a:srgbClr val="8A6A2E"/>
+              <a:srgbClr val="C8963E"/>
             </a:solidFill>
           </a:ln>
         </p:spPr>
@@ -3258,65 +3347,6 @@
           </a:fontRef>
         </p:style>
       </p:cxnSp>
-      <p:pic>
-        <p:nvPicPr>
-          <p:cNvPr id="8" name="Picture 7" descr="Alan.png"/>
-          <p:cNvPicPr>
-            <a:picLocks noChangeAspect="1"/>
-          </p:cNvPicPr>
-          <p:nvPr/>
-        </p:nvPicPr>
-        <p:blipFill>
-          <a:blip r:embed="rId6"/>
-          <a:stretch>
-            <a:fillRect/>
-          </a:stretch>
-        </p:blipFill>
-        <p:spPr>
-          <a:xfrm>
-            <a:off x="10826226" y="128016"/>
-            <a:ext cx="908270" cy="384048"/>
-          </a:xfrm>
-          <a:prstGeom prst="rect">
-            <a:avLst/>
-          </a:prstGeom>
-        </p:spPr>
-      </p:pic>
-      <p:cxnSp>
-        <p:nvCxnSpPr>
-          <p:cNvPr id="9" name="Connector 8"/>
-          <p:cNvCxnSpPr/>
-          <p:nvPr/>
-        </p:nvCxnSpPr>
-        <p:spPr>
-          <a:xfrm>
-            <a:off x="457200" y="667512"/>
-            <a:ext cx="11277295" cy="0"/>
-          </a:xfrm>
-          <a:prstGeom prst="line">
-            <a:avLst/>
-          </a:prstGeom>
-          <a:ln w="9525">
-            <a:solidFill>
-              <a:srgbClr val="C8963E"/>
-            </a:solidFill>
-          </a:ln>
-        </p:spPr>
-        <p:style>
-          <a:lnRef idx="2">
-            <a:schemeClr val="accent1"/>
-          </a:lnRef>
-          <a:fillRef idx="0">
-            <a:schemeClr val="accent1"/>
-          </a:fillRef>
-          <a:effectRef idx="1">
-            <a:schemeClr val="accent1"/>
-          </a:effectRef>
-          <a:fontRef idx="minor">
-            <a:schemeClr val="tx1"/>
-          </a:fontRef>
-        </p:style>
-      </p:cxnSp>
       <p:sp>
         <p:nvSpPr>
           <p:cNvPr id="10" name="TextBox 9"/>
@@ -3325,8 +3355,8 @@
         </p:nvSpPr>
         <p:spPr>
           <a:xfrm>
-            <a:off x="640080" y="2011680"/>
-            <a:ext cx="7315200" cy="365760"/>
+            <a:off x="960120" y="4617720"/>
+            <a:ext cx="10058400" cy="365760"/>
           </a:xfrm>
           <a:prstGeom prst="rect">
             <a:avLst/>
@@ -3341,149 +3371,9 @@
           <a:p>
             <a:pPr algn="l"/>
             <a:r>
-              <a:rPr sz="1400" b="1" i="1">
-                <a:solidFill>
-                  <a:srgbClr val="8A6A2E"/>
-                </a:solidFill>
-                <a:latin typeface="Calibri"/>
-              </a:rPr>
-              <a:t>KCL NLP  ·  Research Talk</a:t>
-            </a:r>
-          </a:p>
-        </p:txBody>
-      </p:sp>
-      <p:sp>
-        <p:nvSpPr>
-          <p:cNvPr id="11" name="TextBox 10"/>
-          <p:cNvSpPr txBox="1"/>
-          <p:nvPr/>
-        </p:nvSpPr>
-        <p:spPr>
-          <a:xfrm>
-            <a:off x="640080" y="2468880"/>
-            <a:ext cx="9144000" cy="1463040"/>
-          </a:xfrm>
-          <a:prstGeom prst="rect">
-            <a:avLst/>
-          </a:prstGeom>
-          <a:noFill/>
-        </p:spPr>
-        <p:txBody>
-          <a:bodyPr wrap="square" lIns="0" rIns="0" tIns="0" bIns="0" anchor="t">
-            <a:spAutoFit/>
-          </a:bodyPr>
-          <a:lstStyle/>
-          <a:p>
-            <a:pPr algn="l"/>
-            <a:r>
-              <a:rPr sz="4400" b="1" i="0">
-                <a:solidFill>
-                  <a:srgbClr val="2B1F12"/>
-                </a:solidFill>
-                <a:latin typeface="Georgia"/>
-              </a:rPr>
-              <a:t>Talk Title Goes Here</a:t>
-            </a:r>
-          </a:p>
-        </p:txBody>
-      </p:sp>
-      <p:sp>
-        <p:nvSpPr>
-          <p:cNvPr id="12" name="TextBox 11"/>
-          <p:cNvSpPr txBox="1"/>
-          <p:nvPr/>
-        </p:nvSpPr>
-        <p:spPr>
-          <a:xfrm>
-            <a:off x="640080" y="3840480"/>
-            <a:ext cx="9144000" cy="548640"/>
-          </a:xfrm>
-          <a:prstGeom prst="rect">
-            <a:avLst/>
-          </a:prstGeom>
-          <a:noFill/>
-        </p:spPr>
-        <p:txBody>
-          <a:bodyPr wrap="square" lIns="0" rIns="0" tIns="0" bIns="0" anchor="t">
-            <a:spAutoFit/>
-          </a:bodyPr>
-          <a:lstStyle/>
-          <a:p>
-            <a:pPr algn="l"/>
-            <a:r>
-              <a:rPr sz="2000" b="0" i="1">
-                <a:solidFill>
-                  <a:srgbClr val="6E5A3C"/>
-                </a:solidFill>
-                <a:latin typeface="Georgia"/>
-              </a:rPr>
-              <a:t>A concise subtitle or one-line abstract</a:t>
-            </a:r>
-          </a:p>
-        </p:txBody>
-      </p:sp>
-      <p:cxnSp>
-        <p:nvCxnSpPr>
-          <p:cNvPr id="13" name="Connector 12"/>
-          <p:cNvCxnSpPr/>
-          <p:nvPr/>
-        </p:nvCxnSpPr>
-        <p:spPr>
-          <a:xfrm>
-            <a:off x="640080" y="4663440"/>
-            <a:ext cx="1645920" cy="0"/>
-          </a:xfrm>
-          <a:prstGeom prst="line">
-            <a:avLst/>
-          </a:prstGeom>
-          <a:ln w="19050">
-            <a:solidFill>
-              <a:srgbClr val="C8963E"/>
-            </a:solidFill>
-          </a:ln>
-        </p:spPr>
-        <p:style>
-          <a:lnRef idx="2">
-            <a:schemeClr val="accent1"/>
-          </a:lnRef>
-          <a:fillRef idx="0">
-            <a:schemeClr val="accent1"/>
-          </a:fillRef>
-          <a:effectRef idx="1">
-            <a:schemeClr val="accent1"/>
-          </a:effectRef>
-          <a:fontRef idx="minor">
-            <a:schemeClr val="tx1"/>
-          </a:fontRef>
-        </p:style>
-      </p:cxnSp>
-      <p:sp>
-        <p:nvSpPr>
-          <p:cNvPr id="14" name="TextBox 13"/>
-          <p:cNvSpPr txBox="1"/>
-          <p:nvPr/>
-        </p:nvSpPr>
-        <p:spPr>
-          <a:xfrm>
-            <a:off x="640080" y="4754880"/>
-            <a:ext cx="9144000" cy="365760"/>
-          </a:xfrm>
-          <a:prstGeom prst="rect">
-            <a:avLst/>
-          </a:prstGeom>
-          <a:noFill/>
-        </p:spPr>
-        <p:txBody>
-          <a:bodyPr wrap="square" lIns="0" rIns="0" tIns="0" bIns="0" anchor="t">
-            <a:spAutoFit/>
-          </a:bodyPr>
-          <a:lstStyle/>
-          <a:p>
-            <a:pPr algn="l"/>
-            <a:r>
               <a:rPr sz="1400" b="0" i="0">
                 <a:solidFill>
-                  <a:srgbClr val="2B1F12"/>
+                  <a:srgbClr val="1F1F1F"/>
                 </a:solidFill>
                 <a:latin typeface="Calibri"/>
               </a:rPr>
@@ -3512,7 +3402,7 @@
       <p:grpSpPr/>
       <p:pic>
         <p:nvPicPr>
-          <p:cNvPr id="2" name="Picture 1" descr="parchment_bg.png"/>
+          <p:cNvPr id="2" name="Picture 1" descr="KCL.png"/>
           <p:cNvPicPr>
             <a:picLocks noChangeAspect="1"/>
           </p:cNvPicPr>
@@ -3526,8 +3416,8 @@
         </p:blipFill>
         <p:spPr>
           <a:xfrm>
-            <a:off x="0" y="0"/>
-            <a:ext cx="12191695" cy="6858000"/>
+            <a:off x="9111763" y="201168"/>
+            <a:ext cx="831046" cy="411480"/>
           </a:xfrm>
           <a:prstGeom prst="rect">
             <a:avLst/>
@@ -3536,7 +3426,7 @@
       </p:pic>
       <p:pic>
         <p:nvPicPr>
-          <p:cNvPr id="3" name="Picture 2" descr="tree_branch.png"/>
+          <p:cNvPr id="3" name="Picture 2" descr="KCLNLP.png"/>
           <p:cNvPicPr>
             <a:picLocks noChangeAspect="1"/>
           </p:cNvPicPr>
@@ -3550,8 +3440,8 @@
         </p:blipFill>
         <p:spPr>
           <a:xfrm>
-            <a:off x="-274320" y="2240280"/>
-            <a:ext cx="6400800" cy="4800600"/>
+            <a:off x="10125688" y="201168"/>
+            <a:ext cx="452782" cy="411480"/>
           </a:xfrm>
           <a:prstGeom prst="rect">
             <a:avLst/>
@@ -3560,7 +3450,7 @@
       </p:pic>
       <p:pic>
         <p:nvPicPr>
-          <p:cNvPr id="4" name="Picture 3" descr="KCL.png"/>
+          <p:cNvPr id="4" name="Picture 3" descr="Alan.png"/>
           <p:cNvPicPr>
             <a:picLocks noChangeAspect="1"/>
           </p:cNvPicPr>
@@ -3574,8 +3464,8 @@
         </p:blipFill>
         <p:spPr>
           <a:xfrm>
-            <a:off x="9298804" y="128016"/>
-            <a:ext cx="775643" cy="384048"/>
+            <a:off x="10761349" y="201168"/>
+            <a:ext cx="973146" cy="411480"/>
           </a:xfrm>
           <a:prstGeom prst="rect">
             <a:avLst/>
@@ -3590,15 +3480,15 @@
         </p:nvCxnSpPr>
         <p:spPr>
           <a:xfrm>
-            <a:off x="10156742" y="182880"/>
-            <a:ext cx="0" cy="274320"/>
+            <a:off x="457200" y="777240"/>
+            <a:ext cx="11277295" cy="0"/>
           </a:xfrm>
           <a:prstGeom prst="line">
             <a:avLst/>
           </a:prstGeom>
-          <a:ln w="4000">
+          <a:ln w="9525">
             <a:solidFill>
-              <a:srgbClr val="8A6A2E"/>
+              <a:srgbClr val="C8963E"/>
             </a:solidFill>
           </a:ln>
         </p:spPr>
@@ -3617,30 +3507,41 @@
           </a:fontRef>
         </p:style>
       </p:cxnSp>
-      <p:pic>
-        <p:nvPicPr>
-          <p:cNvPr id="6" name="Picture 5" descr="KCLNLP.png"/>
-          <p:cNvPicPr>
-            <a:picLocks noChangeAspect="1"/>
-          </p:cNvPicPr>
+      <p:sp>
+        <p:nvSpPr>
+          <p:cNvPr id="6" name="TextBox 5"/>
+          <p:cNvSpPr txBox="1"/>
           <p:nvPr/>
-        </p:nvPicPr>
-        <p:blipFill>
-          <a:blip r:embed="rId5"/>
-          <a:stretch>
-            <a:fillRect/>
-          </a:stretch>
-        </p:blipFill>
-        <p:spPr>
-          <a:xfrm>
-            <a:off x="10239038" y="128016"/>
-            <a:ext cx="422596" cy="384048"/>
+        </p:nvSpPr>
+        <p:spPr>
+          <a:xfrm>
+            <a:off x="914400" y="2743200"/>
+            <a:ext cx="1645920" cy="1097280"/>
           </a:xfrm>
           <a:prstGeom prst="rect">
             <a:avLst/>
           </a:prstGeom>
-        </p:spPr>
-      </p:pic>
+          <a:noFill/>
+        </p:spPr>
+        <p:txBody>
+          <a:bodyPr wrap="square" lIns="0" rIns="0" tIns="0" bIns="0" anchor="t">
+            <a:spAutoFit/>
+          </a:bodyPr>
+          <a:lstStyle/>
+          <a:p>
+            <a:pPr algn="l"/>
+            <a:r>
+              <a:rPr sz="5600" b="1" i="0">
+                <a:solidFill>
+                  <a:srgbClr val="C8963E"/>
+                </a:solidFill>
+                <a:latin typeface="Calibri"/>
+              </a:rPr>
+              <a:t>01</a:t>
+            </a:r>
+          </a:p>
+        </p:txBody>
+      </p:sp>
       <p:cxnSp>
         <p:nvCxnSpPr>
           <p:cNvPr id="7" name="Connector 6"/>
@@ -3649,15 +3550,15 @@
         </p:nvCxnSpPr>
         <p:spPr>
           <a:xfrm>
-            <a:off x="10743930" y="182880"/>
-            <a:ext cx="0" cy="274320"/>
+            <a:off x="2651760" y="2971800"/>
+            <a:ext cx="0" cy="822960"/>
           </a:xfrm>
           <a:prstGeom prst="line">
             <a:avLst/>
           </a:prstGeom>
-          <a:ln w="4000">
+          <a:ln w="12700">
             <a:solidFill>
-              <a:srgbClr val="8A6A2E"/>
+              <a:srgbClr val="C8963E"/>
             </a:solidFill>
           </a:ln>
         </p:spPr>
@@ -3676,75 +3577,16 @@
           </a:fontRef>
         </p:style>
       </p:cxnSp>
-      <p:pic>
-        <p:nvPicPr>
-          <p:cNvPr id="8" name="Picture 7" descr="Alan.png"/>
-          <p:cNvPicPr>
-            <a:picLocks noChangeAspect="1"/>
-          </p:cNvPicPr>
-          <p:nvPr/>
-        </p:nvPicPr>
-        <p:blipFill>
-          <a:blip r:embed="rId6"/>
-          <a:stretch>
-            <a:fillRect/>
-          </a:stretch>
-        </p:blipFill>
-        <p:spPr>
-          <a:xfrm>
-            <a:off x="10826226" y="128016"/>
-            <a:ext cx="908270" cy="384048"/>
-          </a:xfrm>
-          <a:prstGeom prst="rect">
-            <a:avLst/>
-          </a:prstGeom>
-        </p:spPr>
-      </p:pic>
-      <p:cxnSp>
-        <p:nvCxnSpPr>
-          <p:cNvPr id="9" name="Connector 8"/>
-          <p:cNvCxnSpPr/>
-          <p:nvPr/>
-        </p:nvCxnSpPr>
-        <p:spPr>
-          <a:xfrm>
-            <a:off x="457200" y="667512"/>
-            <a:ext cx="11277295" cy="0"/>
-          </a:xfrm>
-          <a:prstGeom prst="line">
-            <a:avLst/>
-          </a:prstGeom>
-          <a:ln w="9525">
-            <a:solidFill>
-              <a:srgbClr val="C8963E"/>
-            </a:solidFill>
-          </a:ln>
-        </p:spPr>
-        <p:style>
-          <a:lnRef idx="2">
-            <a:schemeClr val="accent1"/>
-          </a:lnRef>
-          <a:fillRef idx="0">
-            <a:schemeClr val="accent1"/>
-          </a:fillRef>
-          <a:effectRef idx="1">
-            <a:schemeClr val="accent1"/>
-          </a:effectRef>
-          <a:fontRef idx="minor">
-            <a:schemeClr val="tx1"/>
-          </a:fontRef>
-        </p:style>
-      </p:cxnSp>
-      <p:sp>
-        <p:nvSpPr>
-          <p:cNvPr id="10" name="TextBox 9"/>
+      <p:sp>
+        <p:nvSpPr>
+          <p:cNvPr id="8" name="TextBox 7"/>
           <p:cNvSpPr txBox="1"/>
           <p:nvPr/>
         </p:nvSpPr>
         <p:spPr>
           <a:xfrm>
-            <a:off x="3931920" y="2468880"/>
-            <a:ext cx="1463040" cy="914400"/>
+            <a:off x="2926080" y="2926080"/>
+            <a:ext cx="7315200" cy="914400"/>
           </a:xfrm>
           <a:prstGeom prst="rect">
             <a:avLst/>
@@ -3759,62 +3601,27 @@
           <a:p>
             <a:pPr algn="l"/>
             <a:r>
-              <a:rPr sz="6400" b="1" i="0">
+              <a:rPr sz="3400" b="1" i="0">
                 <a:solidFill>
-                  <a:srgbClr val="C8963E"/>
+                  <a:srgbClr val="1F1F1F"/>
                 </a:solidFill>
-                <a:latin typeface="Georgia"/>
+                <a:latin typeface="Calibri"/>
               </a:rPr>
-              <a:t>01</a:t>
-            </a:r>
-          </a:p>
-        </p:txBody>
-      </p:sp>
-      <p:cxnSp>
-        <p:nvCxnSpPr>
-          <p:cNvPr id="11" name="Connector 10"/>
-          <p:cNvCxnSpPr/>
-          <p:nvPr/>
-        </p:nvCxnSpPr>
-        <p:spPr>
-          <a:xfrm>
-            <a:off x="5486400" y="2880360"/>
-            <a:ext cx="0" cy="1280160"/>
-          </a:xfrm>
-          <a:prstGeom prst="line">
-            <a:avLst/>
-          </a:prstGeom>
-          <a:ln w="12700">
-            <a:solidFill>
-              <a:srgbClr val="8A6A2E"/>
-            </a:solidFill>
-          </a:ln>
-        </p:spPr>
-        <p:style>
-          <a:lnRef idx="2">
-            <a:schemeClr val="accent1"/>
-          </a:lnRef>
-          <a:fillRef idx="0">
-            <a:schemeClr val="accent1"/>
-          </a:fillRef>
-          <a:effectRef idx="1">
-            <a:schemeClr val="accent1"/>
-          </a:effectRef>
-          <a:fontRef idx="minor">
-            <a:schemeClr val="tx1"/>
-          </a:fontRef>
-        </p:style>
-      </p:cxnSp>
-      <p:sp>
-        <p:nvSpPr>
-          <p:cNvPr id="12" name="TextBox 11"/>
+              <a:t>Motivation</a:t>
+            </a:r>
+          </a:p>
+        </p:txBody>
+      </p:sp>
+      <p:sp>
+        <p:nvSpPr>
+          <p:cNvPr id="9" name="TextBox 8"/>
           <p:cNvSpPr txBox="1"/>
           <p:nvPr/>
         </p:nvSpPr>
         <p:spPr>
           <a:xfrm>
-            <a:off x="5760720" y="2697480"/>
-            <a:ext cx="6858000" cy="1188720"/>
+            <a:off x="2926080" y="3703320"/>
+            <a:ext cx="7315200" cy="365760"/>
           </a:xfrm>
           <a:prstGeom prst="rect">
             <a:avLst/>
@@ -3829,44 +3636,9 @@
           <a:p>
             <a:pPr algn="l"/>
             <a:r>
-              <a:rPr sz="3600" b="1" i="0">
-                <a:solidFill>
-                  <a:srgbClr val="2B1F12"/>
-                </a:solidFill>
-                <a:latin typeface="Georgia"/>
-              </a:rPr>
-              <a:t>Motivation</a:t>
-            </a:r>
-          </a:p>
-        </p:txBody>
-      </p:sp>
-      <p:sp>
-        <p:nvSpPr>
-          <p:cNvPr id="13" name="TextBox 12"/>
-          <p:cNvSpPr txBox="1"/>
-          <p:nvPr/>
-        </p:nvSpPr>
-        <p:spPr>
-          <a:xfrm>
-            <a:off x="5760720" y="3657600"/>
-            <a:ext cx="6858000" cy="457200"/>
-          </a:xfrm>
-          <a:prstGeom prst="rect">
-            <a:avLst/>
-          </a:prstGeom>
-          <a:noFill/>
-        </p:spPr>
-        <p:txBody>
-          <a:bodyPr wrap="square" lIns="0" rIns="0" tIns="0" bIns="0" anchor="t">
-            <a:spAutoFit/>
-          </a:bodyPr>
-          <a:lstStyle/>
-          <a:p>
-            <a:pPr algn="l"/>
-            <a:r>
               <a:rPr sz="1400" b="0" i="1">
                 <a:solidFill>
-                  <a:srgbClr val="6E5A3C"/>
+                  <a:srgbClr val="707070"/>
                 </a:solidFill>
                 <a:latin typeface="Calibri"/>
               </a:rPr>
@@ -3895,7 +3667,7 @@
       <p:grpSpPr/>
       <p:pic>
         <p:nvPicPr>
-          <p:cNvPr id="2" name="Picture 1" descr="parchment_bg.png"/>
+          <p:cNvPr id="2" name="Picture 1" descr="KCL.png"/>
           <p:cNvPicPr>
             <a:picLocks noChangeAspect="1"/>
           </p:cNvPicPr>
@@ -3909,8 +3681,8 @@
         </p:blipFill>
         <p:spPr>
           <a:xfrm>
-            <a:off x="0" y="0"/>
-            <a:ext cx="12191695" cy="6858000"/>
+            <a:off x="9111763" y="201168"/>
+            <a:ext cx="831046" cy="411480"/>
           </a:xfrm>
           <a:prstGeom prst="rect">
             <a:avLst/>
@@ -3919,7 +3691,7 @@
       </p:pic>
       <p:pic>
         <p:nvPicPr>
-          <p:cNvPr id="3" name="Picture 2" descr="KCL.png"/>
+          <p:cNvPr id="3" name="Picture 2" descr="KCLNLP.png"/>
           <p:cNvPicPr>
             <a:picLocks noChangeAspect="1"/>
           </p:cNvPicPr>
@@ -3933,31 +3705,55 @@
         </p:blipFill>
         <p:spPr>
           <a:xfrm>
-            <a:off x="9298804" y="128016"/>
-            <a:ext cx="775643" cy="384048"/>
+            <a:off x="10125688" y="201168"/>
+            <a:ext cx="452782" cy="411480"/>
           </a:xfrm>
           <a:prstGeom prst="rect">
             <a:avLst/>
           </a:prstGeom>
         </p:spPr>
       </p:pic>
+      <p:pic>
+        <p:nvPicPr>
+          <p:cNvPr id="4" name="Picture 3" descr="Alan.png"/>
+          <p:cNvPicPr>
+            <a:picLocks noChangeAspect="1"/>
+          </p:cNvPicPr>
+          <p:nvPr/>
+        </p:nvPicPr>
+        <p:blipFill>
+          <a:blip r:embed="rId4"/>
+          <a:stretch>
+            <a:fillRect/>
+          </a:stretch>
+        </p:blipFill>
+        <p:spPr>
+          <a:xfrm>
+            <a:off x="10761349" y="201168"/>
+            <a:ext cx="973146" cy="411480"/>
+          </a:xfrm>
+          <a:prstGeom prst="rect">
+            <a:avLst/>
+          </a:prstGeom>
+        </p:spPr>
+      </p:pic>
       <p:cxnSp>
         <p:nvCxnSpPr>
-          <p:cNvPr id="4" name="Connector 3"/>
+          <p:cNvPr id="5" name="Connector 4"/>
           <p:cNvCxnSpPr/>
           <p:nvPr/>
         </p:nvCxnSpPr>
         <p:spPr>
           <a:xfrm>
-            <a:off x="10156742" y="182880"/>
-            <a:ext cx="0" cy="274320"/>
+            <a:off x="457200" y="777240"/>
+            <a:ext cx="11277295" cy="0"/>
           </a:xfrm>
           <a:prstGeom prst="line">
             <a:avLst/>
           </a:prstGeom>
-          <a:ln w="4000">
+          <a:ln w="9525">
             <a:solidFill>
-              <a:srgbClr val="8A6A2E"/>
+              <a:srgbClr val="C8963E"/>
             </a:solidFill>
           </a:ln>
         </p:spPr>
@@ -3976,47 +3772,101 @@
           </a:fontRef>
         </p:style>
       </p:cxnSp>
-      <p:pic>
-        <p:nvPicPr>
-          <p:cNvPr id="5" name="Picture 4" descr="KCLNLP.png"/>
-          <p:cNvPicPr>
-            <a:picLocks noChangeAspect="1"/>
-          </p:cNvPicPr>
+      <p:sp>
+        <p:nvSpPr>
+          <p:cNvPr id="6" name="Rectangle 5"/>
+          <p:cNvSpPr/>
           <p:nvPr/>
-        </p:nvPicPr>
-        <p:blipFill>
-          <a:blip r:embed="rId4"/>
-          <a:stretch>
-            <a:fillRect/>
-          </a:stretch>
-        </p:blipFill>
-        <p:spPr>
-          <a:xfrm>
-            <a:off x="10239038" y="128016"/>
-            <a:ext cx="422596" cy="384048"/>
+        </p:nvSpPr>
+        <p:spPr>
+          <a:xfrm>
+            <a:off x="548640" y="1078992"/>
+            <a:ext cx="109728" cy="640080"/>
           </a:xfrm>
           <a:prstGeom prst="rect">
             <a:avLst/>
           </a:prstGeom>
-        </p:spPr>
-      </p:pic>
+          <a:solidFill>
+            <a:srgbClr val="C8963E"/>
+          </a:solidFill>
+          <a:ln>
+            <a:noFill/>
+          </a:ln>
+        </p:spPr>
+        <p:style>
+          <a:lnRef idx="1">
+            <a:schemeClr val="accent1"/>
+          </a:lnRef>
+          <a:fillRef idx="3">
+            <a:schemeClr val="accent1"/>
+          </a:fillRef>
+          <a:effectRef idx="2">
+            <a:schemeClr val="accent1"/>
+          </a:effectRef>
+          <a:fontRef idx="minor">
+            <a:schemeClr val="lt1"/>
+          </a:fontRef>
+        </p:style>
+        <p:txBody>
+          <a:bodyPr rtlCol="0" anchor="ctr"/>
+          <a:lstStyle/>
+          <a:p>
+            <a:pPr algn="ctr"/>
+          </a:p>
+        </p:txBody>
+      </p:sp>
+      <p:sp>
+        <p:nvSpPr>
+          <p:cNvPr id="7" name="TextBox 6"/>
+          <p:cNvSpPr txBox="1"/>
+          <p:nvPr/>
+        </p:nvSpPr>
+        <p:spPr>
+          <a:xfrm>
+            <a:off x="822960" y="1005840"/>
+            <a:ext cx="10058400" cy="822960"/>
+          </a:xfrm>
+          <a:prstGeom prst="rect">
+            <a:avLst/>
+          </a:prstGeom>
+          <a:noFill/>
+        </p:spPr>
+        <p:txBody>
+          <a:bodyPr wrap="square" lIns="0" rIns="0" tIns="0" bIns="0" anchor="t">
+            <a:spAutoFit/>
+          </a:bodyPr>
+          <a:lstStyle/>
+          <a:p>
+            <a:pPr algn="l"/>
+            <a:r>
+              <a:rPr sz="2600" b="1" i="0">
+                <a:solidFill>
+                  <a:srgbClr val="1F1F1F"/>
+                </a:solidFill>
+                <a:latin typeface="Calibri"/>
+              </a:rPr>
+              <a:t>Slide title</a:t>
+            </a:r>
+          </a:p>
+        </p:txBody>
+      </p:sp>
       <p:cxnSp>
         <p:nvCxnSpPr>
-          <p:cNvPr id="6" name="Connector 5"/>
+          <p:cNvPr id="8" name="Connector 7"/>
           <p:cNvCxnSpPr/>
           <p:nvPr/>
         </p:nvCxnSpPr>
         <p:spPr>
           <a:xfrm>
-            <a:off x="10743930" y="182880"/>
-            <a:ext cx="0" cy="274320"/>
+            <a:off x="822960" y="1874520"/>
+            <a:ext cx="10911535" cy="0"/>
           </a:xfrm>
           <a:prstGeom prst="line">
             <a:avLst/>
           </a:prstGeom>
-          <a:ln w="4000">
+          <a:ln w="6350">
             <a:solidFill>
-              <a:srgbClr val="8A6A2E"/>
+              <a:srgbClr val="C8963E"/>
             </a:solidFill>
           </a:ln>
         </p:spPr>
@@ -4035,225 +3885,16 @@
           </a:fontRef>
         </p:style>
       </p:cxnSp>
-      <p:pic>
-        <p:nvPicPr>
-          <p:cNvPr id="7" name="Picture 6" descr="Alan.png"/>
-          <p:cNvPicPr>
-            <a:picLocks noChangeAspect="1"/>
-          </p:cNvPicPr>
-          <p:nvPr/>
-        </p:nvPicPr>
-        <p:blipFill>
-          <a:blip r:embed="rId5"/>
-          <a:stretch>
-            <a:fillRect/>
-          </a:stretch>
-        </p:blipFill>
-        <p:spPr>
-          <a:xfrm>
-            <a:off x="10826226" y="128016"/>
-            <a:ext cx="908270" cy="384048"/>
-          </a:xfrm>
-          <a:prstGeom prst="rect">
-            <a:avLst/>
-          </a:prstGeom>
-        </p:spPr>
-      </p:pic>
-      <p:cxnSp>
-        <p:nvCxnSpPr>
-          <p:cNvPr id="8" name="Connector 7"/>
-          <p:cNvCxnSpPr/>
-          <p:nvPr/>
-        </p:nvCxnSpPr>
-        <p:spPr>
-          <a:xfrm>
-            <a:off x="457200" y="667512"/>
-            <a:ext cx="11277295" cy="0"/>
-          </a:xfrm>
-          <a:prstGeom prst="line">
-            <a:avLst/>
-          </a:prstGeom>
-          <a:ln w="9525">
-            <a:solidFill>
-              <a:srgbClr val="C8963E"/>
-            </a:solidFill>
-          </a:ln>
-        </p:spPr>
-        <p:style>
-          <a:lnRef idx="2">
-            <a:schemeClr val="accent1"/>
-          </a:lnRef>
-          <a:fillRef idx="0">
-            <a:schemeClr val="accent1"/>
-          </a:fillRef>
-          <a:effectRef idx="1">
-            <a:schemeClr val="accent1"/>
-          </a:effectRef>
-          <a:fontRef idx="minor">
-            <a:schemeClr val="tx1"/>
-          </a:fontRef>
-        </p:style>
-      </p:cxnSp>
-      <p:cxnSp>
-        <p:nvCxnSpPr>
-          <p:cNvPr id="9" name="Connector 8"/>
-          <p:cNvCxnSpPr/>
-          <p:nvPr/>
-        </p:nvCxnSpPr>
-        <p:spPr>
-          <a:xfrm>
-            <a:off x="347472" y="868680"/>
-            <a:ext cx="0" cy="5532120"/>
-          </a:xfrm>
-          <a:prstGeom prst="line">
-            <a:avLst/>
-          </a:prstGeom>
-          <a:ln w="12700">
-            <a:solidFill>
-              <a:srgbClr val="C8963E"/>
-            </a:solidFill>
-          </a:ln>
-        </p:spPr>
-        <p:style>
-          <a:lnRef idx="2">
-            <a:schemeClr val="accent1"/>
-          </a:lnRef>
-          <a:fillRef idx="0">
-            <a:schemeClr val="accent1"/>
-          </a:fillRef>
-          <a:effectRef idx="1">
-            <a:schemeClr val="accent1"/>
-          </a:effectRef>
-          <a:fontRef idx="minor">
-            <a:schemeClr val="tx1"/>
-          </a:fontRef>
-        </p:style>
-      </p:cxnSp>
-      <p:sp>
-        <p:nvSpPr>
-          <p:cNvPr id="10" name="Oval 9"/>
-          <p:cNvSpPr/>
-          <p:nvPr/>
-        </p:nvSpPr>
-        <p:spPr>
-          <a:xfrm rot="1500000">
-            <a:off x="274320" y="3552444"/>
-            <a:ext cx="146304" cy="201168"/>
-          </a:xfrm>
-          <a:prstGeom prst="ellipse">
-            <a:avLst/>
-          </a:prstGeom>
-          <a:solidFill>
-            <a:srgbClr val="6B7A3E"/>
-          </a:solidFill>
-          <a:ln w="4000">
-            <a:solidFill>
-              <a:srgbClr val="8A6A2E"/>
-            </a:solidFill>
-          </a:ln>
-        </p:spPr>
-        <p:style>
-          <a:lnRef idx="1">
-            <a:schemeClr val="accent1"/>
-          </a:lnRef>
-          <a:fillRef idx="3">
-            <a:schemeClr val="accent1"/>
-          </a:fillRef>
-          <a:effectRef idx="2">
-            <a:schemeClr val="accent1"/>
-          </a:effectRef>
-          <a:fontRef idx="minor">
-            <a:schemeClr val="lt1"/>
-          </a:fontRef>
-        </p:style>
-        <p:txBody>
-          <a:bodyPr rtlCol="0" anchor="ctr"/>
-          <a:lstStyle/>
-          <a:p>
-            <a:pPr algn="ctr"/>
-          </a:p>
-        </p:txBody>
-      </p:sp>
-      <p:sp>
-        <p:nvSpPr>
-          <p:cNvPr id="11" name="TextBox 10"/>
+      <p:sp>
+        <p:nvSpPr>
+          <p:cNvPr id="9" name="TextBox 8"/>
           <p:cNvSpPr txBox="1"/>
           <p:nvPr/>
         </p:nvSpPr>
         <p:spPr>
           <a:xfrm>
-            <a:off x="731520" y="914400"/>
-            <a:ext cx="10058400" cy="822960"/>
-          </a:xfrm>
-          <a:prstGeom prst="rect">
-            <a:avLst/>
-          </a:prstGeom>
-          <a:noFill/>
-        </p:spPr>
-        <p:txBody>
-          <a:bodyPr wrap="square" lIns="0" rIns="0" tIns="0" bIns="0" anchor="t">
-            <a:spAutoFit/>
-          </a:bodyPr>
-          <a:lstStyle/>
-          <a:p>
-            <a:pPr algn="l"/>
-            <a:r>
-              <a:rPr sz="2800" b="1" i="0">
-                <a:solidFill>
-                  <a:srgbClr val="2B1F12"/>
-                </a:solidFill>
-                <a:latin typeface="Georgia"/>
-              </a:rPr>
-              <a:t>Slide title</a:t>
-            </a:r>
-          </a:p>
-        </p:txBody>
-      </p:sp>
-      <p:cxnSp>
-        <p:nvCxnSpPr>
-          <p:cNvPr id="12" name="Connector 11"/>
-          <p:cNvCxnSpPr/>
-          <p:nvPr/>
-        </p:nvCxnSpPr>
-        <p:spPr>
-          <a:xfrm>
-            <a:off x="731520" y="1691640"/>
-            <a:ext cx="822960" cy="0"/>
-          </a:xfrm>
-          <a:prstGeom prst="line">
-            <a:avLst/>
-          </a:prstGeom>
-          <a:ln w="12700">
-            <a:solidFill>
-              <a:srgbClr val="C8963E"/>
-            </a:solidFill>
-          </a:ln>
-        </p:spPr>
-        <p:style>
-          <a:lnRef idx="2">
-            <a:schemeClr val="accent1"/>
-          </a:lnRef>
-          <a:fillRef idx="0">
-            <a:schemeClr val="accent1"/>
-          </a:fillRef>
-          <a:effectRef idx="1">
-            <a:schemeClr val="accent1"/>
-          </a:effectRef>
-          <a:fontRef idx="minor">
-            <a:schemeClr val="tx1"/>
-          </a:fontRef>
-        </p:style>
-      </p:cxnSp>
-      <p:sp>
-        <p:nvSpPr>
-          <p:cNvPr id="13" name="TextBox 12"/>
-          <p:cNvSpPr txBox="1"/>
-          <p:nvPr/>
-        </p:nvSpPr>
-        <p:spPr>
-          <a:xfrm>
-            <a:off x="731520" y="1965960"/>
-            <a:ext cx="10698480" cy="4206240"/>
+            <a:off x="822960" y="2148840"/>
+            <a:ext cx="10972800" cy="4206240"/>
           </a:xfrm>
           <a:prstGeom prst="rect">
             <a:avLst/>
@@ -4274,7 +3915,7 @@
             <a:r>
               <a:rPr sz="1800">
                 <a:solidFill>
-                  <a:srgbClr val="2B1F12"/>
+                  <a:srgbClr val="1F1F1F"/>
                 </a:solidFill>
                 <a:latin typeface="Calibri"/>
               </a:rPr>
@@ -4290,7 +3931,7 @@
             <a:r>
               <a:rPr sz="1800">
                 <a:solidFill>
-                  <a:srgbClr val="2B1F12"/>
+                  <a:srgbClr val="1F1F1F"/>
                 </a:solidFill>
                 <a:latin typeface="Calibri"/>
               </a:rPr>
@@ -4306,7 +3947,7 @@
             <a:r>
               <a:rPr sz="1800">
                 <a:solidFill>
-                  <a:srgbClr val="2B1F12"/>
+                  <a:srgbClr val="1F1F1F"/>
                 </a:solidFill>
                 <a:latin typeface="Calibri"/>
               </a:rPr>
@@ -4322,7 +3963,7 @@
             <a:r>
               <a:rPr sz="1800">
                 <a:solidFill>
-                  <a:srgbClr val="2B1F12"/>
+                  <a:srgbClr val="1F1F1F"/>
                 </a:solidFill>
                 <a:latin typeface="Calibri"/>
               </a:rPr>
@@ -4333,14 +3974,14 @@
       </p:sp>
       <p:sp>
         <p:nvSpPr>
-          <p:cNvPr id="14" name="TextBox 13"/>
+          <p:cNvPr id="10" name="TextBox 9"/>
           <p:cNvSpPr txBox="1"/>
           <p:nvPr/>
         </p:nvSpPr>
         <p:spPr>
           <a:xfrm>
-            <a:off x="731520" y="6446520"/>
-            <a:ext cx="10698480" cy="274320"/>
+            <a:off x="822960" y="6492240"/>
+            <a:ext cx="10972800" cy="274320"/>
           </a:xfrm>
           <a:prstGeom prst="rect">
             <a:avLst/>
@@ -4357,7 +3998,7 @@
             <a:r>
               <a:rPr sz="1100" b="0" i="1">
                 <a:solidFill>
-                  <a:srgbClr val="6E5A3C"/>
+                  <a:srgbClr val="707070"/>
                 </a:solidFill>
                 <a:latin typeface="Calibri"/>
               </a:rPr>
@@ -4386,7 +4027,7 @@
       <p:grpSpPr/>
       <p:pic>
         <p:nvPicPr>
-          <p:cNvPr id="2" name="Picture 1" descr="parchment_bg.png"/>
+          <p:cNvPr id="2" name="Picture 1" descr="KCL.png"/>
           <p:cNvPicPr>
             <a:picLocks noChangeAspect="1"/>
           </p:cNvPicPr>
@@ -4400,8 +4041,8 @@
         </p:blipFill>
         <p:spPr>
           <a:xfrm>
-            <a:off x="0" y="0"/>
-            <a:ext cx="12191695" cy="6858000"/>
+            <a:off x="9111763" y="201168"/>
+            <a:ext cx="831046" cy="411480"/>
           </a:xfrm>
           <a:prstGeom prst="rect">
             <a:avLst/>
@@ -4410,7 +4051,7 @@
       </p:pic>
       <p:pic>
         <p:nvPicPr>
-          <p:cNvPr id="3" name="Picture 2" descr="KCL.png"/>
+          <p:cNvPr id="3" name="Picture 2" descr="KCLNLP.png"/>
           <p:cNvPicPr>
             <a:picLocks noChangeAspect="1"/>
           </p:cNvPicPr>
@@ -4424,31 +4065,55 @@
         </p:blipFill>
         <p:spPr>
           <a:xfrm>
-            <a:off x="9298804" y="128016"/>
-            <a:ext cx="775643" cy="384048"/>
+            <a:off x="10125688" y="201168"/>
+            <a:ext cx="452782" cy="411480"/>
           </a:xfrm>
           <a:prstGeom prst="rect">
             <a:avLst/>
           </a:prstGeom>
         </p:spPr>
       </p:pic>
+      <p:pic>
+        <p:nvPicPr>
+          <p:cNvPr id="4" name="Picture 3" descr="Alan.png"/>
+          <p:cNvPicPr>
+            <a:picLocks noChangeAspect="1"/>
+          </p:cNvPicPr>
+          <p:nvPr/>
+        </p:nvPicPr>
+        <p:blipFill>
+          <a:blip r:embed="rId4"/>
+          <a:stretch>
+            <a:fillRect/>
+          </a:stretch>
+        </p:blipFill>
+        <p:spPr>
+          <a:xfrm>
+            <a:off x="10761349" y="201168"/>
+            <a:ext cx="973146" cy="411480"/>
+          </a:xfrm>
+          <a:prstGeom prst="rect">
+            <a:avLst/>
+          </a:prstGeom>
+        </p:spPr>
+      </p:pic>
       <p:cxnSp>
         <p:nvCxnSpPr>
-          <p:cNvPr id="4" name="Connector 3"/>
+          <p:cNvPr id="5" name="Connector 4"/>
           <p:cNvCxnSpPr/>
           <p:nvPr/>
         </p:nvCxnSpPr>
         <p:spPr>
           <a:xfrm>
-            <a:off x="10156742" y="182880"/>
-            <a:ext cx="0" cy="274320"/>
+            <a:off x="457200" y="777240"/>
+            <a:ext cx="11277295" cy="0"/>
           </a:xfrm>
           <a:prstGeom prst="line">
             <a:avLst/>
           </a:prstGeom>
-          <a:ln w="4000">
+          <a:ln w="9525">
             <a:solidFill>
-              <a:srgbClr val="8A6A2E"/>
+              <a:srgbClr val="C8963E"/>
             </a:solidFill>
           </a:ln>
         </p:spPr>
@@ -4467,47 +4132,101 @@
           </a:fontRef>
         </p:style>
       </p:cxnSp>
-      <p:pic>
-        <p:nvPicPr>
-          <p:cNvPr id="5" name="Picture 4" descr="KCLNLP.png"/>
-          <p:cNvPicPr>
-            <a:picLocks noChangeAspect="1"/>
-          </p:cNvPicPr>
+      <p:sp>
+        <p:nvSpPr>
+          <p:cNvPr id="6" name="Rectangle 5"/>
+          <p:cNvSpPr/>
           <p:nvPr/>
-        </p:nvPicPr>
-        <p:blipFill>
-          <a:blip r:embed="rId4"/>
-          <a:stretch>
-            <a:fillRect/>
-          </a:stretch>
-        </p:blipFill>
-        <p:spPr>
-          <a:xfrm>
-            <a:off x="10239038" y="128016"/>
-            <a:ext cx="422596" cy="384048"/>
+        </p:nvSpPr>
+        <p:spPr>
+          <a:xfrm>
+            <a:off x="548640" y="1078992"/>
+            <a:ext cx="109728" cy="640080"/>
           </a:xfrm>
           <a:prstGeom prst="rect">
             <a:avLst/>
           </a:prstGeom>
-        </p:spPr>
-      </p:pic>
+          <a:solidFill>
+            <a:srgbClr val="C8963E"/>
+          </a:solidFill>
+          <a:ln>
+            <a:noFill/>
+          </a:ln>
+        </p:spPr>
+        <p:style>
+          <a:lnRef idx="1">
+            <a:schemeClr val="accent1"/>
+          </a:lnRef>
+          <a:fillRef idx="3">
+            <a:schemeClr val="accent1"/>
+          </a:fillRef>
+          <a:effectRef idx="2">
+            <a:schemeClr val="accent1"/>
+          </a:effectRef>
+          <a:fontRef idx="minor">
+            <a:schemeClr val="lt1"/>
+          </a:fontRef>
+        </p:style>
+        <p:txBody>
+          <a:bodyPr rtlCol="0" anchor="ctr"/>
+          <a:lstStyle/>
+          <a:p>
+            <a:pPr algn="ctr"/>
+          </a:p>
+        </p:txBody>
+      </p:sp>
+      <p:sp>
+        <p:nvSpPr>
+          <p:cNvPr id="7" name="TextBox 6"/>
+          <p:cNvSpPr txBox="1"/>
+          <p:nvPr/>
+        </p:nvSpPr>
+        <p:spPr>
+          <a:xfrm>
+            <a:off x="822960" y="1005840"/>
+            <a:ext cx="10058400" cy="822960"/>
+          </a:xfrm>
+          <a:prstGeom prst="rect">
+            <a:avLst/>
+          </a:prstGeom>
+          <a:noFill/>
+        </p:spPr>
+        <p:txBody>
+          <a:bodyPr wrap="square" lIns="0" rIns="0" tIns="0" bIns="0" anchor="t">
+            <a:spAutoFit/>
+          </a:bodyPr>
+          <a:lstStyle/>
+          <a:p>
+            <a:pPr algn="l"/>
+            <a:r>
+              <a:rPr sz="2600" b="1" i="0">
+                <a:solidFill>
+                  <a:srgbClr val="1F1F1F"/>
+                </a:solidFill>
+                <a:latin typeface="Calibri"/>
+              </a:rPr>
+              <a:t>Figure or image + text</a:t>
+            </a:r>
+          </a:p>
+        </p:txBody>
+      </p:sp>
       <p:cxnSp>
         <p:nvCxnSpPr>
-          <p:cNvPr id="6" name="Connector 5"/>
+          <p:cNvPr id="8" name="Connector 7"/>
           <p:cNvCxnSpPr/>
           <p:nvPr/>
         </p:nvCxnSpPr>
         <p:spPr>
           <a:xfrm>
-            <a:off x="10743930" y="182880"/>
-            <a:ext cx="0" cy="274320"/>
+            <a:off x="822960" y="1874520"/>
+            <a:ext cx="10911535" cy="0"/>
           </a:xfrm>
           <a:prstGeom prst="line">
             <a:avLst/>
           </a:prstGeom>
-          <a:ln w="4000">
+          <a:ln w="6350">
             <a:solidFill>
-              <a:srgbClr val="8A6A2E"/>
+              <a:srgbClr val="C8963E"/>
             </a:solidFill>
           </a:ln>
         </p:spPr>
@@ -4526,120 +4245,24 @@
           </a:fontRef>
         </p:style>
       </p:cxnSp>
-      <p:pic>
-        <p:nvPicPr>
-          <p:cNvPr id="7" name="Picture 6" descr="Alan.png"/>
-          <p:cNvPicPr>
-            <a:picLocks noChangeAspect="1"/>
-          </p:cNvPicPr>
+      <p:sp>
+        <p:nvSpPr>
+          <p:cNvPr id="9" name="Rectangle 8"/>
+          <p:cNvSpPr/>
           <p:nvPr/>
-        </p:nvPicPr>
-        <p:blipFill>
-          <a:blip r:embed="rId5"/>
-          <a:stretch>
-            <a:fillRect/>
-          </a:stretch>
-        </p:blipFill>
-        <p:spPr>
-          <a:xfrm>
-            <a:off x="10826226" y="128016"/>
-            <a:ext cx="908270" cy="384048"/>
+        </p:nvSpPr>
+        <p:spPr>
+          <a:xfrm>
+            <a:off x="822960" y="2148840"/>
+            <a:ext cx="5303520" cy="4114800"/>
           </a:xfrm>
           <a:prstGeom prst="rect">
             <a:avLst/>
           </a:prstGeom>
-        </p:spPr>
-      </p:pic>
-      <p:cxnSp>
-        <p:nvCxnSpPr>
-          <p:cNvPr id="8" name="Connector 7"/>
-          <p:cNvCxnSpPr/>
-          <p:nvPr/>
-        </p:nvCxnSpPr>
-        <p:spPr>
-          <a:xfrm>
-            <a:off x="457200" y="667512"/>
-            <a:ext cx="11277295" cy="0"/>
-          </a:xfrm>
-          <a:prstGeom prst="line">
-            <a:avLst/>
-          </a:prstGeom>
-          <a:ln w="9525">
+          <a:noFill/>
+          <a:ln w="6350">
             <a:solidFill>
-              <a:srgbClr val="C8963E"/>
-            </a:solidFill>
-          </a:ln>
-        </p:spPr>
-        <p:style>
-          <a:lnRef idx="2">
-            <a:schemeClr val="accent1"/>
-          </a:lnRef>
-          <a:fillRef idx="0">
-            <a:schemeClr val="accent1"/>
-          </a:fillRef>
-          <a:effectRef idx="1">
-            <a:schemeClr val="accent1"/>
-          </a:effectRef>
-          <a:fontRef idx="minor">
-            <a:schemeClr val="tx1"/>
-          </a:fontRef>
-        </p:style>
-      </p:cxnSp>
-      <p:cxnSp>
-        <p:nvCxnSpPr>
-          <p:cNvPr id="9" name="Connector 8"/>
-          <p:cNvCxnSpPr/>
-          <p:nvPr/>
-        </p:nvCxnSpPr>
-        <p:spPr>
-          <a:xfrm>
-            <a:off x="347472" y="868680"/>
-            <a:ext cx="0" cy="5532120"/>
-          </a:xfrm>
-          <a:prstGeom prst="line">
-            <a:avLst/>
-          </a:prstGeom>
-          <a:ln w="12700">
-            <a:solidFill>
-              <a:srgbClr val="C8963E"/>
-            </a:solidFill>
-          </a:ln>
-        </p:spPr>
-        <p:style>
-          <a:lnRef idx="2">
-            <a:schemeClr val="accent1"/>
-          </a:lnRef>
-          <a:fillRef idx="0">
-            <a:schemeClr val="accent1"/>
-          </a:fillRef>
-          <a:effectRef idx="1">
-            <a:schemeClr val="accent1"/>
-          </a:effectRef>
-          <a:fontRef idx="minor">
-            <a:schemeClr val="tx1"/>
-          </a:fontRef>
-        </p:style>
-      </p:cxnSp>
-      <p:sp>
-        <p:nvSpPr>
-          <p:cNvPr id="10" name="Oval 9"/>
-          <p:cNvSpPr/>
-          <p:nvPr/>
-        </p:nvSpPr>
-        <p:spPr>
-          <a:xfrm rot="1500000">
-            <a:off x="274320" y="3552444"/>
-            <a:ext cx="146304" cy="201168"/>
-          </a:xfrm>
-          <a:prstGeom prst="ellipse">
-            <a:avLst/>
-          </a:prstGeom>
-          <a:solidFill>
-            <a:srgbClr val="6B7A3E"/>
-          </a:solidFill>
-          <a:ln w="4000">
-            <a:solidFill>
-              <a:srgbClr val="8A6A2E"/>
+              <a:srgbClr val="707070"/>
             </a:solidFill>
           </a:ln>
         </p:spPr>
@@ -4667,14 +4290,14 @@
       </p:sp>
       <p:sp>
         <p:nvSpPr>
-          <p:cNvPr id="11" name="TextBox 10"/>
+          <p:cNvPr id="10" name="TextBox 9"/>
           <p:cNvSpPr txBox="1"/>
           <p:nvPr/>
         </p:nvSpPr>
         <p:spPr>
           <a:xfrm>
-            <a:off x="731520" y="914400"/>
-            <a:ext cx="10058400" cy="822960"/>
+            <a:off x="822960" y="2148840"/>
+            <a:ext cx="5303520" cy="4114800"/>
           </a:xfrm>
           <a:prstGeom prst="rect">
             <a:avLst/>
@@ -4682,114 +4305,34 @@
           <a:noFill/>
         </p:spPr>
         <p:txBody>
-          <a:bodyPr wrap="square" lIns="0" rIns="0" tIns="0" bIns="0" anchor="t">
+          <a:bodyPr wrap="square" lIns="0" rIns="0" tIns="0" bIns="0" anchor="ctr">
             <a:spAutoFit/>
           </a:bodyPr>
           <a:lstStyle/>
           <a:p>
-            <a:pPr algn="l"/>
-            <a:r>
-              <a:rPr sz="2800" b="1" i="0">
+            <a:pPr algn="ctr"/>
+            <a:r>
+              <a:rPr sz="1400" b="0" i="1">
                 <a:solidFill>
-                  <a:srgbClr val="2B1F12"/>
+                  <a:srgbClr val="707070"/>
                 </a:solidFill>
-                <a:latin typeface="Georgia"/>
+                <a:latin typeface="Calibri"/>
               </a:rPr>
-              <a:t>Figure or image + text</a:t>
-            </a:r>
-          </a:p>
-        </p:txBody>
-      </p:sp>
-      <p:cxnSp>
-        <p:nvCxnSpPr>
-          <p:cNvPr id="12" name="Connector 11"/>
-          <p:cNvCxnSpPr/>
-          <p:nvPr/>
-        </p:nvCxnSpPr>
-        <p:spPr>
-          <a:xfrm>
-            <a:off x="731520" y="1691640"/>
-            <a:ext cx="822960" cy="0"/>
-          </a:xfrm>
-          <a:prstGeom prst="line">
-            <a:avLst/>
-          </a:prstGeom>
-          <a:ln w="12700">
-            <a:solidFill>
-              <a:srgbClr val="C8963E"/>
-            </a:solidFill>
-          </a:ln>
-        </p:spPr>
-        <p:style>
-          <a:lnRef idx="2">
-            <a:schemeClr val="accent1"/>
-          </a:lnRef>
-          <a:fillRef idx="0">
-            <a:schemeClr val="accent1"/>
-          </a:fillRef>
-          <a:effectRef idx="1">
-            <a:schemeClr val="accent1"/>
-          </a:effectRef>
-          <a:fontRef idx="minor">
-            <a:schemeClr val="tx1"/>
-          </a:fontRef>
-        </p:style>
-      </p:cxnSp>
-      <p:sp>
-        <p:nvSpPr>
-          <p:cNvPr id="13" name="Rectangle 12"/>
-          <p:cNvSpPr/>
-          <p:nvPr/>
-        </p:nvSpPr>
-        <p:spPr>
-          <a:xfrm>
-            <a:off x="731520" y="2011680"/>
-            <a:ext cx="5120640" cy="4206240"/>
-          </a:xfrm>
-          <a:prstGeom prst="rect">
-            <a:avLst/>
-          </a:prstGeom>
-          <a:solidFill>
-            <a:srgbClr val="ECDFC3"/>
-          </a:solidFill>
-          <a:ln w="9525">
-            <a:solidFill>
-              <a:srgbClr val="8A6A2E"/>
-            </a:solidFill>
-          </a:ln>
-        </p:spPr>
-        <p:style>
-          <a:lnRef idx="1">
-            <a:schemeClr val="accent1"/>
-          </a:lnRef>
-          <a:fillRef idx="3">
-            <a:schemeClr val="accent1"/>
-          </a:fillRef>
-          <a:effectRef idx="2">
-            <a:schemeClr val="accent1"/>
-          </a:effectRef>
-          <a:fontRef idx="minor">
-            <a:schemeClr val="lt1"/>
-          </a:fontRef>
-        </p:style>
-        <p:txBody>
-          <a:bodyPr rtlCol="0" anchor="ctr"/>
-          <a:lstStyle/>
-          <a:p>
-            <a:pPr algn="ctr"/>
-          </a:p>
-        </p:txBody>
-      </p:sp>
-      <p:sp>
-        <p:nvSpPr>
-          <p:cNvPr id="14" name="TextBox 13"/>
+              <a:t>[ figure / diagram ]</a:t>
+            </a:r>
+          </a:p>
+        </p:txBody>
+      </p:sp>
+      <p:sp>
+        <p:nvSpPr>
+          <p:cNvPr id="11" name="TextBox 10"/>
           <p:cNvSpPr txBox="1"/>
           <p:nvPr/>
         </p:nvSpPr>
         <p:spPr>
           <a:xfrm>
-            <a:off x="731520" y="2011680"/>
-            <a:ext cx="5120640" cy="4206240"/>
+            <a:off x="6583680" y="2148840"/>
+            <a:ext cx="5150815" cy="457200"/>
           </a:xfrm>
           <a:prstGeom prst="rect">
             <a:avLst/>
@@ -4797,104 +4340,34 @@
           <a:noFill/>
         </p:spPr>
         <p:txBody>
-          <a:bodyPr wrap="square" lIns="0" rIns="0" tIns="0" bIns="0" anchor="ctr">
+          <a:bodyPr wrap="square" lIns="0" rIns="0" tIns="0" bIns="0" anchor="t">
             <a:spAutoFit/>
           </a:bodyPr>
           <a:lstStyle/>
           <a:p>
-            <a:pPr algn="ctr"/>
-            <a:r>
-              <a:rPr sz="1400" b="0" i="1">
+            <a:pPr algn="l"/>
+            <a:r>
+              <a:rPr sz="2000" b="1" i="0">
                 <a:solidFill>
-                  <a:srgbClr val="6E5A3C"/>
+                  <a:srgbClr val="1F1F1F"/>
                 </a:solidFill>
                 <a:latin typeface="Calibri"/>
               </a:rPr>
-              <a:t>[ figure / diagram ]</a:t>
-            </a:r>
-          </a:p>
-        </p:txBody>
-      </p:sp>
-      <p:cxnSp>
-        <p:nvCxnSpPr>
-          <p:cNvPr id="15" name="Connector 14"/>
-          <p:cNvCxnSpPr/>
-          <p:nvPr/>
-        </p:nvCxnSpPr>
-        <p:spPr>
-          <a:xfrm>
-            <a:off x="6172200" y="2194560"/>
-            <a:ext cx="0" cy="3840480"/>
-          </a:xfrm>
-          <a:prstGeom prst="line">
-            <a:avLst/>
-          </a:prstGeom>
-          <a:ln w="9525">
-            <a:solidFill>
-              <a:srgbClr val="6B7A3E"/>
-            </a:solidFill>
-          </a:ln>
-        </p:spPr>
-        <p:style>
-          <a:lnRef idx="2">
-            <a:schemeClr val="accent1"/>
-          </a:lnRef>
-          <a:fillRef idx="0">
-            <a:schemeClr val="accent1"/>
-          </a:fillRef>
-          <a:effectRef idx="1">
-            <a:schemeClr val="accent1"/>
-          </a:effectRef>
-          <a:fontRef idx="minor">
-            <a:schemeClr val="tx1"/>
-          </a:fontRef>
-        </p:style>
-      </p:cxnSp>
-      <p:sp>
-        <p:nvSpPr>
-          <p:cNvPr id="16" name="TextBox 15"/>
+              <a:t>Caption or claim</a:t>
+            </a:r>
+          </a:p>
+        </p:txBody>
+      </p:sp>
+      <p:sp>
+        <p:nvSpPr>
+          <p:cNvPr id="12" name="TextBox 11"/>
           <p:cNvSpPr txBox="1"/>
           <p:nvPr/>
         </p:nvSpPr>
         <p:spPr>
           <a:xfrm>
-            <a:off x="6492240" y="2011680"/>
-            <a:ext cx="5242255" cy="457200"/>
-          </a:xfrm>
-          <a:prstGeom prst="rect">
-            <a:avLst/>
-          </a:prstGeom>
-          <a:noFill/>
-        </p:spPr>
-        <p:txBody>
-          <a:bodyPr wrap="square" lIns="0" rIns="0" tIns="0" bIns="0" anchor="t">
-            <a:spAutoFit/>
-          </a:bodyPr>
-          <a:lstStyle/>
-          <a:p>
-            <a:pPr algn="l"/>
-            <a:r>
-              <a:rPr sz="2000" b="1" i="0">
-                <a:solidFill>
-                  <a:srgbClr val="2B1F12"/>
-                </a:solidFill>
-                <a:latin typeface="Georgia"/>
-              </a:rPr>
-              <a:t>Caption or claim</a:t>
-            </a:r>
-          </a:p>
-        </p:txBody>
-      </p:sp>
-      <p:sp>
-        <p:nvSpPr>
-          <p:cNvPr id="17" name="TextBox 16"/>
-          <p:cNvSpPr txBox="1"/>
-          <p:nvPr/>
-        </p:nvSpPr>
-        <p:spPr>
-          <a:xfrm>
-            <a:off x="6492240" y="2651760"/>
-            <a:ext cx="5242255" cy="3566160"/>
+            <a:off x="6583680" y="2788920"/>
+            <a:ext cx="5150815" cy="3474720"/>
           </a:xfrm>
           <a:prstGeom prst="rect">
             <a:avLst/>
@@ -4915,7 +4388,7 @@
             <a:r>
               <a:rPr sz="1500">
                 <a:solidFill>
-                  <a:srgbClr val="2B1F12"/>
+                  <a:srgbClr val="1F1F1F"/>
                 </a:solidFill>
                 <a:latin typeface="Calibri"/>
               </a:rPr>
@@ -4931,7 +4404,7 @@
             <a:r>
               <a:rPr sz="1500">
                 <a:solidFill>
-                  <a:srgbClr val="2B1F12"/>
+                  <a:srgbClr val="1F1F1F"/>
                 </a:solidFill>
                 <a:latin typeface="Calibri"/>
               </a:rPr>
@@ -4947,7 +4420,7 @@
             <a:r>
               <a:rPr sz="1500">
                 <a:solidFill>
-                  <a:srgbClr val="2B1F12"/>
+                  <a:srgbClr val="1F1F1F"/>
                 </a:solidFill>
                 <a:latin typeface="Calibri"/>
               </a:rPr>
@@ -4976,7 +4449,7 @@
       <p:grpSpPr/>
       <p:pic>
         <p:nvPicPr>
-          <p:cNvPr id="2" name="Picture 1" descr="parchment_bg.png"/>
+          <p:cNvPr id="2" name="Picture 1" descr="KCL.png"/>
           <p:cNvPicPr>
             <a:picLocks noChangeAspect="1"/>
           </p:cNvPicPr>
@@ -4990,8 +4463,8 @@
         </p:blipFill>
         <p:spPr>
           <a:xfrm>
-            <a:off x="0" y="0"/>
-            <a:ext cx="12191695" cy="6858000"/>
+            <a:off x="9111763" y="201168"/>
+            <a:ext cx="831046" cy="411480"/>
           </a:xfrm>
           <a:prstGeom prst="rect">
             <a:avLst/>
@@ -5000,7 +4473,7 @@
       </p:pic>
       <p:pic>
         <p:nvPicPr>
-          <p:cNvPr id="3" name="Picture 2" descr="tree_branch.png"/>
+          <p:cNvPr id="3" name="Picture 2" descr="KCLNLP.png"/>
           <p:cNvPicPr>
             <a:picLocks noChangeAspect="1"/>
           </p:cNvPicPr>
@@ -5014,8 +4487,8 @@
         </p:blipFill>
         <p:spPr>
           <a:xfrm>
-            <a:off x="4785055" y="1280160"/>
-            <a:ext cx="7680960" cy="5760720"/>
+            <a:off x="10125688" y="201168"/>
+            <a:ext cx="452782" cy="411480"/>
           </a:xfrm>
           <a:prstGeom prst="rect">
             <a:avLst/>
@@ -5024,7 +4497,7 @@
       </p:pic>
       <p:pic>
         <p:nvPicPr>
-          <p:cNvPr id="4" name="Picture 3" descr="KCL.png"/>
+          <p:cNvPr id="4" name="Picture 3" descr="Alan.png"/>
           <p:cNvPicPr>
             <a:picLocks noChangeAspect="1"/>
           </p:cNvPicPr>
@@ -5038,8 +4511,8 @@
         </p:blipFill>
         <p:spPr>
           <a:xfrm>
-            <a:off x="9298804" y="128016"/>
-            <a:ext cx="775643" cy="384048"/>
+            <a:off x="10761349" y="201168"/>
+            <a:ext cx="973146" cy="411480"/>
           </a:xfrm>
           <a:prstGeom prst="rect">
             <a:avLst/>
@@ -5054,15 +4527,15 @@
         </p:nvCxnSpPr>
         <p:spPr>
           <a:xfrm>
-            <a:off x="10156742" y="182880"/>
-            <a:ext cx="0" cy="274320"/>
+            <a:off x="457200" y="777240"/>
+            <a:ext cx="11277295" cy="0"/>
           </a:xfrm>
           <a:prstGeom prst="line">
             <a:avLst/>
           </a:prstGeom>
-          <a:ln w="4000">
+          <a:ln w="9525">
             <a:solidFill>
-              <a:srgbClr val="8A6A2E"/>
+              <a:srgbClr val="C8963E"/>
             </a:solidFill>
           </a:ln>
         </p:spPr>
@@ -5081,47 +4554,101 @@
           </a:fontRef>
         </p:style>
       </p:cxnSp>
-      <p:pic>
-        <p:nvPicPr>
-          <p:cNvPr id="6" name="Picture 5" descr="KCLNLP.png"/>
-          <p:cNvPicPr>
-            <a:picLocks noChangeAspect="1"/>
-          </p:cNvPicPr>
+      <p:sp>
+        <p:nvSpPr>
+          <p:cNvPr id="6" name="Rectangle 5"/>
+          <p:cNvSpPr/>
           <p:nvPr/>
-        </p:nvPicPr>
-        <p:blipFill>
-          <a:blip r:embed="rId5"/>
-          <a:stretch>
-            <a:fillRect/>
-          </a:stretch>
-        </p:blipFill>
-        <p:spPr>
-          <a:xfrm>
-            <a:off x="10239038" y="128016"/>
-            <a:ext cx="422596" cy="384048"/>
+        </p:nvSpPr>
+        <p:spPr>
+          <a:xfrm>
+            <a:off x="640080" y="2880360"/>
+            <a:ext cx="109728" cy="1463040"/>
           </a:xfrm>
           <a:prstGeom prst="rect">
             <a:avLst/>
           </a:prstGeom>
-        </p:spPr>
-      </p:pic>
+          <a:solidFill>
+            <a:srgbClr val="C8963E"/>
+          </a:solidFill>
+          <a:ln>
+            <a:noFill/>
+          </a:ln>
+        </p:spPr>
+        <p:style>
+          <a:lnRef idx="1">
+            <a:schemeClr val="accent1"/>
+          </a:lnRef>
+          <a:fillRef idx="3">
+            <a:schemeClr val="accent1"/>
+          </a:fillRef>
+          <a:effectRef idx="2">
+            <a:schemeClr val="accent1"/>
+          </a:effectRef>
+          <a:fontRef idx="minor">
+            <a:schemeClr val="lt1"/>
+          </a:fontRef>
+        </p:style>
+        <p:txBody>
+          <a:bodyPr rtlCol="0" anchor="ctr"/>
+          <a:lstStyle/>
+          <a:p>
+            <a:pPr algn="ctr"/>
+          </a:p>
+        </p:txBody>
+      </p:sp>
+      <p:sp>
+        <p:nvSpPr>
+          <p:cNvPr id="7" name="TextBox 6"/>
+          <p:cNvSpPr txBox="1"/>
+          <p:nvPr/>
+        </p:nvSpPr>
+        <p:spPr>
+          <a:xfrm>
+            <a:off x="960120" y="2743200"/>
+            <a:ext cx="9144000" cy="1463040"/>
+          </a:xfrm>
+          <a:prstGeom prst="rect">
+            <a:avLst/>
+          </a:prstGeom>
+          <a:noFill/>
+        </p:spPr>
+        <p:txBody>
+          <a:bodyPr wrap="square" lIns="0" rIns="0" tIns="0" bIns="0" anchor="t">
+            <a:spAutoFit/>
+          </a:bodyPr>
+          <a:lstStyle/>
+          <a:p>
+            <a:pPr algn="l"/>
+            <a:r>
+              <a:rPr sz="5600" b="1" i="0">
+                <a:solidFill>
+                  <a:srgbClr val="1F1F1F"/>
+                </a:solidFill>
+                <a:latin typeface="Calibri"/>
+              </a:rPr>
+              <a:t>Thank you</a:t>
+            </a:r>
+          </a:p>
+        </p:txBody>
+      </p:sp>
       <p:cxnSp>
         <p:nvCxnSpPr>
-          <p:cNvPr id="7" name="Connector 6"/>
+          <p:cNvPr id="8" name="Connector 7"/>
           <p:cNvCxnSpPr/>
           <p:nvPr/>
         </p:nvCxnSpPr>
         <p:spPr>
           <a:xfrm>
-            <a:off x="10743930" y="182880"/>
-            <a:ext cx="0" cy="274320"/>
+            <a:off x="960120" y="4343400"/>
+            <a:ext cx="1691640" cy="0"/>
           </a:xfrm>
           <a:prstGeom prst="line">
             <a:avLst/>
           </a:prstGeom>
-          <a:ln w="4000">
+          <a:ln w="19050">
             <a:solidFill>
-              <a:srgbClr val="8A6A2E"/>
+              <a:srgbClr val="C8963E"/>
             </a:solidFill>
           </a:ln>
         </p:spPr>
@@ -5140,75 +4667,16 @@
           </a:fontRef>
         </p:style>
       </p:cxnSp>
-      <p:pic>
-        <p:nvPicPr>
-          <p:cNvPr id="8" name="Picture 7" descr="Alan.png"/>
-          <p:cNvPicPr>
-            <a:picLocks noChangeAspect="1"/>
-          </p:cNvPicPr>
-          <p:nvPr/>
-        </p:nvPicPr>
-        <p:blipFill>
-          <a:blip r:embed="rId6"/>
-          <a:stretch>
-            <a:fillRect/>
-          </a:stretch>
-        </p:blipFill>
-        <p:spPr>
-          <a:xfrm>
-            <a:off x="10826226" y="128016"/>
-            <a:ext cx="908270" cy="384048"/>
-          </a:xfrm>
-          <a:prstGeom prst="rect">
-            <a:avLst/>
-          </a:prstGeom>
-        </p:spPr>
-      </p:pic>
-      <p:cxnSp>
-        <p:nvCxnSpPr>
-          <p:cNvPr id="9" name="Connector 8"/>
-          <p:cNvCxnSpPr/>
-          <p:nvPr/>
-        </p:nvCxnSpPr>
-        <p:spPr>
-          <a:xfrm>
-            <a:off x="457200" y="667512"/>
-            <a:ext cx="11277295" cy="0"/>
-          </a:xfrm>
-          <a:prstGeom prst="line">
-            <a:avLst/>
-          </a:prstGeom>
-          <a:ln w="9525">
-            <a:solidFill>
-              <a:srgbClr val="C8963E"/>
-            </a:solidFill>
-          </a:ln>
-        </p:spPr>
-        <p:style>
-          <a:lnRef idx="2">
-            <a:schemeClr val="accent1"/>
-          </a:lnRef>
-          <a:fillRef idx="0">
-            <a:schemeClr val="accent1"/>
-          </a:fillRef>
-          <a:effectRef idx="1">
-            <a:schemeClr val="accent1"/>
-          </a:effectRef>
-          <a:fontRef idx="minor">
-            <a:schemeClr val="tx1"/>
-          </a:fontRef>
-        </p:style>
-      </p:cxnSp>
-      <p:sp>
-        <p:nvSpPr>
-          <p:cNvPr id="10" name="TextBox 9"/>
+      <p:sp>
+        <p:nvSpPr>
+          <p:cNvPr id="9" name="TextBox 8"/>
           <p:cNvSpPr txBox="1"/>
           <p:nvPr/>
         </p:nvSpPr>
         <p:spPr>
           <a:xfrm>
-            <a:off x="640080" y="2560320"/>
-            <a:ext cx="9144000" cy="1280160"/>
+            <a:off x="960120" y="4526280"/>
+            <a:ext cx="9144000" cy="457200"/>
           </a:xfrm>
           <a:prstGeom prst="rect">
             <a:avLst/>
@@ -5223,62 +4691,27 @@
           <a:p>
             <a:pPr algn="l"/>
             <a:r>
-              <a:rPr sz="6000" b="1" i="0">
+              <a:rPr sz="2000" b="0" i="1">
                 <a:solidFill>
-                  <a:srgbClr val="2B1F12"/>
+                  <a:srgbClr val="707070"/>
                 </a:solidFill>
-                <a:latin typeface="Georgia"/>
+                <a:latin typeface="Calibri"/>
               </a:rPr>
-              <a:t>Thank you</a:t>
-            </a:r>
-          </a:p>
-        </p:txBody>
-      </p:sp>
-      <p:cxnSp>
-        <p:nvCxnSpPr>
-          <p:cNvPr id="11" name="Connector 10"/>
-          <p:cNvCxnSpPr/>
-          <p:nvPr/>
-        </p:nvCxnSpPr>
-        <p:spPr>
-          <a:xfrm>
-            <a:off x="640080" y="3931920"/>
-            <a:ext cx="1645920" cy="0"/>
-          </a:xfrm>
-          <a:prstGeom prst="line">
-            <a:avLst/>
-          </a:prstGeom>
-          <a:ln w="19050">
-            <a:solidFill>
-              <a:srgbClr val="C8963E"/>
-            </a:solidFill>
-          </a:ln>
-        </p:spPr>
-        <p:style>
-          <a:lnRef idx="2">
-            <a:schemeClr val="accent1"/>
-          </a:lnRef>
-          <a:fillRef idx="0">
-            <a:schemeClr val="accent1"/>
-          </a:fillRef>
-          <a:effectRef idx="1">
-            <a:schemeClr val="accent1"/>
-          </a:effectRef>
-          <a:fontRef idx="minor">
-            <a:schemeClr val="tx1"/>
-          </a:fontRef>
-        </p:style>
-      </p:cxnSp>
-      <p:sp>
-        <p:nvSpPr>
-          <p:cNvPr id="12" name="TextBox 11"/>
+              <a:t>Questions &amp; discussion</a:t>
+            </a:r>
+          </a:p>
+        </p:txBody>
+      </p:sp>
+      <p:sp>
+        <p:nvSpPr>
+          <p:cNvPr id="10" name="TextBox 9"/>
           <p:cNvSpPr txBox="1"/>
           <p:nvPr/>
         </p:nvSpPr>
         <p:spPr>
           <a:xfrm>
-            <a:off x="640080" y="4114800"/>
-            <a:ext cx="9144000" cy="457200"/>
+            <a:off x="960120" y="5257800"/>
+            <a:ext cx="9144000" cy="365760"/>
           </a:xfrm>
           <a:prstGeom prst="rect">
             <a:avLst/>
@@ -5293,44 +4726,9 @@
           <a:p>
             <a:pPr algn="l"/>
             <a:r>
-              <a:rPr sz="2200" b="0" i="1">
-                <a:solidFill>
-                  <a:srgbClr val="6E5A3C"/>
-                </a:solidFill>
-                <a:latin typeface="Georgia"/>
-              </a:rPr>
-              <a:t>Questions &amp; discussion</a:t>
-            </a:r>
-          </a:p>
-        </p:txBody>
-      </p:sp>
-      <p:sp>
-        <p:nvSpPr>
-          <p:cNvPr id="13" name="TextBox 12"/>
-          <p:cNvSpPr txBox="1"/>
-          <p:nvPr/>
-        </p:nvSpPr>
-        <p:spPr>
-          <a:xfrm>
-            <a:off x="640080" y="4937760"/>
-            <a:ext cx="9144000" cy="365760"/>
-          </a:xfrm>
-          <a:prstGeom prst="rect">
-            <a:avLst/>
-          </a:prstGeom>
-          <a:noFill/>
-        </p:spPr>
-        <p:txBody>
-          <a:bodyPr wrap="square" lIns="0" rIns="0" tIns="0" bIns="0" anchor="t">
-            <a:spAutoFit/>
-          </a:bodyPr>
-          <a:lstStyle/>
-          <a:p>
-            <a:pPr algn="l"/>
-            <a:r>
               <a:rPr sz="1400" b="0" i="0">
                 <a:solidFill>
-                  <a:srgbClr val="2B1F12"/>
+                  <a:srgbClr val="1F1F1F"/>
                 </a:solidFill>
                 <a:latin typeface="Calibri"/>
               </a:rPr>

</xml_diff>

<commit_message>
colour the header: cream band, orange rule, running 'Now:' label
Match the reference style: logo header sits on a cream band spanning
the full slide width, separated from the body by a thick orange rule.
Content and two-column slides carry a 'Now: <section>' running title
on the header's left, with 'Now:' in orange. Title-slide accent bar
and section-divider numerals shift from gold to the same warm orange
for consistency.

Co-Authored-By: Claude Opus 4.7 (1M context) <noreply@anthropic.com>
</commit_message>
<xml_diff>
--- a/templates/tree_yellow_texture/KCLNLP_TreeYellow.pptx
+++ b/templates/tree_yellow_texture/KCLNLP_TreeYellow.pptx
@@ -3092,9 +3092,52 @@
         <p:nvPr/>
       </p:nvGrpSpPr>
       <p:grpSpPr/>
+      <p:sp>
+        <p:nvSpPr>
+          <p:cNvPr id="2" name="Rectangle 1"/>
+          <p:cNvSpPr/>
+          <p:nvPr/>
+        </p:nvSpPr>
+        <p:spPr>
+          <a:xfrm>
+            <a:off x="0" y="0"/>
+            <a:ext cx="12191695" cy="777240"/>
+          </a:xfrm>
+          <a:prstGeom prst="rect">
+            <a:avLst/>
+          </a:prstGeom>
+          <a:solidFill>
+            <a:srgbClr val="F2E6CC"/>
+          </a:solidFill>
+          <a:ln>
+            <a:noFill/>
+          </a:ln>
+        </p:spPr>
+        <p:style>
+          <a:lnRef idx="1">
+            <a:schemeClr val="accent1"/>
+          </a:lnRef>
+          <a:fillRef idx="3">
+            <a:schemeClr val="accent1"/>
+          </a:fillRef>
+          <a:effectRef idx="2">
+            <a:schemeClr val="accent1"/>
+          </a:effectRef>
+          <a:fontRef idx="minor">
+            <a:schemeClr val="lt1"/>
+          </a:fontRef>
+        </p:style>
+        <p:txBody>
+          <a:bodyPr rtlCol="0" anchor="ctr"/>
+          <a:lstStyle/>
+          <a:p>
+            <a:pPr algn="ctr"/>
+          </a:p>
+        </p:txBody>
+      </p:sp>
       <p:pic>
         <p:nvPicPr>
-          <p:cNvPr id="2" name="Picture 1" descr="KCL.png"/>
+          <p:cNvPr id="3" name="Picture 2" descr="KCL.png"/>
           <p:cNvPicPr>
             <a:picLocks noChangeAspect="1"/>
           </p:cNvPicPr>
@@ -3108,8 +3151,8 @@
         </p:blipFill>
         <p:spPr>
           <a:xfrm>
-            <a:off x="9111763" y="201168"/>
-            <a:ext cx="831046" cy="411480"/>
+            <a:off x="8619356" y="137160"/>
+            <a:ext cx="1015723" cy="502920"/>
           </a:xfrm>
           <a:prstGeom prst="rect">
             <a:avLst/>
@@ -3118,7 +3161,7 @@
       </p:pic>
       <p:pic>
         <p:nvPicPr>
-          <p:cNvPr id="3" name="Picture 2" descr="KCLNLP.png"/>
+          <p:cNvPr id="4" name="Picture 3" descr="KCLNLP.png"/>
           <p:cNvPicPr>
             <a:picLocks noChangeAspect="1"/>
           </p:cNvPicPr>
@@ -3132,8 +3175,8 @@
         </p:blipFill>
         <p:spPr>
           <a:xfrm>
-            <a:off x="10125688" y="201168"/>
-            <a:ext cx="452782" cy="411480"/>
+            <a:off x="9836246" y="137160"/>
+            <a:ext cx="553400" cy="502920"/>
           </a:xfrm>
           <a:prstGeom prst="rect">
             <a:avLst/>
@@ -3142,7 +3185,7 @@
       </p:pic>
       <p:pic>
         <p:nvPicPr>
-          <p:cNvPr id="4" name="Picture 3" descr="Alan.png"/>
+          <p:cNvPr id="5" name="Picture 4" descr="Alan.png"/>
           <p:cNvPicPr>
             <a:picLocks noChangeAspect="1"/>
           </p:cNvPicPr>
@@ -3156,8 +3199,8 @@
         </p:blipFill>
         <p:spPr>
           <a:xfrm>
-            <a:off x="10761349" y="201168"/>
-            <a:ext cx="973146" cy="411480"/>
+            <a:off x="10590814" y="137160"/>
+            <a:ext cx="1189401" cy="502920"/>
           </a:xfrm>
           <a:prstGeom prst="rect">
             <a:avLst/>
@@ -3166,21 +3209,21 @@
       </p:pic>
       <p:cxnSp>
         <p:nvCxnSpPr>
-          <p:cNvPr id="5" name="Connector 4"/>
+          <p:cNvPr id="6" name="Connector 5"/>
           <p:cNvCxnSpPr/>
           <p:nvPr/>
         </p:nvCxnSpPr>
         <p:spPr>
           <a:xfrm>
-            <a:off x="457200" y="777240"/>
-            <a:ext cx="11277295" cy="0"/>
+            <a:off x="0" y="777240"/>
+            <a:ext cx="12191695" cy="0"/>
           </a:xfrm>
           <a:prstGeom prst="line">
             <a:avLst/>
           </a:prstGeom>
-          <a:ln w="9525">
+          <a:ln w="19050">
             <a:solidFill>
-              <a:srgbClr val="C8963E"/>
+              <a:srgbClr val="D94A1C"/>
             </a:solidFill>
           </a:ln>
         </p:spPr>
@@ -3201,20 +3244,20 @@
       </p:cxnSp>
       <p:sp>
         <p:nvSpPr>
-          <p:cNvPr id="6" name="Rectangle 5"/>
+          <p:cNvPr id="7" name="Rectangle 6"/>
           <p:cNvSpPr/>
           <p:nvPr/>
         </p:nvSpPr>
         <p:spPr>
           <a:xfrm>
-            <a:off x="640080" y="2468880"/>
+            <a:off x="594360" y="2468880"/>
             <a:ext cx="109728" cy="1280160"/>
           </a:xfrm>
           <a:prstGeom prst="rect">
             <a:avLst/>
           </a:prstGeom>
           <a:solidFill>
-            <a:srgbClr val="C8963E"/>
+            <a:srgbClr val="D94A1C"/>
           </a:solidFill>
           <a:ln>
             <a:noFill/>
@@ -3244,13 +3287,13 @@
       </p:sp>
       <p:sp>
         <p:nvSpPr>
-          <p:cNvPr id="7" name="TextBox 6"/>
+          <p:cNvPr id="8" name="TextBox 7"/>
           <p:cNvSpPr txBox="1"/>
           <p:nvPr/>
         </p:nvSpPr>
         <p:spPr>
           <a:xfrm>
-            <a:off x="960120" y="2377440"/>
+            <a:off x="914400" y="2377440"/>
             <a:ext cx="10058400" cy="1463040"/>
           </a:xfrm>
           <a:prstGeom prst="rect">
@@ -3279,13 +3322,13 @@
       </p:sp>
       <p:sp>
         <p:nvSpPr>
-          <p:cNvPr id="8" name="TextBox 7"/>
+          <p:cNvPr id="9" name="TextBox 8"/>
           <p:cNvSpPr txBox="1"/>
           <p:nvPr/>
         </p:nvSpPr>
         <p:spPr>
           <a:xfrm>
-            <a:off x="960120" y="3749040"/>
+            <a:off x="914400" y="3749040"/>
             <a:ext cx="10058400" cy="548640"/>
           </a:xfrm>
           <a:prstGeom prst="rect">
@@ -3314,13 +3357,13 @@
       </p:sp>
       <p:cxnSp>
         <p:nvCxnSpPr>
-          <p:cNvPr id="9" name="Connector 8"/>
+          <p:cNvPr id="10" name="Connector 9"/>
           <p:cNvCxnSpPr/>
           <p:nvPr/>
         </p:nvCxnSpPr>
         <p:spPr>
           <a:xfrm>
-            <a:off x="960120" y="4480560"/>
+            <a:off x="914400" y="4480560"/>
             <a:ext cx="1691640" cy="0"/>
           </a:xfrm>
           <a:prstGeom prst="line">
@@ -3328,7 +3371,7 @@
           </a:prstGeom>
           <a:ln w="19050">
             <a:solidFill>
-              <a:srgbClr val="C8963E"/>
+              <a:srgbClr val="D94A1C"/>
             </a:solidFill>
           </a:ln>
         </p:spPr>
@@ -3349,13 +3392,13 @@
       </p:cxnSp>
       <p:sp>
         <p:nvSpPr>
-          <p:cNvPr id="10" name="TextBox 9"/>
+          <p:cNvPr id="11" name="TextBox 10"/>
           <p:cNvSpPr txBox="1"/>
           <p:nvPr/>
         </p:nvSpPr>
         <p:spPr>
           <a:xfrm>
-            <a:off x="960120" y="4617720"/>
+            <a:off x="914400" y="4617720"/>
             <a:ext cx="10058400" cy="365760"/>
           </a:xfrm>
           <a:prstGeom prst="rect">
@@ -3400,9 +3443,52 @@
         <p:nvPr/>
       </p:nvGrpSpPr>
       <p:grpSpPr/>
+      <p:sp>
+        <p:nvSpPr>
+          <p:cNvPr id="2" name="Rectangle 1"/>
+          <p:cNvSpPr/>
+          <p:nvPr/>
+        </p:nvSpPr>
+        <p:spPr>
+          <a:xfrm>
+            <a:off x="0" y="0"/>
+            <a:ext cx="12191695" cy="777240"/>
+          </a:xfrm>
+          <a:prstGeom prst="rect">
+            <a:avLst/>
+          </a:prstGeom>
+          <a:solidFill>
+            <a:srgbClr val="F2E6CC"/>
+          </a:solidFill>
+          <a:ln>
+            <a:noFill/>
+          </a:ln>
+        </p:spPr>
+        <p:style>
+          <a:lnRef idx="1">
+            <a:schemeClr val="accent1"/>
+          </a:lnRef>
+          <a:fillRef idx="3">
+            <a:schemeClr val="accent1"/>
+          </a:fillRef>
+          <a:effectRef idx="2">
+            <a:schemeClr val="accent1"/>
+          </a:effectRef>
+          <a:fontRef idx="minor">
+            <a:schemeClr val="lt1"/>
+          </a:fontRef>
+        </p:style>
+        <p:txBody>
+          <a:bodyPr rtlCol="0" anchor="ctr"/>
+          <a:lstStyle/>
+          <a:p>
+            <a:pPr algn="ctr"/>
+          </a:p>
+        </p:txBody>
+      </p:sp>
       <p:pic>
         <p:nvPicPr>
-          <p:cNvPr id="2" name="Picture 1" descr="KCL.png"/>
+          <p:cNvPr id="3" name="Picture 2" descr="KCL.png"/>
           <p:cNvPicPr>
             <a:picLocks noChangeAspect="1"/>
           </p:cNvPicPr>
@@ -3416,8 +3502,8 @@
         </p:blipFill>
         <p:spPr>
           <a:xfrm>
-            <a:off x="9111763" y="201168"/>
-            <a:ext cx="831046" cy="411480"/>
+            <a:off x="8619356" y="137160"/>
+            <a:ext cx="1015723" cy="502920"/>
           </a:xfrm>
           <a:prstGeom prst="rect">
             <a:avLst/>
@@ -3426,7 +3512,7 @@
       </p:pic>
       <p:pic>
         <p:nvPicPr>
-          <p:cNvPr id="3" name="Picture 2" descr="KCLNLP.png"/>
+          <p:cNvPr id="4" name="Picture 3" descr="KCLNLP.png"/>
           <p:cNvPicPr>
             <a:picLocks noChangeAspect="1"/>
           </p:cNvPicPr>
@@ -3440,8 +3526,8 @@
         </p:blipFill>
         <p:spPr>
           <a:xfrm>
-            <a:off x="10125688" y="201168"/>
-            <a:ext cx="452782" cy="411480"/>
+            <a:off x="9836246" y="137160"/>
+            <a:ext cx="553400" cy="502920"/>
           </a:xfrm>
           <a:prstGeom prst="rect">
             <a:avLst/>
@@ -3450,7 +3536,7 @@
       </p:pic>
       <p:pic>
         <p:nvPicPr>
-          <p:cNvPr id="4" name="Picture 3" descr="Alan.png"/>
+          <p:cNvPr id="5" name="Picture 4" descr="Alan.png"/>
           <p:cNvPicPr>
             <a:picLocks noChangeAspect="1"/>
           </p:cNvPicPr>
@@ -3464,31 +3550,75 @@
         </p:blipFill>
         <p:spPr>
           <a:xfrm>
-            <a:off x="10761349" y="201168"/>
-            <a:ext cx="973146" cy="411480"/>
+            <a:off x="10590814" y="137160"/>
+            <a:ext cx="1189401" cy="502920"/>
           </a:xfrm>
           <a:prstGeom prst="rect">
             <a:avLst/>
           </a:prstGeom>
         </p:spPr>
       </p:pic>
+      <p:sp>
+        <p:nvSpPr>
+          <p:cNvPr id="6" name="TextBox 5"/>
+          <p:cNvSpPr txBox="1"/>
+          <p:nvPr/>
+        </p:nvSpPr>
+        <p:spPr>
+          <a:xfrm>
+            <a:off x="411480" y="0"/>
+            <a:ext cx="7315200" cy="777240"/>
+          </a:xfrm>
+          <a:prstGeom prst="rect">
+            <a:avLst/>
+          </a:prstGeom>
+          <a:noFill/>
+        </p:spPr>
+        <p:txBody>
+          <a:bodyPr wrap="square" lIns="0" rIns="0" tIns="0" bIns="0" anchor="ctr">
+            <a:spAutoFit/>
+          </a:bodyPr>
+          <a:lstStyle/>
+          <a:p>
+            <a:pPr algn="l"/>
+            <a:r>
+              <a:rPr sz="1600" b="1" i="1">
+                <a:solidFill>
+                  <a:srgbClr val="D94A1C"/>
+                </a:solidFill>
+                <a:latin typeface="Calibri"/>
+              </a:rPr>
+              <a:t>Now: </a:t>
+            </a:r>
+            <a:r>
+              <a:rPr sz="1600" i="1">
+                <a:solidFill>
+                  <a:srgbClr val="1F1F1F"/>
+                </a:solidFill>
+                <a:latin typeface="Calibri"/>
+              </a:rPr>
+              <a:t>Motivation</a:t>
+            </a:r>
+          </a:p>
+        </p:txBody>
+      </p:sp>
       <p:cxnSp>
         <p:nvCxnSpPr>
-          <p:cNvPr id="5" name="Connector 4"/>
+          <p:cNvPr id="7" name="Connector 6"/>
           <p:cNvCxnSpPr/>
           <p:nvPr/>
         </p:nvCxnSpPr>
         <p:spPr>
           <a:xfrm>
-            <a:off x="457200" y="777240"/>
-            <a:ext cx="11277295" cy="0"/>
+            <a:off x="0" y="777240"/>
+            <a:ext cx="12191695" cy="0"/>
           </a:xfrm>
           <a:prstGeom prst="line">
             <a:avLst/>
           </a:prstGeom>
-          <a:ln w="9525">
+          <a:ln w="19050">
             <a:solidFill>
-              <a:srgbClr val="C8963E"/>
+              <a:srgbClr val="D94A1C"/>
             </a:solidFill>
           </a:ln>
         </p:spPr>
@@ -3509,13 +3639,13 @@
       </p:cxnSp>
       <p:sp>
         <p:nvSpPr>
-          <p:cNvPr id="6" name="TextBox 5"/>
+          <p:cNvPr id="8" name="TextBox 7"/>
           <p:cNvSpPr txBox="1"/>
           <p:nvPr/>
         </p:nvSpPr>
         <p:spPr>
           <a:xfrm>
-            <a:off x="914400" y="2743200"/>
+            <a:off x="868680" y="2743200"/>
             <a:ext cx="1645920" cy="1097280"/>
           </a:xfrm>
           <a:prstGeom prst="rect">
@@ -3533,7 +3663,7 @@
             <a:r>
               <a:rPr sz="5600" b="1" i="0">
                 <a:solidFill>
-                  <a:srgbClr val="C8963E"/>
+                  <a:srgbClr val="D94A1C"/>
                 </a:solidFill>
                 <a:latin typeface="Calibri"/>
               </a:rPr>
@@ -3544,13 +3674,13 @@
       </p:sp>
       <p:cxnSp>
         <p:nvCxnSpPr>
-          <p:cNvPr id="7" name="Connector 6"/>
+          <p:cNvPr id="9" name="Connector 8"/>
           <p:cNvCxnSpPr/>
           <p:nvPr/>
         </p:nvCxnSpPr>
         <p:spPr>
           <a:xfrm>
-            <a:off x="2651760" y="2971800"/>
+            <a:off x="2606040" y="2971800"/>
             <a:ext cx="0" cy="822960"/>
           </a:xfrm>
           <a:prstGeom prst="line">
@@ -3558,7 +3688,7 @@
           </a:prstGeom>
           <a:ln w="12700">
             <a:solidFill>
-              <a:srgbClr val="C8963E"/>
+              <a:srgbClr val="D94A1C"/>
             </a:solidFill>
           </a:ln>
         </p:spPr>
@@ -3579,13 +3709,13 @@
       </p:cxnSp>
       <p:sp>
         <p:nvSpPr>
-          <p:cNvPr id="8" name="TextBox 7"/>
+          <p:cNvPr id="10" name="TextBox 9"/>
           <p:cNvSpPr txBox="1"/>
           <p:nvPr/>
         </p:nvSpPr>
         <p:spPr>
           <a:xfrm>
-            <a:off x="2926080" y="2926080"/>
+            <a:off x="2880360" y="2926080"/>
             <a:ext cx="7315200" cy="914400"/>
           </a:xfrm>
           <a:prstGeom prst="rect">
@@ -3614,13 +3744,13 @@
       </p:sp>
       <p:sp>
         <p:nvSpPr>
-          <p:cNvPr id="9" name="TextBox 8"/>
+          <p:cNvPr id="11" name="TextBox 10"/>
           <p:cNvSpPr txBox="1"/>
           <p:nvPr/>
         </p:nvSpPr>
         <p:spPr>
           <a:xfrm>
-            <a:off x="2926080" y="3703320"/>
+            <a:off x="2880360" y="3703320"/>
             <a:ext cx="7315200" cy="365760"/>
           </a:xfrm>
           <a:prstGeom prst="rect">
@@ -3665,9 +3795,52 @@
         <p:nvPr/>
       </p:nvGrpSpPr>
       <p:grpSpPr/>
+      <p:sp>
+        <p:nvSpPr>
+          <p:cNvPr id="2" name="Rectangle 1"/>
+          <p:cNvSpPr/>
+          <p:nvPr/>
+        </p:nvSpPr>
+        <p:spPr>
+          <a:xfrm>
+            <a:off x="0" y="0"/>
+            <a:ext cx="12191695" cy="777240"/>
+          </a:xfrm>
+          <a:prstGeom prst="rect">
+            <a:avLst/>
+          </a:prstGeom>
+          <a:solidFill>
+            <a:srgbClr val="F2E6CC"/>
+          </a:solidFill>
+          <a:ln>
+            <a:noFill/>
+          </a:ln>
+        </p:spPr>
+        <p:style>
+          <a:lnRef idx="1">
+            <a:schemeClr val="accent1"/>
+          </a:lnRef>
+          <a:fillRef idx="3">
+            <a:schemeClr val="accent1"/>
+          </a:fillRef>
+          <a:effectRef idx="2">
+            <a:schemeClr val="accent1"/>
+          </a:effectRef>
+          <a:fontRef idx="minor">
+            <a:schemeClr val="lt1"/>
+          </a:fontRef>
+        </p:style>
+        <p:txBody>
+          <a:bodyPr rtlCol="0" anchor="ctr"/>
+          <a:lstStyle/>
+          <a:p>
+            <a:pPr algn="ctr"/>
+          </a:p>
+        </p:txBody>
+      </p:sp>
       <p:pic>
         <p:nvPicPr>
-          <p:cNvPr id="2" name="Picture 1" descr="KCL.png"/>
+          <p:cNvPr id="3" name="Picture 2" descr="KCL.png"/>
           <p:cNvPicPr>
             <a:picLocks noChangeAspect="1"/>
           </p:cNvPicPr>
@@ -3681,8 +3854,8 @@
         </p:blipFill>
         <p:spPr>
           <a:xfrm>
-            <a:off x="9111763" y="201168"/>
-            <a:ext cx="831046" cy="411480"/>
+            <a:off x="8619356" y="137160"/>
+            <a:ext cx="1015723" cy="502920"/>
           </a:xfrm>
           <a:prstGeom prst="rect">
             <a:avLst/>
@@ -3691,7 +3864,7 @@
       </p:pic>
       <p:pic>
         <p:nvPicPr>
-          <p:cNvPr id="3" name="Picture 2" descr="KCLNLP.png"/>
+          <p:cNvPr id="4" name="Picture 3" descr="KCLNLP.png"/>
           <p:cNvPicPr>
             <a:picLocks noChangeAspect="1"/>
           </p:cNvPicPr>
@@ -3705,8 +3878,8 @@
         </p:blipFill>
         <p:spPr>
           <a:xfrm>
-            <a:off x="10125688" y="201168"/>
-            <a:ext cx="452782" cy="411480"/>
+            <a:off x="9836246" y="137160"/>
+            <a:ext cx="553400" cy="502920"/>
           </a:xfrm>
           <a:prstGeom prst="rect">
             <a:avLst/>
@@ -3715,7 +3888,7 @@
       </p:pic>
       <p:pic>
         <p:nvPicPr>
-          <p:cNvPr id="4" name="Picture 3" descr="Alan.png"/>
+          <p:cNvPr id="5" name="Picture 4" descr="Alan.png"/>
           <p:cNvPicPr>
             <a:picLocks noChangeAspect="1"/>
           </p:cNvPicPr>
@@ -3729,31 +3902,75 @@
         </p:blipFill>
         <p:spPr>
           <a:xfrm>
-            <a:off x="10761349" y="201168"/>
-            <a:ext cx="973146" cy="411480"/>
+            <a:off x="10590814" y="137160"/>
+            <a:ext cx="1189401" cy="502920"/>
           </a:xfrm>
           <a:prstGeom prst="rect">
             <a:avLst/>
           </a:prstGeom>
         </p:spPr>
       </p:pic>
+      <p:sp>
+        <p:nvSpPr>
+          <p:cNvPr id="6" name="TextBox 5"/>
+          <p:cNvSpPr txBox="1"/>
+          <p:nvPr/>
+        </p:nvSpPr>
+        <p:spPr>
+          <a:xfrm>
+            <a:off x="411480" y="0"/>
+            <a:ext cx="7315200" cy="777240"/>
+          </a:xfrm>
+          <a:prstGeom prst="rect">
+            <a:avLst/>
+          </a:prstGeom>
+          <a:noFill/>
+        </p:spPr>
+        <p:txBody>
+          <a:bodyPr wrap="square" lIns="0" rIns="0" tIns="0" bIns="0" anchor="ctr">
+            <a:spAutoFit/>
+          </a:bodyPr>
+          <a:lstStyle/>
+          <a:p>
+            <a:pPr algn="l"/>
+            <a:r>
+              <a:rPr sz="1600" b="1" i="1">
+                <a:solidFill>
+                  <a:srgbClr val="D94A1C"/>
+                </a:solidFill>
+                <a:latin typeface="Calibri"/>
+              </a:rPr>
+              <a:t>Now: </a:t>
+            </a:r>
+            <a:r>
+              <a:rPr sz="1600" i="1">
+                <a:solidFill>
+                  <a:srgbClr val="1F1F1F"/>
+                </a:solidFill>
+                <a:latin typeface="Calibri"/>
+              </a:rPr>
+              <a:t>Motivation</a:t>
+            </a:r>
+          </a:p>
+        </p:txBody>
+      </p:sp>
       <p:cxnSp>
         <p:nvCxnSpPr>
-          <p:cNvPr id="5" name="Connector 4"/>
+          <p:cNvPr id="7" name="Connector 6"/>
           <p:cNvCxnSpPr/>
           <p:nvPr/>
         </p:nvCxnSpPr>
         <p:spPr>
           <a:xfrm>
-            <a:off x="457200" y="777240"/>
-            <a:ext cx="11277295" cy="0"/>
+            <a:off x="0" y="777240"/>
+            <a:ext cx="12191695" cy="0"/>
           </a:xfrm>
           <a:prstGeom prst="line">
             <a:avLst/>
           </a:prstGeom>
-          <a:ln w="9525">
+          <a:ln w="19050">
             <a:solidFill>
-              <a:srgbClr val="C8963E"/>
+              <a:srgbClr val="D94A1C"/>
             </a:solidFill>
           </a:ln>
         </p:spPr>
@@ -3774,20 +3991,20 @@
       </p:cxnSp>
       <p:sp>
         <p:nvSpPr>
-          <p:cNvPr id="6" name="Rectangle 5"/>
+          <p:cNvPr id="8" name="Rectangle 7"/>
           <p:cNvSpPr/>
           <p:nvPr/>
         </p:nvSpPr>
         <p:spPr>
           <a:xfrm>
-            <a:off x="548640" y="1078992"/>
+            <a:off x="502920" y="1261872"/>
             <a:ext cx="109728" cy="640080"/>
           </a:xfrm>
           <a:prstGeom prst="rect">
             <a:avLst/>
           </a:prstGeom>
           <a:solidFill>
-            <a:srgbClr val="C8963E"/>
+            <a:srgbClr val="D94A1C"/>
           </a:solidFill>
           <a:ln>
             <a:noFill/>
@@ -3817,13 +4034,13 @@
       </p:sp>
       <p:sp>
         <p:nvSpPr>
-          <p:cNvPr id="7" name="TextBox 6"/>
+          <p:cNvPr id="9" name="TextBox 8"/>
           <p:cNvSpPr txBox="1"/>
           <p:nvPr/>
         </p:nvSpPr>
         <p:spPr>
           <a:xfrm>
-            <a:off x="822960" y="1005840"/>
+            <a:off x="777240" y="1188720"/>
             <a:ext cx="10058400" cy="822960"/>
           </a:xfrm>
           <a:prstGeom prst="rect">
@@ -3850,51 +4067,16 @@
           </a:p>
         </p:txBody>
       </p:sp>
-      <p:cxnSp>
-        <p:nvCxnSpPr>
-          <p:cNvPr id="8" name="Connector 7"/>
-          <p:cNvCxnSpPr/>
-          <p:nvPr/>
-        </p:nvCxnSpPr>
-        <p:spPr>
-          <a:xfrm>
-            <a:off x="822960" y="1874520"/>
-            <a:ext cx="10911535" cy="0"/>
-          </a:xfrm>
-          <a:prstGeom prst="line">
-            <a:avLst/>
-          </a:prstGeom>
-          <a:ln w="6350">
-            <a:solidFill>
-              <a:srgbClr val="C8963E"/>
-            </a:solidFill>
-          </a:ln>
-        </p:spPr>
-        <p:style>
-          <a:lnRef idx="2">
-            <a:schemeClr val="accent1"/>
-          </a:lnRef>
-          <a:fillRef idx="0">
-            <a:schemeClr val="accent1"/>
-          </a:fillRef>
-          <a:effectRef idx="1">
-            <a:schemeClr val="accent1"/>
-          </a:effectRef>
-          <a:fontRef idx="minor">
-            <a:schemeClr val="tx1"/>
-          </a:fontRef>
-        </p:style>
-      </p:cxnSp>
-      <p:sp>
-        <p:nvSpPr>
-          <p:cNvPr id="9" name="TextBox 8"/>
+      <p:sp>
+        <p:nvSpPr>
+          <p:cNvPr id="10" name="TextBox 9"/>
           <p:cNvSpPr txBox="1"/>
           <p:nvPr/>
         </p:nvSpPr>
         <p:spPr>
           <a:xfrm>
-            <a:off x="822960" y="2148840"/>
-            <a:ext cx="10972800" cy="4206240"/>
+            <a:off x="777240" y="2194560"/>
+            <a:ext cx="10972800" cy="4023360"/>
           </a:xfrm>
           <a:prstGeom prst="rect">
             <a:avLst/>
@@ -3974,13 +4156,13 @@
       </p:sp>
       <p:sp>
         <p:nvSpPr>
-          <p:cNvPr id="10" name="TextBox 9"/>
+          <p:cNvPr id="11" name="TextBox 10"/>
           <p:cNvSpPr txBox="1"/>
           <p:nvPr/>
         </p:nvSpPr>
         <p:spPr>
           <a:xfrm>
-            <a:off x="822960" y="6492240"/>
+            <a:off x="777240" y="6492240"/>
             <a:ext cx="10972800" cy="274320"/>
           </a:xfrm>
           <a:prstGeom prst="rect">
@@ -4025,9 +4207,52 @@
         <p:nvPr/>
       </p:nvGrpSpPr>
       <p:grpSpPr/>
+      <p:sp>
+        <p:nvSpPr>
+          <p:cNvPr id="2" name="Rectangle 1"/>
+          <p:cNvSpPr/>
+          <p:nvPr/>
+        </p:nvSpPr>
+        <p:spPr>
+          <a:xfrm>
+            <a:off x="0" y="0"/>
+            <a:ext cx="12191695" cy="777240"/>
+          </a:xfrm>
+          <a:prstGeom prst="rect">
+            <a:avLst/>
+          </a:prstGeom>
+          <a:solidFill>
+            <a:srgbClr val="F2E6CC"/>
+          </a:solidFill>
+          <a:ln>
+            <a:noFill/>
+          </a:ln>
+        </p:spPr>
+        <p:style>
+          <a:lnRef idx="1">
+            <a:schemeClr val="accent1"/>
+          </a:lnRef>
+          <a:fillRef idx="3">
+            <a:schemeClr val="accent1"/>
+          </a:fillRef>
+          <a:effectRef idx="2">
+            <a:schemeClr val="accent1"/>
+          </a:effectRef>
+          <a:fontRef idx="minor">
+            <a:schemeClr val="lt1"/>
+          </a:fontRef>
+        </p:style>
+        <p:txBody>
+          <a:bodyPr rtlCol="0" anchor="ctr"/>
+          <a:lstStyle/>
+          <a:p>
+            <a:pPr algn="ctr"/>
+          </a:p>
+        </p:txBody>
+      </p:sp>
       <p:pic>
         <p:nvPicPr>
-          <p:cNvPr id="2" name="Picture 1" descr="KCL.png"/>
+          <p:cNvPr id="3" name="Picture 2" descr="KCL.png"/>
           <p:cNvPicPr>
             <a:picLocks noChangeAspect="1"/>
           </p:cNvPicPr>
@@ -4041,8 +4266,8 @@
         </p:blipFill>
         <p:spPr>
           <a:xfrm>
-            <a:off x="9111763" y="201168"/>
-            <a:ext cx="831046" cy="411480"/>
+            <a:off x="8619356" y="137160"/>
+            <a:ext cx="1015723" cy="502920"/>
           </a:xfrm>
           <a:prstGeom prst="rect">
             <a:avLst/>
@@ -4051,7 +4276,7 @@
       </p:pic>
       <p:pic>
         <p:nvPicPr>
-          <p:cNvPr id="3" name="Picture 2" descr="KCLNLP.png"/>
+          <p:cNvPr id="4" name="Picture 3" descr="KCLNLP.png"/>
           <p:cNvPicPr>
             <a:picLocks noChangeAspect="1"/>
           </p:cNvPicPr>
@@ -4065,8 +4290,8 @@
         </p:blipFill>
         <p:spPr>
           <a:xfrm>
-            <a:off x="10125688" y="201168"/>
-            <a:ext cx="452782" cy="411480"/>
+            <a:off x="9836246" y="137160"/>
+            <a:ext cx="553400" cy="502920"/>
           </a:xfrm>
           <a:prstGeom prst="rect">
             <a:avLst/>
@@ -4075,7 +4300,7 @@
       </p:pic>
       <p:pic>
         <p:nvPicPr>
-          <p:cNvPr id="4" name="Picture 3" descr="Alan.png"/>
+          <p:cNvPr id="5" name="Picture 4" descr="Alan.png"/>
           <p:cNvPicPr>
             <a:picLocks noChangeAspect="1"/>
           </p:cNvPicPr>
@@ -4089,31 +4314,75 @@
         </p:blipFill>
         <p:spPr>
           <a:xfrm>
-            <a:off x="10761349" y="201168"/>
-            <a:ext cx="973146" cy="411480"/>
+            <a:off x="10590814" y="137160"/>
+            <a:ext cx="1189401" cy="502920"/>
           </a:xfrm>
           <a:prstGeom prst="rect">
             <a:avLst/>
           </a:prstGeom>
         </p:spPr>
       </p:pic>
+      <p:sp>
+        <p:nvSpPr>
+          <p:cNvPr id="6" name="TextBox 5"/>
+          <p:cNvSpPr txBox="1"/>
+          <p:nvPr/>
+        </p:nvSpPr>
+        <p:spPr>
+          <a:xfrm>
+            <a:off x="411480" y="0"/>
+            <a:ext cx="7315200" cy="777240"/>
+          </a:xfrm>
+          <a:prstGeom prst="rect">
+            <a:avLst/>
+          </a:prstGeom>
+          <a:noFill/>
+        </p:spPr>
+        <p:txBody>
+          <a:bodyPr wrap="square" lIns="0" rIns="0" tIns="0" bIns="0" anchor="ctr">
+            <a:spAutoFit/>
+          </a:bodyPr>
+          <a:lstStyle/>
+          <a:p>
+            <a:pPr algn="l"/>
+            <a:r>
+              <a:rPr sz="1600" b="1" i="1">
+                <a:solidFill>
+                  <a:srgbClr val="D94A1C"/>
+                </a:solidFill>
+                <a:latin typeface="Calibri"/>
+              </a:rPr>
+              <a:t>Now: </a:t>
+            </a:r>
+            <a:r>
+              <a:rPr sz="1600" i="1">
+                <a:solidFill>
+                  <a:srgbClr val="1F1F1F"/>
+                </a:solidFill>
+                <a:latin typeface="Calibri"/>
+              </a:rPr>
+              <a:t>Motivation</a:t>
+            </a:r>
+          </a:p>
+        </p:txBody>
+      </p:sp>
       <p:cxnSp>
         <p:nvCxnSpPr>
-          <p:cNvPr id="5" name="Connector 4"/>
+          <p:cNvPr id="7" name="Connector 6"/>
           <p:cNvCxnSpPr/>
           <p:nvPr/>
         </p:nvCxnSpPr>
         <p:spPr>
           <a:xfrm>
-            <a:off x="457200" y="777240"/>
-            <a:ext cx="11277295" cy="0"/>
+            <a:off x="0" y="777240"/>
+            <a:ext cx="12191695" cy="0"/>
           </a:xfrm>
           <a:prstGeom prst="line">
             <a:avLst/>
           </a:prstGeom>
-          <a:ln w="9525">
+          <a:ln w="19050">
             <a:solidFill>
-              <a:srgbClr val="C8963E"/>
+              <a:srgbClr val="D94A1C"/>
             </a:solidFill>
           </a:ln>
         </p:spPr>
@@ -4134,20 +4403,20 @@
       </p:cxnSp>
       <p:sp>
         <p:nvSpPr>
-          <p:cNvPr id="6" name="Rectangle 5"/>
+          <p:cNvPr id="8" name="Rectangle 7"/>
           <p:cNvSpPr/>
           <p:nvPr/>
         </p:nvSpPr>
         <p:spPr>
           <a:xfrm>
-            <a:off x="548640" y="1078992"/>
+            <a:off x="502920" y="1261872"/>
             <a:ext cx="109728" cy="640080"/>
           </a:xfrm>
           <a:prstGeom prst="rect">
             <a:avLst/>
           </a:prstGeom>
           <a:solidFill>
-            <a:srgbClr val="C8963E"/>
+            <a:srgbClr val="D94A1C"/>
           </a:solidFill>
           <a:ln>
             <a:noFill/>
@@ -4177,13 +4446,13 @@
       </p:sp>
       <p:sp>
         <p:nvSpPr>
-          <p:cNvPr id="7" name="TextBox 6"/>
+          <p:cNvPr id="9" name="TextBox 8"/>
           <p:cNvSpPr txBox="1"/>
           <p:nvPr/>
         </p:nvSpPr>
         <p:spPr>
           <a:xfrm>
-            <a:off x="822960" y="1005840"/>
+            <a:off x="777240" y="1188720"/>
             <a:ext cx="10058400" cy="822960"/>
           </a:xfrm>
           <a:prstGeom prst="rect">
@@ -4210,51 +4479,16 @@
           </a:p>
         </p:txBody>
       </p:sp>
-      <p:cxnSp>
-        <p:nvCxnSpPr>
-          <p:cNvPr id="8" name="Connector 7"/>
-          <p:cNvCxnSpPr/>
-          <p:nvPr/>
-        </p:nvCxnSpPr>
-        <p:spPr>
-          <a:xfrm>
-            <a:off x="822960" y="1874520"/>
-            <a:ext cx="10911535" cy="0"/>
-          </a:xfrm>
-          <a:prstGeom prst="line">
-            <a:avLst/>
-          </a:prstGeom>
-          <a:ln w="6350">
-            <a:solidFill>
-              <a:srgbClr val="C8963E"/>
-            </a:solidFill>
-          </a:ln>
-        </p:spPr>
-        <p:style>
-          <a:lnRef idx="2">
-            <a:schemeClr val="accent1"/>
-          </a:lnRef>
-          <a:fillRef idx="0">
-            <a:schemeClr val="accent1"/>
-          </a:fillRef>
-          <a:effectRef idx="1">
-            <a:schemeClr val="accent1"/>
-          </a:effectRef>
-          <a:fontRef idx="minor">
-            <a:schemeClr val="tx1"/>
-          </a:fontRef>
-        </p:style>
-      </p:cxnSp>
-      <p:sp>
-        <p:nvSpPr>
-          <p:cNvPr id="9" name="Rectangle 8"/>
+      <p:sp>
+        <p:nvSpPr>
+          <p:cNvPr id="10" name="Rectangle 9"/>
           <p:cNvSpPr/>
           <p:nvPr/>
         </p:nvSpPr>
         <p:spPr>
           <a:xfrm>
-            <a:off x="822960" y="2148840"/>
-            <a:ext cx="5303520" cy="4114800"/>
+            <a:off x="777240" y="2194560"/>
+            <a:ext cx="5303520" cy="3931920"/>
           </a:xfrm>
           <a:prstGeom prst="rect">
             <a:avLst/>
@@ -4290,14 +4524,14 @@
       </p:sp>
       <p:sp>
         <p:nvSpPr>
-          <p:cNvPr id="10" name="TextBox 9"/>
+          <p:cNvPr id="11" name="TextBox 10"/>
           <p:cNvSpPr txBox="1"/>
           <p:nvPr/>
         </p:nvSpPr>
         <p:spPr>
           <a:xfrm>
-            <a:off x="822960" y="2148840"/>
-            <a:ext cx="5303520" cy="4114800"/>
+            <a:off x="777240" y="2194560"/>
+            <a:ext cx="5303520" cy="3931920"/>
           </a:xfrm>
           <a:prstGeom prst="rect">
             <a:avLst/>
@@ -4325,14 +4559,14 @@
       </p:sp>
       <p:sp>
         <p:nvSpPr>
-          <p:cNvPr id="11" name="TextBox 10"/>
+          <p:cNvPr id="12" name="TextBox 11"/>
           <p:cNvSpPr txBox="1"/>
           <p:nvPr/>
         </p:nvSpPr>
         <p:spPr>
           <a:xfrm>
-            <a:off x="6583680" y="2148840"/>
-            <a:ext cx="5150815" cy="457200"/>
+            <a:off x="6537960" y="2194560"/>
+            <a:ext cx="5242255" cy="457200"/>
           </a:xfrm>
           <a:prstGeom prst="rect">
             <a:avLst/>
@@ -4360,14 +4594,14 @@
       </p:sp>
       <p:sp>
         <p:nvSpPr>
-          <p:cNvPr id="12" name="TextBox 11"/>
+          <p:cNvPr id="13" name="TextBox 12"/>
           <p:cNvSpPr txBox="1"/>
           <p:nvPr/>
         </p:nvSpPr>
         <p:spPr>
           <a:xfrm>
-            <a:off x="6583680" y="2788920"/>
-            <a:ext cx="5150815" cy="3474720"/>
+            <a:off x="6537960" y="2834640"/>
+            <a:ext cx="5242255" cy="3291840"/>
           </a:xfrm>
           <a:prstGeom prst="rect">
             <a:avLst/>
@@ -4447,9 +4681,52 @@
         <p:nvPr/>
       </p:nvGrpSpPr>
       <p:grpSpPr/>
+      <p:sp>
+        <p:nvSpPr>
+          <p:cNvPr id="2" name="Rectangle 1"/>
+          <p:cNvSpPr/>
+          <p:nvPr/>
+        </p:nvSpPr>
+        <p:spPr>
+          <a:xfrm>
+            <a:off x="0" y="0"/>
+            <a:ext cx="12191695" cy="777240"/>
+          </a:xfrm>
+          <a:prstGeom prst="rect">
+            <a:avLst/>
+          </a:prstGeom>
+          <a:solidFill>
+            <a:srgbClr val="F2E6CC"/>
+          </a:solidFill>
+          <a:ln>
+            <a:noFill/>
+          </a:ln>
+        </p:spPr>
+        <p:style>
+          <a:lnRef idx="1">
+            <a:schemeClr val="accent1"/>
+          </a:lnRef>
+          <a:fillRef idx="3">
+            <a:schemeClr val="accent1"/>
+          </a:fillRef>
+          <a:effectRef idx="2">
+            <a:schemeClr val="accent1"/>
+          </a:effectRef>
+          <a:fontRef idx="minor">
+            <a:schemeClr val="lt1"/>
+          </a:fontRef>
+        </p:style>
+        <p:txBody>
+          <a:bodyPr rtlCol="0" anchor="ctr"/>
+          <a:lstStyle/>
+          <a:p>
+            <a:pPr algn="ctr"/>
+          </a:p>
+        </p:txBody>
+      </p:sp>
       <p:pic>
         <p:nvPicPr>
-          <p:cNvPr id="2" name="Picture 1" descr="KCL.png"/>
+          <p:cNvPr id="3" name="Picture 2" descr="KCL.png"/>
           <p:cNvPicPr>
             <a:picLocks noChangeAspect="1"/>
           </p:cNvPicPr>
@@ -4463,8 +4740,8 @@
         </p:blipFill>
         <p:spPr>
           <a:xfrm>
-            <a:off x="9111763" y="201168"/>
-            <a:ext cx="831046" cy="411480"/>
+            <a:off x="8619356" y="137160"/>
+            <a:ext cx="1015723" cy="502920"/>
           </a:xfrm>
           <a:prstGeom prst="rect">
             <a:avLst/>
@@ -4473,7 +4750,7 @@
       </p:pic>
       <p:pic>
         <p:nvPicPr>
-          <p:cNvPr id="3" name="Picture 2" descr="KCLNLP.png"/>
+          <p:cNvPr id="4" name="Picture 3" descr="KCLNLP.png"/>
           <p:cNvPicPr>
             <a:picLocks noChangeAspect="1"/>
           </p:cNvPicPr>
@@ -4487,8 +4764,8 @@
         </p:blipFill>
         <p:spPr>
           <a:xfrm>
-            <a:off x="10125688" y="201168"/>
-            <a:ext cx="452782" cy="411480"/>
+            <a:off x="9836246" y="137160"/>
+            <a:ext cx="553400" cy="502920"/>
           </a:xfrm>
           <a:prstGeom prst="rect">
             <a:avLst/>
@@ -4497,7 +4774,7 @@
       </p:pic>
       <p:pic>
         <p:nvPicPr>
-          <p:cNvPr id="4" name="Picture 3" descr="Alan.png"/>
+          <p:cNvPr id="5" name="Picture 4" descr="Alan.png"/>
           <p:cNvPicPr>
             <a:picLocks noChangeAspect="1"/>
           </p:cNvPicPr>
@@ -4511,8 +4788,8 @@
         </p:blipFill>
         <p:spPr>
           <a:xfrm>
-            <a:off x="10761349" y="201168"/>
-            <a:ext cx="973146" cy="411480"/>
+            <a:off x="10590814" y="137160"/>
+            <a:ext cx="1189401" cy="502920"/>
           </a:xfrm>
           <a:prstGeom prst="rect">
             <a:avLst/>
@@ -4521,21 +4798,21 @@
       </p:pic>
       <p:cxnSp>
         <p:nvCxnSpPr>
-          <p:cNvPr id="5" name="Connector 4"/>
+          <p:cNvPr id="6" name="Connector 5"/>
           <p:cNvCxnSpPr/>
           <p:nvPr/>
         </p:nvCxnSpPr>
         <p:spPr>
           <a:xfrm>
-            <a:off x="457200" y="777240"/>
-            <a:ext cx="11277295" cy="0"/>
+            <a:off x="0" y="777240"/>
+            <a:ext cx="12191695" cy="0"/>
           </a:xfrm>
           <a:prstGeom prst="line">
             <a:avLst/>
           </a:prstGeom>
-          <a:ln w="9525">
+          <a:ln w="19050">
             <a:solidFill>
-              <a:srgbClr val="C8963E"/>
+              <a:srgbClr val="D94A1C"/>
             </a:solidFill>
           </a:ln>
         </p:spPr>
@@ -4556,20 +4833,20 @@
       </p:cxnSp>
       <p:sp>
         <p:nvSpPr>
-          <p:cNvPr id="6" name="Rectangle 5"/>
+          <p:cNvPr id="7" name="Rectangle 6"/>
           <p:cNvSpPr/>
           <p:nvPr/>
         </p:nvSpPr>
         <p:spPr>
           <a:xfrm>
-            <a:off x="640080" y="2880360"/>
+            <a:off x="594360" y="2880360"/>
             <a:ext cx="109728" cy="1463040"/>
           </a:xfrm>
           <a:prstGeom prst="rect">
             <a:avLst/>
           </a:prstGeom>
           <a:solidFill>
-            <a:srgbClr val="C8963E"/>
+            <a:srgbClr val="D94A1C"/>
           </a:solidFill>
           <a:ln>
             <a:noFill/>
@@ -4599,13 +4876,13 @@
       </p:sp>
       <p:sp>
         <p:nvSpPr>
-          <p:cNvPr id="7" name="TextBox 6"/>
+          <p:cNvPr id="8" name="TextBox 7"/>
           <p:cNvSpPr txBox="1"/>
           <p:nvPr/>
         </p:nvSpPr>
         <p:spPr>
           <a:xfrm>
-            <a:off x="960120" y="2743200"/>
+            <a:off x="914400" y="2743200"/>
             <a:ext cx="9144000" cy="1463040"/>
           </a:xfrm>
           <a:prstGeom prst="rect">
@@ -4634,13 +4911,13 @@
       </p:sp>
       <p:cxnSp>
         <p:nvCxnSpPr>
-          <p:cNvPr id="8" name="Connector 7"/>
+          <p:cNvPr id="9" name="Connector 8"/>
           <p:cNvCxnSpPr/>
           <p:nvPr/>
         </p:nvCxnSpPr>
         <p:spPr>
           <a:xfrm>
-            <a:off x="960120" y="4343400"/>
+            <a:off x="914400" y="4343400"/>
             <a:ext cx="1691640" cy="0"/>
           </a:xfrm>
           <a:prstGeom prst="line">
@@ -4648,7 +4925,7 @@
           </a:prstGeom>
           <a:ln w="19050">
             <a:solidFill>
-              <a:srgbClr val="C8963E"/>
+              <a:srgbClr val="D94A1C"/>
             </a:solidFill>
           </a:ln>
         </p:spPr>
@@ -4669,13 +4946,13 @@
       </p:cxnSp>
       <p:sp>
         <p:nvSpPr>
-          <p:cNvPr id="9" name="TextBox 8"/>
+          <p:cNvPr id="10" name="TextBox 9"/>
           <p:cNvSpPr txBox="1"/>
           <p:nvPr/>
         </p:nvSpPr>
         <p:spPr>
           <a:xfrm>
-            <a:off x="960120" y="4526280"/>
+            <a:off x="914400" y="4526280"/>
             <a:ext cx="9144000" cy="457200"/>
           </a:xfrm>
           <a:prstGeom prst="rect">
@@ -4704,13 +4981,13 @@
       </p:sp>
       <p:sp>
         <p:nvSpPr>
-          <p:cNvPr id="10" name="TextBox 9"/>
+          <p:cNvPr id="11" name="TextBox 10"/>
           <p:cNvSpPr txBox="1"/>
           <p:nvPr/>
         </p:nvSpPr>
         <p:spPr>
           <a:xfrm>
-            <a:off x="960120" y="5257800"/>
+            <a:off x="914400" y="5257800"/>
             <a:ext cx="9144000" cy="365760"/>
           </a:xfrm>
           <a:prstGeom prst="rect">

</xml_diff>

<commit_message>
put slide titles in the header, switch body to Roman serif
Per user request: slide titles now live inside the cream header band
(left side, as 'Now: <title>') instead of in the body, so content
gets the full slide height to breathe. Taller header (1.05in)
accommodates the larger title. Section, content, and two-column
layouts all take a single 'title' arg — no body title.

Typography: Georgia Bold for titles, Cambria for body (Roman serif,
paired with Georgia for distinct weights). README updated with the
convention and font choices.

Co-Authored-By: Claude Opus 4.7 (1M context) <noreply@anthropic.com>
</commit_message>
<xml_diff>
--- a/templates/tree_yellow_texture/KCLNLP_TreeYellow.pptx
+++ b/templates/tree_yellow_texture/KCLNLP_TreeYellow.pptx
@@ -3101,7 +3101,7 @@
         <p:spPr>
           <a:xfrm>
             <a:off x="0" y="0"/>
-            <a:ext cx="12191695" cy="777240"/>
+            <a:ext cx="12191695" cy="960120"/>
           </a:xfrm>
           <a:prstGeom prst="rect">
             <a:avLst/>
@@ -3151,8 +3151,8 @@
         </p:blipFill>
         <p:spPr>
           <a:xfrm>
-            <a:off x="8619356" y="137160"/>
-            <a:ext cx="1015723" cy="502920"/>
+            <a:off x="8368581" y="205740"/>
+            <a:ext cx="1108061" cy="548640"/>
           </a:xfrm>
           <a:prstGeom prst="rect">
             <a:avLst/>
@@ -3175,8 +3175,8 @@
         </p:blipFill>
         <p:spPr>
           <a:xfrm>
-            <a:off x="9836246" y="137160"/>
-            <a:ext cx="553400" cy="502920"/>
+            <a:off x="9677810" y="205740"/>
+            <a:ext cx="603709" cy="548640"/>
           </a:xfrm>
           <a:prstGeom prst="rect">
             <a:avLst/>
@@ -3199,8 +3199,8 @@
         </p:blipFill>
         <p:spPr>
           <a:xfrm>
-            <a:off x="10590814" y="137160"/>
-            <a:ext cx="1189401" cy="502920"/>
+            <a:off x="10482687" y="205740"/>
+            <a:ext cx="1297528" cy="548640"/>
           </a:xfrm>
           <a:prstGeom prst="rect">
             <a:avLst/>
@@ -3215,7 +3215,7 @@
         </p:nvCxnSpPr>
         <p:spPr>
           <a:xfrm>
-            <a:off x="0" y="777240"/>
+            <a:off x="0" y="960120"/>
             <a:ext cx="12191695" cy="0"/>
           </a:xfrm>
           <a:prstGeom prst="line">
@@ -3250,7 +3250,7 @@
         </p:nvSpPr>
         <p:spPr>
           <a:xfrm>
-            <a:off x="594360" y="2468880"/>
+            <a:off x="594360" y="2560320"/>
             <a:ext cx="109728" cy="1280160"/>
           </a:xfrm>
           <a:prstGeom prst="rect">
@@ -3293,7 +3293,7 @@
         </p:nvSpPr>
         <p:spPr>
           <a:xfrm>
-            <a:off x="914400" y="2377440"/>
+            <a:off x="914400" y="2468880"/>
             <a:ext cx="10058400" cy="1463040"/>
           </a:xfrm>
           <a:prstGeom prst="rect">
@@ -3309,11 +3309,11 @@
           <a:p>
             <a:pPr algn="l"/>
             <a:r>
-              <a:rPr sz="4000" b="1" i="0">
+              <a:rPr sz="4400" b="1" i="0">
                 <a:solidFill>
                   <a:srgbClr val="1F1F1F"/>
                 </a:solidFill>
-                <a:latin typeface="Calibri"/>
+                <a:latin typeface="Georgia"/>
               </a:rPr>
               <a:t>Talk Title Goes Here</a:t>
             </a:r>
@@ -3328,7 +3328,7 @@
         </p:nvSpPr>
         <p:spPr>
           <a:xfrm>
-            <a:off x="914400" y="3749040"/>
+            <a:off x="914400" y="3840480"/>
             <a:ext cx="10058400" cy="548640"/>
           </a:xfrm>
           <a:prstGeom prst="rect">
@@ -3344,11 +3344,11 @@
           <a:p>
             <a:pPr algn="l"/>
             <a:r>
-              <a:rPr sz="1800" b="0" i="1">
+              <a:rPr sz="2000" b="0" i="1">
                 <a:solidFill>
                   <a:srgbClr val="707070"/>
                 </a:solidFill>
-                <a:latin typeface="Calibri"/>
+                <a:latin typeface="Cambria"/>
               </a:rPr>
               <a:t>A concise subtitle or one-line abstract</a:t>
             </a:r>
@@ -3363,7 +3363,7 @@
         </p:nvCxnSpPr>
         <p:spPr>
           <a:xfrm>
-            <a:off x="914400" y="4480560"/>
+            <a:off x="914400" y="4572000"/>
             <a:ext cx="1691640" cy="0"/>
           </a:xfrm>
           <a:prstGeom prst="line">
@@ -3398,7 +3398,7 @@
         </p:nvSpPr>
         <p:spPr>
           <a:xfrm>
-            <a:off x="914400" y="4617720"/>
+            <a:off x="914400" y="4709160"/>
             <a:ext cx="10058400" cy="365760"/>
           </a:xfrm>
           <a:prstGeom prst="rect">
@@ -3418,7 +3418,7 @@
                 <a:solidFill>
                   <a:srgbClr val="1F1F1F"/>
                 </a:solidFill>
-                <a:latin typeface="Calibri"/>
+                <a:latin typeface="Cambria"/>
               </a:rPr>
               <a:t>Speaker Name  ·  Affiliation  ·  Month Year</a:t>
             </a:r>
@@ -3452,7 +3452,7 @@
         <p:spPr>
           <a:xfrm>
             <a:off x="0" y="0"/>
-            <a:ext cx="12191695" cy="777240"/>
+            <a:ext cx="12191695" cy="960120"/>
           </a:xfrm>
           <a:prstGeom prst="rect">
             <a:avLst/>
@@ -3502,8 +3502,8 @@
         </p:blipFill>
         <p:spPr>
           <a:xfrm>
-            <a:off x="8619356" y="137160"/>
-            <a:ext cx="1015723" cy="502920"/>
+            <a:off x="8368581" y="205740"/>
+            <a:ext cx="1108061" cy="548640"/>
           </a:xfrm>
           <a:prstGeom prst="rect">
             <a:avLst/>
@@ -3526,8 +3526,8 @@
         </p:blipFill>
         <p:spPr>
           <a:xfrm>
-            <a:off x="9836246" y="137160"/>
-            <a:ext cx="553400" cy="502920"/>
+            <a:off x="9677810" y="205740"/>
+            <a:ext cx="603709" cy="548640"/>
           </a:xfrm>
           <a:prstGeom prst="rect">
             <a:avLst/>
@@ -3550,8 +3550,8 @@
         </p:blipFill>
         <p:spPr>
           <a:xfrm>
-            <a:off x="10590814" y="137160"/>
-            <a:ext cx="1189401" cy="502920"/>
+            <a:off x="10482687" y="205740"/>
+            <a:ext cx="1297528" cy="548640"/>
           </a:xfrm>
           <a:prstGeom prst="rect">
             <a:avLst/>
@@ -3567,7 +3567,7 @@
         <p:spPr>
           <a:xfrm>
             <a:off x="411480" y="0"/>
-            <a:ext cx="7315200" cy="777240"/>
+            <a:ext cx="7682781" cy="960120"/>
           </a:xfrm>
           <a:prstGeom prst="rect">
             <a:avLst/>
@@ -3586,16 +3586,16 @@
                 <a:solidFill>
                   <a:srgbClr val="D94A1C"/>
                 </a:solidFill>
-                <a:latin typeface="Calibri"/>
+                <a:latin typeface="Georgia"/>
               </a:rPr>
-              <a:t>Now: </a:t>
-            </a:r>
-            <a:r>
-              <a:rPr sz="1600" i="1">
+              <a:t>Now:  </a:t>
+            </a:r>
+            <a:r>
+              <a:rPr sz="2600" b="1">
                 <a:solidFill>
                   <a:srgbClr val="1F1F1F"/>
                 </a:solidFill>
-                <a:latin typeface="Calibri"/>
+                <a:latin typeface="Georgia"/>
               </a:rPr>
               <a:t>Motivation</a:t>
             </a:r>
@@ -3610,7 +3610,7 @@
         </p:nvCxnSpPr>
         <p:spPr>
           <a:xfrm>
-            <a:off x="0" y="777240"/>
+            <a:off x="0" y="960120"/>
             <a:ext cx="12191695" cy="0"/>
           </a:xfrm>
           <a:prstGeom prst="line">
@@ -3645,7 +3645,7 @@
         </p:nvSpPr>
         <p:spPr>
           <a:xfrm>
-            <a:off x="868680" y="2743200"/>
+            <a:off x="868680" y="2926080"/>
             <a:ext cx="1645920" cy="1097280"/>
           </a:xfrm>
           <a:prstGeom prst="rect">
@@ -3665,7 +3665,7 @@
                 <a:solidFill>
                   <a:srgbClr val="D94A1C"/>
                 </a:solidFill>
-                <a:latin typeface="Calibri"/>
+                <a:latin typeface="Georgia"/>
               </a:rPr>
               <a:t>01</a:t>
             </a:r>
@@ -3680,7 +3680,7 @@
         </p:nvCxnSpPr>
         <p:spPr>
           <a:xfrm>
-            <a:off x="2606040" y="2971800"/>
+            <a:off x="2606040" y="3154680"/>
             <a:ext cx="0" cy="822960"/>
           </a:xfrm>
           <a:prstGeom prst="line">
@@ -3715,7 +3715,7 @@
         </p:nvSpPr>
         <p:spPr>
           <a:xfrm>
-            <a:off x="2880360" y="2926080"/>
+            <a:off x="2880360" y="3108960"/>
             <a:ext cx="7315200" cy="914400"/>
           </a:xfrm>
           <a:prstGeom prst="rect">
@@ -3731,11 +3731,11 @@
           <a:p>
             <a:pPr algn="l"/>
             <a:r>
-              <a:rPr sz="3400" b="1" i="0">
+              <a:rPr sz="3600" b="1" i="0">
                 <a:solidFill>
                   <a:srgbClr val="1F1F1F"/>
                 </a:solidFill>
-                <a:latin typeface="Calibri"/>
+                <a:latin typeface="Georgia"/>
               </a:rPr>
               <a:t>Motivation</a:t>
             </a:r>
@@ -3750,7 +3750,7 @@
         </p:nvSpPr>
         <p:spPr>
           <a:xfrm>
-            <a:off x="2880360" y="3703320"/>
+            <a:off x="2880360" y="3886200"/>
             <a:ext cx="7315200" cy="365760"/>
           </a:xfrm>
           <a:prstGeom prst="rect">
@@ -3770,7 +3770,7 @@
                 <a:solidFill>
                   <a:srgbClr val="707070"/>
                 </a:solidFill>
-                <a:latin typeface="Calibri"/>
+                <a:latin typeface="Cambria"/>
               </a:rPr>
               <a:t>An optional one-line summary of this section</a:t>
             </a:r>
@@ -3804,7 +3804,7 @@
         <p:spPr>
           <a:xfrm>
             <a:off x="0" y="0"/>
-            <a:ext cx="12191695" cy="777240"/>
+            <a:ext cx="12191695" cy="960120"/>
           </a:xfrm>
           <a:prstGeom prst="rect">
             <a:avLst/>
@@ -3854,8 +3854,8 @@
         </p:blipFill>
         <p:spPr>
           <a:xfrm>
-            <a:off x="8619356" y="137160"/>
-            <a:ext cx="1015723" cy="502920"/>
+            <a:off x="8368581" y="205740"/>
+            <a:ext cx="1108061" cy="548640"/>
           </a:xfrm>
           <a:prstGeom prst="rect">
             <a:avLst/>
@@ -3878,8 +3878,8 @@
         </p:blipFill>
         <p:spPr>
           <a:xfrm>
-            <a:off x="9836246" y="137160"/>
-            <a:ext cx="553400" cy="502920"/>
+            <a:off x="9677810" y="205740"/>
+            <a:ext cx="603709" cy="548640"/>
           </a:xfrm>
           <a:prstGeom prst="rect">
             <a:avLst/>
@@ -3902,8 +3902,8 @@
         </p:blipFill>
         <p:spPr>
           <a:xfrm>
-            <a:off x="10590814" y="137160"/>
-            <a:ext cx="1189401" cy="502920"/>
+            <a:off x="10482687" y="205740"/>
+            <a:ext cx="1297528" cy="548640"/>
           </a:xfrm>
           <a:prstGeom prst="rect">
             <a:avLst/>
@@ -3919,7 +3919,7 @@
         <p:spPr>
           <a:xfrm>
             <a:off x="411480" y="0"/>
-            <a:ext cx="7315200" cy="777240"/>
+            <a:ext cx="7682781" cy="960120"/>
           </a:xfrm>
           <a:prstGeom prst="rect">
             <a:avLst/>
@@ -3938,18 +3938,18 @@
                 <a:solidFill>
                   <a:srgbClr val="D94A1C"/>
                 </a:solidFill>
-                <a:latin typeface="Calibri"/>
+                <a:latin typeface="Georgia"/>
               </a:rPr>
-              <a:t>Now: </a:t>
-            </a:r>
-            <a:r>
-              <a:rPr sz="1600" i="1">
+              <a:t>Now:  </a:t>
+            </a:r>
+            <a:r>
+              <a:rPr sz="2600" b="1">
                 <a:solidFill>
                   <a:srgbClr val="1F1F1F"/>
                 </a:solidFill>
-                <a:latin typeface="Calibri"/>
+                <a:latin typeface="Georgia"/>
               </a:rPr>
-              <a:t>Motivation</a:t>
+              <a:t>Why retrieval is hard</a:t>
             </a:r>
           </a:p>
         </p:txBody>
@@ -3962,7 +3962,7 @@
         </p:nvCxnSpPr>
         <p:spPr>
           <a:xfrm>
-            <a:off x="0" y="777240"/>
+            <a:off x="0" y="960120"/>
             <a:ext cx="12191695" cy="0"/>
           </a:xfrm>
           <a:prstGeom prst="line">
@@ -3991,57 +3991,14 @@
       </p:cxnSp>
       <p:sp>
         <p:nvSpPr>
-          <p:cNvPr id="8" name="Rectangle 7"/>
-          <p:cNvSpPr/>
-          <p:nvPr/>
-        </p:nvSpPr>
-        <p:spPr>
-          <a:xfrm>
-            <a:off x="502920" y="1261872"/>
-            <a:ext cx="109728" cy="640080"/>
-          </a:xfrm>
-          <a:prstGeom prst="rect">
-            <a:avLst/>
-          </a:prstGeom>
-          <a:solidFill>
-            <a:srgbClr val="D94A1C"/>
-          </a:solidFill>
-          <a:ln>
-            <a:noFill/>
-          </a:ln>
-        </p:spPr>
-        <p:style>
-          <a:lnRef idx="1">
-            <a:schemeClr val="accent1"/>
-          </a:lnRef>
-          <a:fillRef idx="3">
-            <a:schemeClr val="accent1"/>
-          </a:fillRef>
-          <a:effectRef idx="2">
-            <a:schemeClr val="accent1"/>
-          </a:effectRef>
-          <a:fontRef idx="minor">
-            <a:schemeClr val="lt1"/>
-          </a:fontRef>
-        </p:style>
-        <p:txBody>
-          <a:bodyPr rtlCol="0" anchor="ctr"/>
-          <a:lstStyle/>
-          <a:p>
-            <a:pPr algn="ctr"/>
-          </a:p>
-        </p:txBody>
-      </p:sp>
-      <p:sp>
-        <p:nvSpPr>
-          <p:cNvPr id="9" name="TextBox 8"/>
+          <p:cNvPr id="8" name="TextBox 7"/>
           <p:cNvSpPr txBox="1"/>
           <p:nvPr/>
         </p:nvSpPr>
         <p:spPr>
           <a:xfrm>
-            <a:off x="777240" y="1188720"/>
-            <a:ext cx="10058400" cy="822960"/>
+            <a:off x="594360" y="1280160"/>
+            <a:ext cx="11185855" cy="5074920"/>
           </a:xfrm>
           <a:prstGeom prst="rect">
             <a:avLst/>
@@ -4049,34 +4006,102 @@
           <a:noFill/>
         </p:spPr>
         <p:txBody>
-          <a:bodyPr wrap="square" lIns="0" rIns="0" tIns="0" bIns="0" anchor="t">
+          <a:bodyPr wrap="square" lIns="0" rIns="0" tIns="0" bIns="0">
             <a:spAutoFit/>
           </a:bodyPr>
           <a:lstStyle/>
           <a:p>
-            <a:pPr algn="l"/>
-            <a:r>
-              <a:rPr sz="2600" b="1" i="0">
+            <a:pPr algn="l">
+              <a:spcAft>
+                <a:spcPts val="1000"/>
+              </a:spcAft>
+            </a:pPr>
+            <a:r>
+              <a:rPr sz="2000">
                 <a:solidFill>
                   <a:srgbClr val="1F1F1F"/>
                 </a:solidFill>
-                <a:latin typeface="Calibri"/>
+                <a:latin typeface="Cambria"/>
               </a:rPr>
-              <a:t>Slide title</a:t>
-            </a:r>
-          </a:p>
-        </p:txBody>
-      </p:sp>
-      <p:sp>
-        <p:nvSpPr>
-          <p:cNvPr id="10" name="TextBox 9"/>
+              <a:t>•  Lead with the main claim — what the reader should take away</a:t>
+            </a:r>
+          </a:p>
+          <a:p>
+            <a:pPr algn="l">
+              <a:spcAft>
+                <a:spcPts val="1000"/>
+              </a:spcAft>
+            </a:pPr>
+            <a:r>
+              <a:rPr sz="2000">
+                <a:solidFill>
+                  <a:srgbClr val="1F1F1F"/>
+                </a:solidFill>
+                <a:latin typeface="Cambria"/>
+              </a:rPr>
+              <a:t>•  Supporting detail, ideally a number or concrete example</a:t>
+            </a:r>
+          </a:p>
+          <a:p>
+            <a:pPr algn="l">
+              <a:spcAft>
+                <a:spcPts val="1000"/>
+              </a:spcAft>
+            </a:pPr>
+            <a:r>
+              <a:rPr sz="2000">
+                <a:solidFill>
+                  <a:srgbClr val="1F1F1F"/>
+                </a:solidFill>
+                <a:latin typeface="Cambria"/>
+              </a:rPr>
+              <a:t>•  A second supporting point that extends the first</a:t>
+            </a:r>
+          </a:p>
+          <a:p>
+            <a:pPr algn="l">
+              <a:spcAft>
+                <a:spcPts val="1000"/>
+              </a:spcAft>
+            </a:pPr>
+            <a:r>
+              <a:rPr sz="2000">
+                <a:solidFill>
+                  <a:srgbClr val="1F1F1F"/>
+                </a:solidFill>
+                <a:latin typeface="Cambria"/>
+              </a:rPr>
+              <a:t>•  A fourth line of room — titles live in the header, so the body breathes</a:t>
+            </a:r>
+          </a:p>
+          <a:p>
+            <a:pPr algn="l">
+              <a:spcAft>
+                <a:spcPts val="1000"/>
+              </a:spcAft>
+            </a:pPr>
+            <a:r>
+              <a:rPr sz="2000">
+                <a:solidFill>
+                  <a:srgbClr val="1F1F1F"/>
+                </a:solidFill>
+                <a:latin typeface="Cambria"/>
+              </a:rPr>
+              <a:t>•  Edge case, caveat, or the one thing not to forget</a:t>
+            </a:r>
+          </a:p>
+        </p:txBody>
+      </p:sp>
+      <p:sp>
+        <p:nvSpPr>
+          <p:cNvPr id="9" name="TextBox 8"/>
           <p:cNvSpPr txBox="1"/>
           <p:nvPr/>
         </p:nvSpPr>
         <p:spPr>
           <a:xfrm>
-            <a:off x="777240" y="2194560"/>
-            <a:ext cx="10972800" cy="4023360"/>
+            <a:off x="594360" y="6492240"/>
+            <a:ext cx="11185855" cy="274320"/>
           </a:xfrm>
           <a:prstGeom prst="rect">
             <a:avLst/>
@@ -4084,93 +4109,6 @@
           <a:noFill/>
         </p:spPr>
         <p:txBody>
-          <a:bodyPr wrap="square" lIns="0" rIns="0" tIns="0" bIns="0">
-            <a:spAutoFit/>
-          </a:bodyPr>
-          <a:lstStyle/>
-          <a:p>
-            <a:pPr algn="l">
-              <a:spcAft>
-                <a:spcPts val="800"/>
-              </a:spcAft>
-            </a:pPr>
-            <a:r>
-              <a:rPr sz="1800">
-                <a:solidFill>
-                  <a:srgbClr val="1F1F1F"/>
-                </a:solidFill>
-                <a:latin typeface="Calibri"/>
-              </a:rPr>
-              <a:t>•  Lead with the main claim — what the reader should take away</a:t>
-            </a:r>
-          </a:p>
-          <a:p>
-            <a:pPr algn="l">
-              <a:spcAft>
-                <a:spcPts val="800"/>
-              </a:spcAft>
-            </a:pPr>
-            <a:r>
-              <a:rPr sz="1800">
-                <a:solidFill>
-                  <a:srgbClr val="1F1F1F"/>
-                </a:solidFill>
-                <a:latin typeface="Calibri"/>
-              </a:rPr>
-              <a:t>•  Supporting detail, ideally a number or concrete example</a:t>
-            </a:r>
-          </a:p>
-          <a:p>
-            <a:pPr algn="l">
-              <a:spcAft>
-                <a:spcPts val="800"/>
-              </a:spcAft>
-            </a:pPr>
-            <a:r>
-              <a:rPr sz="1800">
-                <a:solidFill>
-                  <a:srgbClr val="1F1F1F"/>
-                </a:solidFill>
-                <a:latin typeface="Calibri"/>
-              </a:rPr>
-              <a:t>•  A second supporting point that extends the first</a:t>
-            </a:r>
-          </a:p>
-          <a:p>
-            <a:pPr algn="l">
-              <a:spcAft>
-                <a:spcPts val="800"/>
-              </a:spcAft>
-            </a:pPr>
-            <a:r>
-              <a:rPr sz="1800">
-                <a:solidFill>
-                  <a:srgbClr val="1F1F1F"/>
-                </a:solidFill>
-                <a:latin typeface="Calibri"/>
-              </a:rPr>
-              <a:t>•  Edge case, caveat, or the one thing not to forget</a:t>
-            </a:r>
-          </a:p>
-        </p:txBody>
-      </p:sp>
-      <p:sp>
-        <p:nvSpPr>
-          <p:cNvPr id="11" name="TextBox 10"/>
-          <p:cNvSpPr txBox="1"/>
-          <p:nvPr/>
-        </p:nvSpPr>
-        <p:spPr>
-          <a:xfrm>
-            <a:off x="777240" y="6492240"/>
-            <a:ext cx="10972800" cy="274320"/>
-          </a:xfrm>
-          <a:prstGeom prst="rect">
-            <a:avLst/>
-          </a:prstGeom>
-          <a:noFill/>
-        </p:spPr>
-        <p:txBody>
           <a:bodyPr wrap="square" lIns="0" rIns="0" tIns="0" bIns="0" anchor="t">
             <a:spAutoFit/>
           </a:bodyPr>
@@ -4182,7 +4120,7 @@
                 <a:solidFill>
                   <a:srgbClr val="707070"/>
                 </a:solidFill>
-                <a:latin typeface="Calibri"/>
+                <a:latin typeface="Cambria"/>
               </a:rPr>
               <a:t>Footer / citation / page note</a:t>
             </a:r>
@@ -4216,7 +4154,7 @@
         <p:spPr>
           <a:xfrm>
             <a:off x="0" y="0"/>
-            <a:ext cx="12191695" cy="777240"/>
+            <a:ext cx="12191695" cy="960120"/>
           </a:xfrm>
           <a:prstGeom prst="rect">
             <a:avLst/>
@@ -4266,8 +4204,8 @@
         </p:blipFill>
         <p:spPr>
           <a:xfrm>
-            <a:off x="8619356" y="137160"/>
-            <a:ext cx="1015723" cy="502920"/>
+            <a:off x="8368581" y="205740"/>
+            <a:ext cx="1108061" cy="548640"/>
           </a:xfrm>
           <a:prstGeom prst="rect">
             <a:avLst/>
@@ -4290,8 +4228,8 @@
         </p:blipFill>
         <p:spPr>
           <a:xfrm>
-            <a:off x="9836246" y="137160"/>
-            <a:ext cx="553400" cy="502920"/>
+            <a:off x="9677810" y="205740"/>
+            <a:ext cx="603709" cy="548640"/>
           </a:xfrm>
           <a:prstGeom prst="rect">
             <a:avLst/>
@@ -4314,8 +4252,8 @@
         </p:blipFill>
         <p:spPr>
           <a:xfrm>
-            <a:off x="10590814" y="137160"/>
-            <a:ext cx="1189401" cy="502920"/>
+            <a:off x="10482687" y="205740"/>
+            <a:ext cx="1297528" cy="548640"/>
           </a:xfrm>
           <a:prstGeom prst="rect">
             <a:avLst/>
@@ -4331,7 +4269,7 @@
         <p:spPr>
           <a:xfrm>
             <a:off x="411480" y="0"/>
-            <a:ext cx="7315200" cy="777240"/>
+            <a:ext cx="7682781" cy="960120"/>
           </a:xfrm>
           <a:prstGeom prst="rect">
             <a:avLst/>
@@ -4350,18 +4288,18 @@
                 <a:solidFill>
                   <a:srgbClr val="D94A1C"/>
                 </a:solidFill>
-                <a:latin typeface="Calibri"/>
+                <a:latin typeface="Georgia"/>
               </a:rPr>
-              <a:t>Now: </a:t>
-            </a:r>
-            <a:r>
-              <a:rPr sz="1600" i="1">
+              <a:t>Now:  </a:t>
+            </a:r>
+            <a:r>
+              <a:rPr sz="2600" b="1">
                 <a:solidFill>
                   <a:srgbClr val="1F1F1F"/>
                 </a:solidFill>
-                <a:latin typeface="Calibri"/>
+                <a:latin typeface="Georgia"/>
               </a:rPr>
-              <a:t>Motivation</a:t>
+              <a:t>Model architecture</a:t>
             </a:r>
           </a:p>
         </p:txBody>
@@ -4374,7 +4312,7 @@
         </p:nvCxnSpPr>
         <p:spPr>
           <a:xfrm>
-            <a:off x="0" y="777240"/>
+            <a:off x="0" y="960120"/>
             <a:ext cx="12191695" cy="0"/>
           </a:xfrm>
           <a:prstGeom prst="line">
@@ -4409,17 +4347,17 @@
         </p:nvSpPr>
         <p:spPr>
           <a:xfrm>
-            <a:off x="502920" y="1261872"/>
-            <a:ext cx="109728" cy="640080"/>
+            <a:off x="594360" y="1280160"/>
+            <a:ext cx="5486400" cy="5120640"/>
           </a:xfrm>
           <a:prstGeom prst="rect">
             <a:avLst/>
           </a:prstGeom>
-          <a:solidFill>
-            <a:srgbClr val="D94A1C"/>
-          </a:solidFill>
-          <a:ln>
-            <a:noFill/>
+          <a:noFill/>
+          <a:ln w="6350">
+            <a:solidFill>
+              <a:srgbClr val="707070"/>
+            </a:solidFill>
           </a:ln>
         </p:spPr>
         <p:style>
@@ -4452,8 +4390,8 @@
         </p:nvSpPr>
         <p:spPr>
           <a:xfrm>
-            <a:off x="777240" y="1188720"/>
-            <a:ext cx="10058400" cy="822960"/>
+            <a:off x="594360" y="1280160"/>
+            <a:ext cx="5486400" cy="5120640"/>
           </a:xfrm>
           <a:prstGeom prst="rect">
             <a:avLst/>
@@ -4461,64 +4399,56 @@
           <a:noFill/>
         </p:spPr>
         <p:txBody>
-          <a:bodyPr wrap="square" lIns="0" rIns="0" tIns="0" bIns="0" anchor="t">
+          <a:bodyPr wrap="square" lIns="0" rIns="0" tIns="0" bIns="0" anchor="ctr">
             <a:spAutoFit/>
           </a:bodyPr>
           <a:lstStyle/>
           <a:p>
-            <a:pPr algn="l"/>
-            <a:r>
-              <a:rPr sz="2600" b="1" i="0">
+            <a:pPr algn="ctr"/>
+            <a:r>
+              <a:rPr sz="1400" b="0" i="1">
                 <a:solidFill>
-                  <a:srgbClr val="1F1F1F"/>
+                  <a:srgbClr val="707070"/>
                 </a:solidFill>
-                <a:latin typeface="Calibri"/>
+                <a:latin typeface="Cambria"/>
               </a:rPr>
-              <a:t>Figure or image + text</a:t>
-            </a:r>
-          </a:p>
-        </p:txBody>
-      </p:sp>
-      <p:sp>
-        <p:nvSpPr>
-          <p:cNvPr id="10" name="Rectangle 9"/>
-          <p:cNvSpPr/>
+              <a:t>[ figure / diagram ]</a:t>
+            </a:r>
+          </a:p>
+        </p:txBody>
+      </p:sp>
+      <p:sp>
+        <p:nvSpPr>
+          <p:cNvPr id="10" name="TextBox 9"/>
+          <p:cNvSpPr txBox="1"/>
           <p:nvPr/>
         </p:nvSpPr>
         <p:spPr>
           <a:xfrm>
-            <a:off x="777240" y="2194560"/>
-            <a:ext cx="5303520" cy="3931920"/>
+            <a:off x="6537960" y="1280160"/>
+            <a:ext cx="5242255" cy="457200"/>
           </a:xfrm>
           <a:prstGeom prst="rect">
             <a:avLst/>
           </a:prstGeom>
           <a:noFill/>
-          <a:ln w="6350">
-            <a:solidFill>
-              <a:srgbClr val="707070"/>
-            </a:solidFill>
-          </a:ln>
-        </p:spPr>
-        <p:style>
-          <a:lnRef idx="1">
-            <a:schemeClr val="accent1"/>
-          </a:lnRef>
-          <a:fillRef idx="3">
-            <a:schemeClr val="accent1"/>
-          </a:fillRef>
-          <a:effectRef idx="2">
-            <a:schemeClr val="accent1"/>
-          </a:effectRef>
-          <a:fontRef idx="minor">
-            <a:schemeClr val="lt1"/>
-          </a:fontRef>
-        </p:style>
-        <p:txBody>
-          <a:bodyPr rtlCol="0" anchor="ctr"/>
-          <a:lstStyle/>
-          <a:p>
-            <a:pPr algn="ctr"/>
+        </p:spPr>
+        <p:txBody>
+          <a:bodyPr wrap="square" lIns="0" rIns="0" tIns="0" bIns="0" anchor="t">
+            <a:spAutoFit/>
+          </a:bodyPr>
+          <a:lstStyle/>
+          <a:p>
+            <a:pPr algn="l"/>
+            <a:r>
+              <a:rPr sz="2200" b="1" i="0">
+                <a:solidFill>
+                  <a:srgbClr val="1F1F1F"/>
+                </a:solidFill>
+                <a:latin typeface="Georgia"/>
+              </a:rPr>
+              <a:t>Caption or claim</a:t>
+            </a:r>
           </a:p>
         </p:txBody>
       </p:sp>
@@ -4530,8 +4460,8 @@
         </p:nvSpPr>
         <p:spPr>
           <a:xfrm>
-            <a:off x="777240" y="2194560"/>
-            <a:ext cx="5303520" cy="3931920"/>
+            <a:off x="6537960" y="2011680"/>
+            <a:ext cx="5242255" cy="4389120"/>
           </a:xfrm>
           <a:prstGeom prst="rect">
             <a:avLst/>
@@ -4539,124 +4469,54 @@
           <a:noFill/>
         </p:spPr>
         <p:txBody>
-          <a:bodyPr wrap="square" lIns="0" rIns="0" tIns="0" bIns="0" anchor="ctr">
+          <a:bodyPr wrap="square" lIns="0" rIns="0" tIns="0" bIns="0">
             <a:spAutoFit/>
           </a:bodyPr>
           <a:lstStyle/>
           <a:p>
-            <a:pPr algn="ctr"/>
-            <a:r>
-              <a:rPr sz="1400" b="0" i="1">
-                <a:solidFill>
-                  <a:srgbClr val="707070"/>
-                </a:solidFill>
-                <a:latin typeface="Calibri"/>
-              </a:rPr>
-              <a:t>[ figure / diagram ]</a:t>
-            </a:r>
-          </a:p>
-        </p:txBody>
-      </p:sp>
-      <p:sp>
-        <p:nvSpPr>
-          <p:cNvPr id="12" name="TextBox 11"/>
-          <p:cNvSpPr txBox="1"/>
-          <p:nvPr/>
-        </p:nvSpPr>
-        <p:spPr>
-          <a:xfrm>
-            <a:off x="6537960" y="2194560"/>
-            <a:ext cx="5242255" cy="457200"/>
-          </a:xfrm>
-          <a:prstGeom prst="rect">
-            <a:avLst/>
-          </a:prstGeom>
-          <a:noFill/>
-        </p:spPr>
-        <p:txBody>
-          <a:bodyPr wrap="square" lIns="0" rIns="0" tIns="0" bIns="0" anchor="t">
-            <a:spAutoFit/>
-          </a:bodyPr>
-          <a:lstStyle/>
-          <a:p>
-            <a:pPr algn="l"/>
-            <a:r>
-              <a:rPr sz="2000" b="1" i="0">
+            <a:pPr algn="l">
+              <a:spcAft>
+                <a:spcPts val="1000"/>
+              </a:spcAft>
+            </a:pPr>
+            <a:r>
+              <a:rPr sz="1700">
                 <a:solidFill>
                   <a:srgbClr val="1F1F1F"/>
                 </a:solidFill>
-                <a:latin typeface="Calibri"/>
+                <a:latin typeface="Cambria"/>
               </a:rPr>
-              <a:t>Caption or claim</a:t>
-            </a:r>
-          </a:p>
-        </p:txBody>
-      </p:sp>
-      <p:sp>
-        <p:nvSpPr>
-          <p:cNvPr id="13" name="TextBox 12"/>
-          <p:cNvSpPr txBox="1"/>
-          <p:nvPr/>
-        </p:nvSpPr>
-        <p:spPr>
-          <a:xfrm>
-            <a:off x="6537960" y="2834640"/>
-            <a:ext cx="5242255" cy="3291840"/>
-          </a:xfrm>
-          <a:prstGeom prst="rect">
-            <a:avLst/>
-          </a:prstGeom>
-          <a:noFill/>
-        </p:spPr>
-        <p:txBody>
-          <a:bodyPr wrap="square" lIns="0" rIns="0" tIns="0" bIns="0">
-            <a:spAutoFit/>
-          </a:bodyPr>
-          <a:lstStyle/>
+              <a:t>•  Explain what the figure shows</a:t>
+            </a:r>
+          </a:p>
           <a:p>
             <a:pPr algn="l">
               <a:spcAft>
-                <a:spcPts val="800"/>
+                <a:spcPts val="1000"/>
               </a:spcAft>
             </a:pPr>
             <a:r>
-              <a:rPr sz="1500">
+              <a:rPr sz="1700">
                 <a:solidFill>
                   <a:srgbClr val="1F1F1F"/>
                 </a:solidFill>
-                <a:latin typeface="Calibri"/>
+                <a:latin typeface="Cambria"/>
               </a:rPr>
-              <a:t>•  Explain what the figure shows</a:t>
+              <a:t>•  Call out the one feature worth noting</a:t>
             </a:r>
           </a:p>
           <a:p>
             <a:pPr algn="l">
               <a:spcAft>
-                <a:spcPts val="800"/>
+                <a:spcPts val="1000"/>
               </a:spcAft>
             </a:pPr>
             <a:r>
-              <a:rPr sz="1500">
+              <a:rPr sz="1700">
                 <a:solidFill>
                   <a:srgbClr val="1F1F1F"/>
                 </a:solidFill>
-                <a:latin typeface="Calibri"/>
-              </a:rPr>
-              <a:t>•  Call out the one feature worth noting</a:t>
-            </a:r>
-          </a:p>
-          <a:p>
-            <a:pPr algn="l">
-              <a:spcAft>
-                <a:spcPts val="800"/>
-              </a:spcAft>
-            </a:pPr>
-            <a:r>
-              <a:rPr sz="1500">
-                <a:solidFill>
-                  <a:srgbClr val="1F1F1F"/>
-                </a:solidFill>
-                <a:latin typeface="Calibri"/>
+                <a:latin typeface="Cambria"/>
               </a:rPr>
               <a:t>•  Relate it back to the slide's main point</a:t>
             </a:r>
@@ -4690,7 +4550,7 @@
         <p:spPr>
           <a:xfrm>
             <a:off x="0" y="0"/>
-            <a:ext cx="12191695" cy="777240"/>
+            <a:ext cx="12191695" cy="960120"/>
           </a:xfrm>
           <a:prstGeom prst="rect">
             <a:avLst/>
@@ -4740,8 +4600,8 @@
         </p:blipFill>
         <p:spPr>
           <a:xfrm>
-            <a:off x="8619356" y="137160"/>
-            <a:ext cx="1015723" cy="502920"/>
+            <a:off x="8368581" y="205740"/>
+            <a:ext cx="1108061" cy="548640"/>
           </a:xfrm>
           <a:prstGeom prst="rect">
             <a:avLst/>
@@ -4764,8 +4624,8 @@
         </p:blipFill>
         <p:spPr>
           <a:xfrm>
-            <a:off x="9836246" y="137160"/>
-            <a:ext cx="553400" cy="502920"/>
+            <a:off x="9677810" y="205740"/>
+            <a:ext cx="603709" cy="548640"/>
           </a:xfrm>
           <a:prstGeom prst="rect">
             <a:avLst/>
@@ -4788,8 +4648,8 @@
         </p:blipFill>
         <p:spPr>
           <a:xfrm>
-            <a:off x="10590814" y="137160"/>
-            <a:ext cx="1189401" cy="502920"/>
+            <a:off x="10482687" y="205740"/>
+            <a:ext cx="1297528" cy="548640"/>
           </a:xfrm>
           <a:prstGeom prst="rect">
             <a:avLst/>
@@ -4804,7 +4664,7 @@
         </p:nvCxnSpPr>
         <p:spPr>
           <a:xfrm>
-            <a:off x="0" y="777240"/>
+            <a:off x="0" y="960120"/>
             <a:ext cx="12191695" cy="0"/>
           </a:xfrm>
           <a:prstGeom prst="line">
@@ -4902,7 +4762,7 @@
                 <a:solidFill>
                   <a:srgbClr val="1F1F1F"/>
                 </a:solidFill>
-                <a:latin typeface="Calibri"/>
+                <a:latin typeface="Georgia"/>
               </a:rPr>
               <a:t>Thank you</a:t>
             </a:r>
@@ -4972,7 +4832,7 @@
                 <a:solidFill>
                   <a:srgbClr val="707070"/>
                 </a:solidFill>
-                <a:latin typeface="Calibri"/>
+                <a:latin typeface="Cambria"/>
               </a:rPr>
               <a:t>Questions &amp; discussion</a:t>
             </a:r>
@@ -5007,7 +4867,7 @@
                 <a:solidFill>
                   <a:srgbClr val="1F1F1F"/>
                 </a:solidFill>
-                <a:latin typeface="Calibri"/>
+                <a:latin typeface="Cambria"/>
               </a:rPr>
               <a:t>speaker@kcl.ac.uk  ·  kclnlp.github.io</a:t>
             </a:r>

</xml_diff>

<commit_message>
use generic placeholder titles in demo deck
Swap 'Why retrieval is hard' and 'Model architecture' for the
neutral 'Slide title' placeholder so nothing in the template
hints at a specific talk's content — users fill these in.

Co-Authored-By: Claude Opus 4.7 (1M context) <noreply@anthropic.com>
</commit_message>
<xml_diff>
--- a/templates/tree_yellow_texture/KCLNLP_TreeYellow.pptx
+++ b/templates/tree_yellow_texture/KCLNLP_TreeYellow.pptx
@@ -3597,7 +3597,7 @@
                 </a:solidFill>
                 <a:latin typeface="Georgia"/>
               </a:rPr>
-              <a:t>Motivation</a:t>
+              <a:t>Section heading</a:t>
             </a:r>
           </a:p>
         </p:txBody>
@@ -3737,7 +3737,7 @@
                 </a:solidFill>
                 <a:latin typeface="Georgia"/>
               </a:rPr>
-              <a:t>Motivation</a:t>
+              <a:t>Section heading</a:t>
             </a:r>
           </a:p>
         </p:txBody>
@@ -3949,7 +3949,7 @@
                 </a:solidFill>
                 <a:latin typeface="Georgia"/>
               </a:rPr>
-              <a:t>Why retrieval is hard</a:t>
+              <a:t>Slide title</a:t>
             </a:r>
           </a:p>
         </p:txBody>
@@ -4299,7 +4299,7 @@
                 </a:solidFill>
                 <a:latin typeface="Georgia"/>
               </a:rPr>
-              <a:t>Model architecture</a:t>
+              <a:t>Slide title</a:t>
             </a:r>
           </a:p>
         </p:txBody>

</xml_diff>

<commit_message>
align section divider: center '01' and title on the same row
Previous layout anchored both text boxes to TOP with different font
sizes, so the larger '01' rendered visually below the section title.
Give both boxes the same row top/height and anchor MIDDLE so their
rendered glyphs share a centerline.

Co-Authored-By: Claude Opus 4.7 (1M context) <noreply@anthropic.com>
</commit_message>
<xml_diff>
--- a/templates/tree_yellow_texture/KCLNLP_TreeYellow.pptx
+++ b/templates/tree_yellow_texture/KCLNLP_TreeYellow.pptx
@@ -3645,8 +3645,8 @@
         </p:nvSpPr>
         <p:spPr>
           <a:xfrm>
-            <a:off x="868680" y="2926080"/>
-            <a:ext cx="1645920" cy="1097280"/>
+            <a:off x="868680" y="2880360"/>
+            <a:ext cx="1645920" cy="1280160"/>
           </a:xfrm>
           <a:prstGeom prst="rect">
             <a:avLst/>
@@ -3654,7 +3654,7 @@
           <a:noFill/>
         </p:spPr>
         <p:txBody>
-          <a:bodyPr wrap="square" lIns="0" rIns="0" tIns="0" bIns="0" anchor="t">
+          <a:bodyPr wrap="square" lIns="0" rIns="0" tIns="0" bIns="0" anchor="ctr">
             <a:spAutoFit/>
           </a:bodyPr>
           <a:lstStyle/>
@@ -3680,7 +3680,7 @@
         </p:nvCxnSpPr>
         <p:spPr>
           <a:xfrm>
-            <a:off x="2606040" y="3154680"/>
+            <a:off x="2606040" y="3108960"/>
             <a:ext cx="0" cy="822960"/>
           </a:xfrm>
           <a:prstGeom prst="line">
@@ -3715,8 +3715,8 @@
         </p:nvSpPr>
         <p:spPr>
           <a:xfrm>
-            <a:off x="2880360" y="3108960"/>
-            <a:ext cx="7315200" cy="914400"/>
+            <a:off x="2880360" y="2880360"/>
+            <a:ext cx="7315200" cy="1280160"/>
           </a:xfrm>
           <a:prstGeom prst="rect">
             <a:avLst/>
@@ -3724,7 +3724,7 @@
           <a:noFill/>
         </p:spPr>
         <p:txBody>
-          <a:bodyPr wrap="square" lIns="0" rIns="0" tIns="0" bIns="0" anchor="t">
+          <a:bodyPr wrap="square" lIns="0" rIns="0" tIns="0" bIns="0" anchor="ctr">
             <a:spAutoFit/>
           </a:bodyPr>
           <a:lstStyle/>
@@ -3750,7 +3750,7 @@
         </p:nvSpPr>
         <p:spPr>
           <a:xfrm>
-            <a:off x="2880360" y="3886200"/>
+            <a:off x="2880360" y="4206240"/>
             <a:ext cx="7315200" cy="365760"/>
           </a:xfrm>
           <a:prstGeom prst="rect">

</xml_diff>

<commit_message>
enlarge and darken muted captions for readability
Small grey sublines (subtitles, section summaries, footer notes,
figure placeholders) were hard to read. Bump sizes up across the
board and darken the MUTED tone from #707070 to #555555:

- SZ_SUBTITLE 20 -> 22, SZ_CAPTION 11 -> 14
- section summary 14 -> 18
- figure placeholder 14 -> 18
- thank-you 'Questions & discussion' 20 -> 22
- title-slide speaker line 14 -> 16
- two-column body bullets 17 -> 18
- thank-you contact line 14 -> 16

Co-Authored-By: Claude Opus 4.7 (1M context) <noreply@anthropic.com>
</commit_message>
<xml_diff>
--- a/templates/tree_yellow_texture/KCLNLP_TreeYellow.pptx
+++ b/templates/tree_yellow_texture/KCLNLP_TreeYellow.pptx
@@ -3344,9 +3344,9 @@
           <a:p>
             <a:pPr algn="l"/>
             <a:r>
-              <a:rPr sz="2000" b="0" i="1">
+              <a:rPr sz="2200" b="0" i="1">
                 <a:solidFill>
-                  <a:srgbClr val="707070"/>
+                  <a:srgbClr val="555555"/>
                 </a:solidFill>
                 <a:latin typeface="Cambria"/>
               </a:rPr>
@@ -3414,7 +3414,7 @@
           <a:p>
             <a:pPr algn="l"/>
             <a:r>
-              <a:rPr sz="1400" b="0" i="0">
+              <a:rPr sz="1600" b="0" i="0">
                 <a:solidFill>
                   <a:srgbClr val="1F1F1F"/>
                 </a:solidFill>
@@ -3751,7 +3751,7 @@
         <p:spPr>
           <a:xfrm>
             <a:off x="2880360" y="4206240"/>
-            <a:ext cx="7315200" cy="365760"/>
+            <a:ext cx="7315200" cy="457200"/>
           </a:xfrm>
           <a:prstGeom prst="rect">
             <a:avLst/>
@@ -3766,9 +3766,9 @@
           <a:p>
             <a:pPr algn="l"/>
             <a:r>
-              <a:rPr sz="1400" b="0" i="1">
+              <a:rPr sz="1800" b="0" i="1">
                 <a:solidFill>
-                  <a:srgbClr val="707070"/>
+                  <a:srgbClr val="555555"/>
                 </a:solidFill>
                 <a:latin typeface="Cambria"/>
               </a:rPr>
@@ -4100,8 +4100,8 @@
         </p:nvSpPr>
         <p:spPr>
           <a:xfrm>
-            <a:off x="594360" y="6492240"/>
-            <a:ext cx="11185855" cy="274320"/>
+            <a:off x="594360" y="6446520"/>
+            <a:ext cx="11185855" cy="320040"/>
           </a:xfrm>
           <a:prstGeom prst="rect">
             <a:avLst/>
@@ -4116,9 +4116,9 @@
           <a:p>
             <a:pPr algn="l"/>
             <a:r>
-              <a:rPr sz="1100" b="0" i="1">
+              <a:rPr sz="1400" b="0" i="1">
                 <a:solidFill>
-                  <a:srgbClr val="707070"/>
+                  <a:srgbClr val="555555"/>
                 </a:solidFill>
                 <a:latin typeface="Cambria"/>
               </a:rPr>
@@ -4356,7 +4356,7 @@
           <a:noFill/>
           <a:ln w="6350">
             <a:solidFill>
-              <a:srgbClr val="707070"/>
+              <a:srgbClr val="555555"/>
             </a:solidFill>
           </a:ln>
         </p:spPr>
@@ -4406,9 +4406,9 @@
           <a:p>
             <a:pPr algn="ctr"/>
             <a:r>
-              <a:rPr sz="1400" b="0" i="1">
+              <a:rPr sz="1800" b="0" i="1">
                 <a:solidFill>
-                  <a:srgbClr val="707070"/>
+                  <a:srgbClr val="555555"/>
                 </a:solidFill>
                 <a:latin typeface="Cambria"/>
               </a:rPr>
@@ -4480,7 +4480,7 @@
               </a:spcAft>
             </a:pPr>
             <a:r>
-              <a:rPr sz="1700">
+              <a:rPr sz="1800">
                 <a:solidFill>
                   <a:srgbClr val="1F1F1F"/>
                 </a:solidFill>
@@ -4496,7 +4496,7 @@
               </a:spcAft>
             </a:pPr>
             <a:r>
-              <a:rPr sz="1700">
+              <a:rPr sz="1800">
                 <a:solidFill>
                   <a:srgbClr val="1F1F1F"/>
                 </a:solidFill>
@@ -4512,7 +4512,7 @@
               </a:spcAft>
             </a:pPr>
             <a:r>
-              <a:rPr sz="1700">
+              <a:rPr sz="1800">
                 <a:solidFill>
                   <a:srgbClr val="1F1F1F"/>
                 </a:solidFill>
@@ -4813,7 +4813,7 @@
         <p:spPr>
           <a:xfrm>
             <a:off x="914400" y="4526280"/>
-            <a:ext cx="9144000" cy="457200"/>
+            <a:ext cx="9144000" cy="548640"/>
           </a:xfrm>
           <a:prstGeom prst="rect">
             <a:avLst/>
@@ -4828,9 +4828,9 @@
           <a:p>
             <a:pPr algn="l"/>
             <a:r>
-              <a:rPr sz="2000" b="0" i="1">
+              <a:rPr sz="2200" b="0" i="1">
                 <a:solidFill>
-                  <a:srgbClr val="707070"/>
+                  <a:srgbClr val="555555"/>
                 </a:solidFill>
                 <a:latin typeface="Cambria"/>
               </a:rPr>
@@ -4847,8 +4847,8 @@
         </p:nvSpPr>
         <p:spPr>
           <a:xfrm>
-            <a:off x="914400" y="5257800"/>
-            <a:ext cx="9144000" cy="365760"/>
+            <a:off x="914400" y="5349240"/>
+            <a:ext cx="9144000" cy="411480"/>
           </a:xfrm>
           <a:prstGeom prst="rect">
             <a:avLst/>
@@ -4863,7 +4863,7 @@
           <a:p>
             <a:pPr algn="l"/>
             <a:r>
-              <a:rPr sz="1400" b="0" i="0">
+              <a:rPr sz="1600" b="0" i="0">
                 <a:solidFill>
                   <a:srgbClr val="1F1F1F"/>
                 </a:solidFill>

</xml_diff>

<commit_message>
make header slide titles bold + italic
Match the 'Now:' eyebrow styling: the slide title in the header is
now rendered bold and italic in Georgia (previously just bold), so
the whole header label reads as one italicised running title.

Co-Authored-By: Claude Opus 4.7 (1M context) <noreply@anthropic.com>
</commit_message>
<xml_diff>
--- a/templates/tree_yellow_texture/KCLNLP_TreeYellow.pptx
+++ b/templates/tree_yellow_texture/KCLNLP_TreeYellow.pptx
@@ -3591,7 +3591,7 @@
               <a:t>Now:  </a:t>
             </a:r>
             <a:r>
-              <a:rPr sz="2600" b="1">
+              <a:rPr sz="2600" b="1" i="1">
                 <a:solidFill>
                   <a:srgbClr val="1F1F1F"/>
                 </a:solidFill>
@@ -3943,7 +3943,7 @@
               <a:t>Now:  </a:t>
             </a:r>
             <a:r>
-              <a:rPr sz="2600" b="1">
+              <a:rPr sz="2600" b="1" i="1">
                 <a:solidFill>
                   <a:srgbClr val="1F1F1F"/>
                 </a:solidFill>
@@ -4293,7 +4293,7 @@
               <a:t>Now:  </a:t>
             </a:r>
             <a:r>
-              <a:rPr sz="2600" b="1">
+              <a:rPr sz="2600" b="1" i="1">
                 <a:solidFill>
                   <a:srgbClr val="1F1F1F"/>
                 </a:solidFill>

</xml_diff>

<commit_message>
switch typography to Calibri for titles and body
Both FONT_HEAD and FONT_BODY are Calibri now; the header title
still distinguishes itself via bold + italic, and body stays regular.
README updated to match.

Co-Authored-By: Claude Opus 4.7 (1M context) <noreply@anthropic.com>
</commit_message>
<xml_diff>
--- a/templates/tree_yellow_texture/KCLNLP_TreeYellow.pptx
+++ b/templates/tree_yellow_texture/KCLNLP_TreeYellow.pptx
@@ -3313,7 +3313,7 @@
                 <a:solidFill>
                   <a:srgbClr val="1F1F1F"/>
                 </a:solidFill>
-                <a:latin typeface="Georgia"/>
+                <a:latin typeface="Calibri"/>
               </a:rPr>
               <a:t>Talk Title Goes Here</a:t>
             </a:r>
@@ -3348,7 +3348,7 @@
                 <a:solidFill>
                   <a:srgbClr val="555555"/>
                 </a:solidFill>
-                <a:latin typeface="Cambria"/>
+                <a:latin typeface="Calibri"/>
               </a:rPr>
               <a:t>A concise subtitle or one-line abstract</a:t>
             </a:r>
@@ -3418,7 +3418,7 @@
                 <a:solidFill>
                   <a:srgbClr val="1F1F1F"/>
                 </a:solidFill>
-                <a:latin typeface="Cambria"/>
+                <a:latin typeface="Calibri"/>
               </a:rPr>
               <a:t>Speaker Name  ·  Affiliation  ·  Month Year</a:t>
             </a:r>
@@ -3586,7 +3586,7 @@
                 <a:solidFill>
                   <a:srgbClr val="D94A1C"/>
                 </a:solidFill>
-                <a:latin typeface="Georgia"/>
+                <a:latin typeface="Calibri"/>
               </a:rPr>
               <a:t>Now:  </a:t>
             </a:r>
@@ -3595,7 +3595,7 @@
                 <a:solidFill>
                   <a:srgbClr val="1F1F1F"/>
                 </a:solidFill>
-                <a:latin typeface="Georgia"/>
+                <a:latin typeface="Calibri"/>
               </a:rPr>
               <a:t>Section heading</a:t>
             </a:r>
@@ -3665,7 +3665,7 @@
                 <a:solidFill>
                   <a:srgbClr val="D94A1C"/>
                 </a:solidFill>
-                <a:latin typeface="Georgia"/>
+                <a:latin typeface="Calibri"/>
               </a:rPr>
               <a:t>01</a:t>
             </a:r>
@@ -3735,7 +3735,7 @@
                 <a:solidFill>
                   <a:srgbClr val="1F1F1F"/>
                 </a:solidFill>
-                <a:latin typeface="Georgia"/>
+                <a:latin typeface="Calibri"/>
               </a:rPr>
               <a:t>Section heading</a:t>
             </a:r>
@@ -3770,7 +3770,7 @@
                 <a:solidFill>
                   <a:srgbClr val="555555"/>
                 </a:solidFill>
-                <a:latin typeface="Cambria"/>
+                <a:latin typeface="Calibri"/>
               </a:rPr>
               <a:t>An optional one-line summary of this section</a:t>
             </a:r>
@@ -3938,7 +3938,7 @@
                 <a:solidFill>
                   <a:srgbClr val="D94A1C"/>
                 </a:solidFill>
-                <a:latin typeface="Georgia"/>
+                <a:latin typeface="Calibri"/>
               </a:rPr>
               <a:t>Now:  </a:t>
             </a:r>
@@ -3947,7 +3947,7 @@
                 <a:solidFill>
                   <a:srgbClr val="1F1F1F"/>
                 </a:solidFill>
-                <a:latin typeface="Georgia"/>
+                <a:latin typeface="Calibri"/>
               </a:rPr>
               <a:t>Slide title</a:t>
             </a:r>
@@ -4021,7 +4021,7 @@
                 <a:solidFill>
                   <a:srgbClr val="1F1F1F"/>
                 </a:solidFill>
-                <a:latin typeface="Cambria"/>
+                <a:latin typeface="Calibri"/>
               </a:rPr>
               <a:t>•  Lead with the main claim — what the reader should take away</a:t>
             </a:r>
@@ -4037,7 +4037,7 @@
                 <a:solidFill>
                   <a:srgbClr val="1F1F1F"/>
                 </a:solidFill>
-                <a:latin typeface="Cambria"/>
+                <a:latin typeface="Calibri"/>
               </a:rPr>
               <a:t>•  Supporting detail, ideally a number or concrete example</a:t>
             </a:r>
@@ -4053,7 +4053,7 @@
                 <a:solidFill>
                   <a:srgbClr val="1F1F1F"/>
                 </a:solidFill>
-                <a:latin typeface="Cambria"/>
+                <a:latin typeface="Calibri"/>
               </a:rPr>
               <a:t>•  A second supporting point that extends the first</a:t>
             </a:r>
@@ -4069,7 +4069,7 @@
                 <a:solidFill>
                   <a:srgbClr val="1F1F1F"/>
                 </a:solidFill>
-                <a:latin typeface="Cambria"/>
+                <a:latin typeface="Calibri"/>
               </a:rPr>
               <a:t>•  A fourth line of room — titles live in the header, so the body breathes</a:t>
             </a:r>
@@ -4085,7 +4085,7 @@
                 <a:solidFill>
                   <a:srgbClr val="1F1F1F"/>
                 </a:solidFill>
-                <a:latin typeface="Cambria"/>
+                <a:latin typeface="Calibri"/>
               </a:rPr>
               <a:t>•  Edge case, caveat, or the one thing not to forget</a:t>
             </a:r>
@@ -4120,7 +4120,7 @@
                 <a:solidFill>
                   <a:srgbClr val="555555"/>
                 </a:solidFill>
-                <a:latin typeface="Cambria"/>
+                <a:latin typeface="Calibri"/>
               </a:rPr>
               <a:t>Footer / citation / page note</a:t>
             </a:r>
@@ -4288,7 +4288,7 @@
                 <a:solidFill>
                   <a:srgbClr val="D94A1C"/>
                 </a:solidFill>
-                <a:latin typeface="Georgia"/>
+                <a:latin typeface="Calibri"/>
               </a:rPr>
               <a:t>Now:  </a:t>
             </a:r>
@@ -4297,7 +4297,7 @@
                 <a:solidFill>
                   <a:srgbClr val="1F1F1F"/>
                 </a:solidFill>
-                <a:latin typeface="Georgia"/>
+                <a:latin typeface="Calibri"/>
               </a:rPr>
               <a:t>Slide title</a:t>
             </a:r>
@@ -4410,7 +4410,7 @@
                 <a:solidFill>
                   <a:srgbClr val="555555"/>
                 </a:solidFill>
-                <a:latin typeface="Cambria"/>
+                <a:latin typeface="Calibri"/>
               </a:rPr>
               <a:t>[ figure / diagram ]</a:t>
             </a:r>
@@ -4445,7 +4445,7 @@
                 <a:solidFill>
                   <a:srgbClr val="1F1F1F"/>
                 </a:solidFill>
-                <a:latin typeface="Georgia"/>
+                <a:latin typeface="Calibri"/>
               </a:rPr>
               <a:t>Caption or claim</a:t>
             </a:r>
@@ -4484,7 +4484,7 @@
                 <a:solidFill>
                   <a:srgbClr val="1F1F1F"/>
                 </a:solidFill>
-                <a:latin typeface="Cambria"/>
+                <a:latin typeface="Calibri"/>
               </a:rPr>
               <a:t>•  Explain what the figure shows</a:t>
             </a:r>
@@ -4500,7 +4500,7 @@
                 <a:solidFill>
                   <a:srgbClr val="1F1F1F"/>
                 </a:solidFill>
-                <a:latin typeface="Cambria"/>
+                <a:latin typeface="Calibri"/>
               </a:rPr>
               <a:t>•  Call out the one feature worth noting</a:t>
             </a:r>
@@ -4516,7 +4516,7 @@
                 <a:solidFill>
                   <a:srgbClr val="1F1F1F"/>
                 </a:solidFill>
-                <a:latin typeface="Cambria"/>
+                <a:latin typeface="Calibri"/>
               </a:rPr>
               <a:t>•  Relate it back to the slide's main point</a:t>
             </a:r>
@@ -4762,7 +4762,7 @@
                 <a:solidFill>
                   <a:srgbClr val="1F1F1F"/>
                 </a:solidFill>
-                <a:latin typeface="Georgia"/>
+                <a:latin typeface="Calibri"/>
               </a:rPr>
               <a:t>Thank you</a:t>
             </a:r>
@@ -4832,7 +4832,7 @@
                 <a:solidFill>
                   <a:srgbClr val="555555"/>
                 </a:solidFill>
-                <a:latin typeface="Cambria"/>
+                <a:latin typeface="Calibri"/>
               </a:rPr>
               <a:t>Questions &amp; discussion</a:t>
             </a:r>
@@ -4867,7 +4867,7 @@
                 <a:solidFill>
                   <a:srgbClr val="1F1F1F"/>
                 </a:solidFill>
-                <a:latin typeface="Cambria"/>
+                <a:latin typeface="Calibri"/>
               </a:rPr>
               <a:t>speaker@kcl.ac.uk  ·  kclnlp.github.io</a:t>
             </a:r>

</xml_diff>

<commit_message>
add centered variants of title and thank-you slides
Add slide_title_centered() and slide_thanks_centered() for talks
that prefer the cover / closing to sit in the middle of the page.
Both variants anchor their content to the vertical center of the
body area below the header and use a short horizontal orange
accent bar above the title (in place of the left vertical bar).
Demo deck now renders both the original left-aligned versions and
the new centered versions so users can pick per deck.

Co-Authored-By: Claude Opus 4.7 (1M context) <noreply@anthropic.com>
</commit_message>
<xml_diff>
--- a/templates/tree_yellow_texture/KCLNLP_TreeYellow.pptx
+++ b/templates/tree_yellow_texture/KCLNLP_TreeYellow.pptx
@@ -10,6 +10,8 @@
     <p:sldId id="258" r:id="rId9"/>
     <p:sldId id="259" r:id="rId10"/>
     <p:sldId id="260" r:id="rId11"/>
+    <p:sldId id="261" r:id="rId12"/>
+    <p:sldId id="262" r:id="rId13"/>
   </p:sldIdLst>
   <p:sldSz cx="12191695" cy="6858000" type="screen4x3"/>
   <p:notesSz cx="6858000" cy="9144000"/>
@@ -3558,53 +3560,9 @@
           </a:prstGeom>
         </p:spPr>
       </p:pic>
-      <p:sp>
-        <p:nvSpPr>
-          <p:cNvPr id="6" name="TextBox 5"/>
-          <p:cNvSpPr txBox="1"/>
-          <p:nvPr/>
-        </p:nvSpPr>
-        <p:spPr>
-          <a:xfrm>
-            <a:off x="411480" y="0"/>
-            <a:ext cx="7682781" cy="960120"/>
-          </a:xfrm>
-          <a:prstGeom prst="rect">
-            <a:avLst/>
-          </a:prstGeom>
-          <a:noFill/>
-        </p:spPr>
-        <p:txBody>
-          <a:bodyPr wrap="square" lIns="0" rIns="0" tIns="0" bIns="0" anchor="ctr">
-            <a:spAutoFit/>
-          </a:bodyPr>
-          <a:lstStyle/>
-          <a:p>
-            <a:pPr algn="l"/>
-            <a:r>
-              <a:rPr sz="1600" b="1" i="1">
-                <a:solidFill>
-                  <a:srgbClr val="D94A1C"/>
-                </a:solidFill>
-                <a:latin typeface="Calibri"/>
-              </a:rPr>
-              <a:t>Now:  </a:t>
-            </a:r>
-            <a:r>
-              <a:rPr sz="2600" b="1" i="1">
-                <a:solidFill>
-                  <a:srgbClr val="1F1F1F"/>
-                </a:solidFill>
-                <a:latin typeface="Calibri"/>
-              </a:rPr>
-              <a:t>Section heading</a:t>
-            </a:r>
-          </a:p>
-        </p:txBody>
-      </p:sp>
       <p:cxnSp>
         <p:nvCxnSpPr>
-          <p:cNvPr id="7" name="Connector 6"/>
+          <p:cNvPr id="6" name="Connector 5"/>
           <p:cNvCxnSpPr/>
           <p:nvPr/>
         </p:nvCxnSpPr>
@@ -3639,14 +3597,57 @@
       </p:cxnSp>
       <p:sp>
         <p:nvSpPr>
+          <p:cNvPr id="7" name="Rectangle 6"/>
+          <p:cNvSpPr/>
+          <p:nvPr/>
+        </p:nvSpPr>
+        <p:spPr>
+          <a:xfrm>
+            <a:off x="5364327" y="2263140"/>
+            <a:ext cx="1463040" cy="54864"/>
+          </a:xfrm>
+          <a:prstGeom prst="rect">
+            <a:avLst/>
+          </a:prstGeom>
+          <a:solidFill>
+            <a:srgbClr val="D94A1C"/>
+          </a:solidFill>
+          <a:ln>
+            <a:noFill/>
+          </a:ln>
+        </p:spPr>
+        <p:style>
+          <a:lnRef idx="1">
+            <a:schemeClr val="accent1"/>
+          </a:lnRef>
+          <a:fillRef idx="3">
+            <a:schemeClr val="accent1"/>
+          </a:fillRef>
+          <a:effectRef idx="2">
+            <a:schemeClr val="accent1"/>
+          </a:effectRef>
+          <a:fontRef idx="minor">
+            <a:schemeClr val="lt1"/>
+          </a:fontRef>
+        </p:style>
+        <p:txBody>
+          <a:bodyPr rtlCol="0" anchor="ctr"/>
+          <a:lstStyle/>
+          <a:p>
+            <a:pPr algn="ctr"/>
+          </a:p>
+        </p:txBody>
+      </p:sp>
+      <p:sp>
+        <p:nvSpPr>
           <p:cNvPr id="8" name="TextBox 7"/>
           <p:cNvSpPr txBox="1"/>
           <p:nvPr/>
         </p:nvSpPr>
         <p:spPr>
           <a:xfrm>
-            <a:off x="868680" y="2880360"/>
-            <a:ext cx="1645920" cy="1280160"/>
+            <a:off x="0" y="2583180"/>
+            <a:ext cx="12191695" cy="1280160"/>
           </a:xfrm>
           <a:prstGeom prst="rect">
             <a:avLst/>
@@ -3659,34 +3660,69 @@
           </a:bodyPr>
           <a:lstStyle/>
           <a:p>
-            <a:pPr algn="l"/>
-            <a:r>
-              <a:rPr sz="5600" b="1" i="0">
+            <a:pPr algn="ctr"/>
+            <a:r>
+              <a:rPr sz="4400" b="1" i="0">
                 <a:solidFill>
-                  <a:srgbClr val="D94A1C"/>
+                  <a:srgbClr val="1F1F1F"/>
                 </a:solidFill>
                 <a:latin typeface="Calibri"/>
               </a:rPr>
-              <a:t>01</a:t>
+              <a:t>Talk Title Goes Here</a:t>
+            </a:r>
+          </a:p>
+        </p:txBody>
+      </p:sp>
+      <p:sp>
+        <p:nvSpPr>
+          <p:cNvPr id="9" name="TextBox 8"/>
+          <p:cNvSpPr txBox="1"/>
+          <p:nvPr/>
+        </p:nvSpPr>
+        <p:spPr>
+          <a:xfrm>
+            <a:off x="0" y="3954780"/>
+            <a:ext cx="12191695" cy="640080"/>
+          </a:xfrm>
+          <a:prstGeom prst="rect">
+            <a:avLst/>
+          </a:prstGeom>
+          <a:noFill/>
+        </p:spPr>
+        <p:txBody>
+          <a:bodyPr wrap="square" lIns="0" rIns="0" tIns="0" bIns="0" anchor="ctr">
+            <a:spAutoFit/>
+          </a:bodyPr>
+          <a:lstStyle/>
+          <a:p>
+            <a:pPr algn="ctr"/>
+            <a:r>
+              <a:rPr sz="2200" b="0" i="1">
+                <a:solidFill>
+                  <a:srgbClr val="555555"/>
+                </a:solidFill>
+                <a:latin typeface="Calibri"/>
+              </a:rPr>
+              <a:t>A concise subtitle or one-line abstract</a:t>
             </a:r>
           </a:p>
         </p:txBody>
       </p:sp>
       <p:cxnSp>
         <p:nvCxnSpPr>
-          <p:cNvPr id="9" name="Connector 8"/>
+          <p:cNvPr id="10" name="Connector 9"/>
           <p:cNvCxnSpPr/>
           <p:nvPr/>
         </p:nvCxnSpPr>
         <p:spPr>
           <a:xfrm>
-            <a:off x="2606040" y="3108960"/>
-            <a:ext cx="0" cy="822960"/>
+            <a:off x="5090007" y="4777740"/>
+            <a:ext cx="2011680" cy="0"/>
           </a:xfrm>
           <a:prstGeom prst="line">
             <a:avLst/>
           </a:prstGeom>
-          <a:ln w="12700">
+          <a:ln w="19050">
             <a:solidFill>
               <a:srgbClr val="D94A1C"/>
             </a:solidFill>
@@ -3709,14 +3745,14 @@
       </p:cxnSp>
       <p:sp>
         <p:nvSpPr>
-          <p:cNvPr id="10" name="TextBox 9"/>
+          <p:cNvPr id="11" name="TextBox 10"/>
           <p:cNvSpPr txBox="1"/>
           <p:nvPr/>
         </p:nvSpPr>
         <p:spPr>
           <a:xfrm>
-            <a:off x="2880360" y="2880360"/>
-            <a:ext cx="7315200" cy="1280160"/>
+            <a:off x="0" y="4960620"/>
+            <a:ext cx="12191695" cy="457200"/>
           </a:xfrm>
           <a:prstGeom prst="rect">
             <a:avLst/>
@@ -3724,55 +3760,20 @@
           <a:noFill/>
         </p:spPr>
         <p:txBody>
-          <a:bodyPr wrap="square" lIns="0" rIns="0" tIns="0" bIns="0" anchor="ctr">
+          <a:bodyPr wrap="square" lIns="0" rIns="0" tIns="0" bIns="0" anchor="t">
             <a:spAutoFit/>
           </a:bodyPr>
           <a:lstStyle/>
           <a:p>
-            <a:pPr algn="l"/>
-            <a:r>
-              <a:rPr sz="3600" b="1" i="0">
+            <a:pPr algn="ctr"/>
+            <a:r>
+              <a:rPr sz="1600" b="0" i="0">
                 <a:solidFill>
                   <a:srgbClr val="1F1F1F"/>
                 </a:solidFill>
                 <a:latin typeface="Calibri"/>
               </a:rPr>
-              <a:t>Section heading</a:t>
-            </a:r>
-          </a:p>
-        </p:txBody>
-      </p:sp>
-      <p:sp>
-        <p:nvSpPr>
-          <p:cNvPr id="11" name="TextBox 10"/>
-          <p:cNvSpPr txBox="1"/>
-          <p:nvPr/>
-        </p:nvSpPr>
-        <p:spPr>
-          <a:xfrm>
-            <a:off x="2880360" y="4206240"/>
-            <a:ext cx="7315200" cy="457200"/>
-          </a:xfrm>
-          <a:prstGeom prst="rect">
-            <a:avLst/>
-          </a:prstGeom>
-          <a:noFill/>
-        </p:spPr>
-        <p:txBody>
-          <a:bodyPr wrap="square" lIns="0" rIns="0" tIns="0" bIns="0" anchor="t">
-            <a:spAutoFit/>
-          </a:bodyPr>
-          <a:lstStyle/>
-          <a:p>
-            <a:pPr algn="l"/>
-            <a:r>
-              <a:rPr sz="1800" b="0" i="1">
-                <a:solidFill>
-                  <a:srgbClr val="555555"/>
-                </a:solidFill>
-                <a:latin typeface="Calibri"/>
-              </a:rPr>
-              <a:t>An optional one-line summary of this section</a:t>
+              <a:t>Speaker Name  ·  Affiliation  ·  Month Year</a:t>
             </a:r>
           </a:p>
         </p:txBody>
@@ -3949,7 +3950,7 @@
                 </a:solidFill>
                 <a:latin typeface="Calibri"/>
               </a:rPr>
-              <a:t>Slide title</a:t>
+              <a:t>Section heading</a:t>
             </a:r>
           </a:p>
         </p:txBody>
@@ -3997,8 +3998,8 @@
         </p:nvSpPr>
         <p:spPr>
           <a:xfrm>
-            <a:off x="594360" y="1280160"/>
-            <a:ext cx="11185855" cy="5074920"/>
+            <a:off x="868680" y="2880360"/>
+            <a:ext cx="1645920" cy="1280160"/>
           </a:xfrm>
           <a:prstGeom prst="rect">
             <a:avLst/>
@@ -4006,102 +4007,104 @@
           <a:noFill/>
         </p:spPr>
         <p:txBody>
-          <a:bodyPr wrap="square" lIns="0" rIns="0" tIns="0" bIns="0">
+          <a:bodyPr wrap="square" lIns="0" rIns="0" tIns="0" bIns="0" anchor="ctr">
             <a:spAutoFit/>
           </a:bodyPr>
           <a:lstStyle/>
           <a:p>
-            <a:pPr algn="l">
-              <a:spcAft>
-                <a:spcPts val="1000"/>
-              </a:spcAft>
-            </a:pPr>
-            <a:r>
-              <a:rPr sz="2000">
+            <a:pPr algn="l"/>
+            <a:r>
+              <a:rPr sz="5600" b="1" i="0">
+                <a:solidFill>
+                  <a:srgbClr val="D94A1C"/>
+                </a:solidFill>
+                <a:latin typeface="Calibri"/>
+              </a:rPr>
+              <a:t>01</a:t>
+            </a:r>
+          </a:p>
+        </p:txBody>
+      </p:sp>
+      <p:cxnSp>
+        <p:nvCxnSpPr>
+          <p:cNvPr id="9" name="Connector 8"/>
+          <p:cNvCxnSpPr/>
+          <p:nvPr/>
+        </p:nvCxnSpPr>
+        <p:spPr>
+          <a:xfrm>
+            <a:off x="2606040" y="3108960"/>
+            <a:ext cx="0" cy="822960"/>
+          </a:xfrm>
+          <a:prstGeom prst="line">
+            <a:avLst/>
+          </a:prstGeom>
+          <a:ln w="12700">
+            <a:solidFill>
+              <a:srgbClr val="D94A1C"/>
+            </a:solidFill>
+          </a:ln>
+        </p:spPr>
+        <p:style>
+          <a:lnRef idx="2">
+            <a:schemeClr val="accent1"/>
+          </a:lnRef>
+          <a:fillRef idx="0">
+            <a:schemeClr val="accent1"/>
+          </a:fillRef>
+          <a:effectRef idx="1">
+            <a:schemeClr val="accent1"/>
+          </a:effectRef>
+          <a:fontRef idx="minor">
+            <a:schemeClr val="tx1"/>
+          </a:fontRef>
+        </p:style>
+      </p:cxnSp>
+      <p:sp>
+        <p:nvSpPr>
+          <p:cNvPr id="10" name="TextBox 9"/>
+          <p:cNvSpPr txBox="1"/>
+          <p:nvPr/>
+        </p:nvSpPr>
+        <p:spPr>
+          <a:xfrm>
+            <a:off x="2880360" y="2880360"/>
+            <a:ext cx="7315200" cy="1280160"/>
+          </a:xfrm>
+          <a:prstGeom prst="rect">
+            <a:avLst/>
+          </a:prstGeom>
+          <a:noFill/>
+        </p:spPr>
+        <p:txBody>
+          <a:bodyPr wrap="square" lIns="0" rIns="0" tIns="0" bIns="0" anchor="ctr">
+            <a:spAutoFit/>
+          </a:bodyPr>
+          <a:lstStyle/>
+          <a:p>
+            <a:pPr algn="l"/>
+            <a:r>
+              <a:rPr sz="3600" b="1" i="0">
                 <a:solidFill>
                   <a:srgbClr val="1F1F1F"/>
                 </a:solidFill>
                 <a:latin typeface="Calibri"/>
               </a:rPr>
-              <a:t>•  Lead with the main claim — what the reader should take away</a:t>
-            </a:r>
-          </a:p>
-          <a:p>
-            <a:pPr algn="l">
-              <a:spcAft>
-                <a:spcPts val="1000"/>
-              </a:spcAft>
-            </a:pPr>
-            <a:r>
-              <a:rPr sz="2000">
-                <a:solidFill>
-                  <a:srgbClr val="1F1F1F"/>
-                </a:solidFill>
-                <a:latin typeface="Calibri"/>
-              </a:rPr>
-              <a:t>•  Supporting detail, ideally a number or concrete example</a:t>
-            </a:r>
-          </a:p>
-          <a:p>
-            <a:pPr algn="l">
-              <a:spcAft>
-                <a:spcPts val="1000"/>
-              </a:spcAft>
-            </a:pPr>
-            <a:r>
-              <a:rPr sz="2000">
-                <a:solidFill>
-                  <a:srgbClr val="1F1F1F"/>
-                </a:solidFill>
-                <a:latin typeface="Calibri"/>
-              </a:rPr>
-              <a:t>•  A second supporting point that extends the first</a:t>
-            </a:r>
-          </a:p>
-          <a:p>
-            <a:pPr algn="l">
-              <a:spcAft>
-                <a:spcPts val="1000"/>
-              </a:spcAft>
-            </a:pPr>
-            <a:r>
-              <a:rPr sz="2000">
-                <a:solidFill>
-                  <a:srgbClr val="1F1F1F"/>
-                </a:solidFill>
-                <a:latin typeface="Calibri"/>
-              </a:rPr>
-              <a:t>•  A fourth line of room — titles live in the header, so the body breathes</a:t>
-            </a:r>
-          </a:p>
-          <a:p>
-            <a:pPr algn="l">
-              <a:spcAft>
-                <a:spcPts val="1000"/>
-              </a:spcAft>
-            </a:pPr>
-            <a:r>
-              <a:rPr sz="2000">
-                <a:solidFill>
-                  <a:srgbClr val="1F1F1F"/>
-                </a:solidFill>
-                <a:latin typeface="Calibri"/>
-              </a:rPr>
-              <a:t>•  Edge case, caveat, or the one thing not to forget</a:t>
-            </a:r>
-          </a:p>
-        </p:txBody>
-      </p:sp>
-      <p:sp>
-        <p:nvSpPr>
-          <p:cNvPr id="9" name="TextBox 8"/>
+              <a:t>Section heading</a:t>
+            </a:r>
+          </a:p>
+        </p:txBody>
+      </p:sp>
+      <p:sp>
+        <p:nvSpPr>
+          <p:cNvPr id="11" name="TextBox 10"/>
           <p:cNvSpPr txBox="1"/>
           <p:nvPr/>
         </p:nvSpPr>
         <p:spPr>
           <a:xfrm>
-            <a:off x="594360" y="6446520"/>
-            <a:ext cx="11185855" cy="320040"/>
+            <a:off x="2880360" y="4206240"/>
+            <a:ext cx="7315200" cy="457200"/>
           </a:xfrm>
           <a:prstGeom prst="rect">
             <a:avLst/>
@@ -4116,13 +4119,13 @@
           <a:p>
             <a:pPr algn="l"/>
             <a:r>
-              <a:rPr sz="1400" b="0" i="1">
+              <a:rPr sz="1800" b="0" i="1">
                 <a:solidFill>
                   <a:srgbClr val="555555"/>
                 </a:solidFill>
                 <a:latin typeface="Calibri"/>
               </a:rPr>
-              <a:t>Footer / citation / page note</a:t>
+              <a:t>An optional one-line summary of this section</a:t>
             </a:r>
           </a:p>
         </p:txBody>
@@ -4341,44 +4344,104 @@
       </p:cxnSp>
       <p:sp>
         <p:nvSpPr>
-          <p:cNvPr id="8" name="Rectangle 7"/>
-          <p:cNvSpPr/>
+          <p:cNvPr id="8" name="TextBox 7"/>
+          <p:cNvSpPr txBox="1"/>
           <p:nvPr/>
         </p:nvSpPr>
         <p:spPr>
           <a:xfrm>
             <a:off x="594360" y="1280160"/>
-            <a:ext cx="5486400" cy="5120640"/>
+            <a:ext cx="11185855" cy="5074920"/>
           </a:xfrm>
           <a:prstGeom prst="rect">
             <a:avLst/>
           </a:prstGeom>
           <a:noFill/>
-          <a:ln w="6350">
-            <a:solidFill>
-              <a:srgbClr val="555555"/>
-            </a:solidFill>
-          </a:ln>
-        </p:spPr>
-        <p:style>
-          <a:lnRef idx="1">
-            <a:schemeClr val="accent1"/>
-          </a:lnRef>
-          <a:fillRef idx="3">
-            <a:schemeClr val="accent1"/>
-          </a:fillRef>
-          <a:effectRef idx="2">
-            <a:schemeClr val="accent1"/>
-          </a:effectRef>
-          <a:fontRef idx="minor">
-            <a:schemeClr val="lt1"/>
-          </a:fontRef>
-        </p:style>
-        <p:txBody>
-          <a:bodyPr rtlCol="0" anchor="ctr"/>
-          <a:lstStyle/>
-          <a:p>
-            <a:pPr algn="ctr"/>
+        </p:spPr>
+        <p:txBody>
+          <a:bodyPr wrap="square" lIns="0" rIns="0" tIns="0" bIns="0">
+            <a:spAutoFit/>
+          </a:bodyPr>
+          <a:lstStyle/>
+          <a:p>
+            <a:pPr algn="l">
+              <a:spcAft>
+                <a:spcPts val="1000"/>
+              </a:spcAft>
+            </a:pPr>
+            <a:r>
+              <a:rPr sz="2000">
+                <a:solidFill>
+                  <a:srgbClr val="1F1F1F"/>
+                </a:solidFill>
+                <a:latin typeface="Calibri"/>
+              </a:rPr>
+              <a:t>•  Lead with the main claim — what the reader should take away</a:t>
+            </a:r>
+          </a:p>
+          <a:p>
+            <a:pPr algn="l">
+              <a:spcAft>
+                <a:spcPts val="1000"/>
+              </a:spcAft>
+            </a:pPr>
+            <a:r>
+              <a:rPr sz="2000">
+                <a:solidFill>
+                  <a:srgbClr val="1F1F1F"/>
+                </a:solidFill>
+                <a:latin typeface="Calibri"/>
+              </a:rPr>
+              <a:t>•  Supporting detail, ideally a number or concrete example</a:t>
+            </a:r>
+          </a:p>
+          <a:p>
+            <a:pPr algn="l">
+              <a:spcAft>
+                <a:spcPts val="1000"/>
+              </a:spcAft>
+            </a:pPr>
+            <a:r>
+              <a:rPr sz="2000">
+                <a:solidFill>
+                  <a:srgbClr val="1F1F1F"/>
+                </a:solidFill>
+                <a:latin typeface="Calibri"/>
+              </a:rPr>
+              <a:t>•  A second supporting point that extends the first</a:t>
+            </a:r>
+          </a:p>
+          <a:p>
+            <a:pPr algn="l">
+              <a:spcAft>
+                <a:spcPts val="1000"/>
+              </a:spcAft>
+            </a:pPr>
+            <a:r>
+              <a:rPr sz="2000">
+                <a:solidFill>
+                  <a:srgbClr val="1F1F1F"/>
+                </a:solidFill>
+                <a:latin typeface="Calibri"/>
+              </a:rPr>
+              <a:t>•  A fourth line of room — titles live in the header, so the body breathes</a:t>
+            </a:r>
+          </a:p>
+          <a:p>
+            <a:pPr algn="l">
+              <a:spcAft>
+                <a:spcPts val="1000"/>
+              </a:spcAft>
+            </a:pPr>
+            <a:r>
+              <a:rPr sz="2000">
+                <a:solidFill>
+                  <a:srgbClr val="1F1F1F"/>
+                </a:solidFill>
+                <a:latin typeface="Calibri"/>
+              </a:rPr>
+              <a:t>•  Edge case, caveat, or the one thing not to forget</a:t>
+            </a:r>
           </a:p>
         </p:txBody>
       </p:sp>
@@ -4390,8 +4453,8 @@
         </p:nvSpPr>
         <p:spPr>
           <a:xfrm>
-            <a:off x="594360" y="1280160"/>
-            <a:ext cx="5486400" cy="5120640"/>
+            <a:off x="594360" y="6446520"/>
+            <a:ext cx="11185855" cy="320040"/>
           </a:xfrm>
           <a:prstGeom prst="rect">
             <a:avLst/>
@@ -4399,126 +4462,20 @@
           <a:noFill/>
         </p:spPr>
         <p:txBody>
-          <a:bodyPr wrap="square" lIns="0" rIns="0" tIns="0" bIns="0" anchor="ctr">
+          <a:bodyPr wrap="square" lIns="0" rIns="0" tIns="0" bIns="0" anchor="t">
             <a:spAutoFit/>
           </a:bodyPr>
           <a:lstStyle/>
           <a:p>
-            <a:pPr algn="ctr"/>
-            <a:r>
-              <a:rPr sz="1800" b="0" i="1">
+            <a:pPr algn="l"/>
+            <a:r>
+              <a:rPr sz="1400" b="0" i="1">
                 <a:solidFill>
                   <a:srgbClr val="555555"/>
                 </a:solidFill>
                 <a:latin typeface="Calibri"/>
               </a:rPr>
-              <a:t>[ figure / diagram ]</a:t>
-            </a:r>
-          </a:p>
-        </p:txBody>
-      </p:sp>
-      <p:sp>
-        <p:nvSpPr>
-          <p:cNvPr id="10" name="TextBox 9"/>
-          <p:cNvSpPr txBox="1"/>
-          <p:nvPr/>
-        </p:nvSpPr>
-        <p:spPr>
-          <a:xfrm>
-            <a:off x="6537960" y="1280160"/>
-            <a:ext cx="5242255" cy="457200"/>
-          </a:xfrm>
-          <a:prstGeom prst="rect">
-            <a:avLst/>
-          </a:prstGeom>
-          <a:noFill/>
-        </p:spPr>
-        <p:txBody>
-          <a:bodyPr wrap="square" lIns="0" rIns="0" tIns="0" bIns="0" anchor="t">
-            <a:spAutoFit/>
-          </a:bodyPr>
-          <a:lstStyle/>
-          <a:p>
-            <a:pPr algn="l"/>
-            <a:r>
-              <a:rPr sz="2200" b="1" i="0">
-                <a:solidFill>
-                  <a:srgbClr val="1F1F1F"/>
-                </a:solidFill>
-                <a:latin typeface="Calibri"/>
-              </a:rPr>
-              <a:t>Caption or claim</a:t>
-            </a:r>
-          </a:p>
-        </p:txBody>
-      </p:sp>
-      <p:sp>
-        <p:nvSpPr>
-          <p:cNvPr id="11" name="TextBox 10"/>
-          <p:cNvSpPr txBox="1"/>
-          <p:nvPr/>
-        </p:nvSpPr>
-        <p:spPr>
-          <a:xfrm>
-            <a:off x="6537960" y="2011680"/>
-            <a:ext cx="5242255" cy="4389120"/>
-          </a:xfrm>
-          <a:prstGeom prst="rect">
-            <a:avLst/>
-          </a:prstGeom>
-          <a:noFill/>
-        </p:spPr>
-        <p:txBody>
-          <a:bodyPr wrap="square" lIns="0" rIns="0" tIns="0" bIns="0">
-            <a:spAutoFit/>
-          </a:bodyPr>
-          <a:lstStyle/>
-          <a:p>
-            <a:pPr algn="l">
-              <a:spcAft>
-                <a:spcPts val="1000"/>
-              </a:spcAft>
-            </a:pPr>
-            <a:r>
-              <a:rPr sz="1800">
-                <a:solidFill>
-                  <a:srgbClr val="1F1F1F"/>
-                </a:solidFill>
-                <a:latin typeface="Calibri"/>
-              </a:rPr>
-              <a:t>•  Explain what the figure shows</a:t>
-            </a:r>
-          </a:p>
-          <a:p>
-            <a:pPr algn="l">
-              <a:spcAft>
-                <a:spcPts val="1000"/>
-              </a:spcAft>
-            </a:pPr>
-            <a:r>
-              <a:rPr sz="1800">
-                <a:solidFill>
-                  <a:srgbClr val="1F1F1F"/>
-                </a:solidFill>
-                <a:latin typeface="Calibri"/>
-              </a:rPr>
-              <a:t>•  Call out the one feature worth noting</a:t>
-            </a:r>
-          </a:p>
-          <a:p>
-            <a:pPr algn="l">
-              <a:spcAft>
-                <a:spcPts val="1000"/>
-              </a:spcAft>
-            </a:pPr>
-            <a:r>
-              <a:rPr sz="1800">
-                <a:solidFill>
-                  <a:srgbClr val="1F1F1F"/>
-                </a:solidFill>
-                <a:latin typeface="Calibri"/>
-              </a:rPr>
-              <a:t>•  Relate it back to the slide's main point</a:t>
+              <a:t>Footer / citation / page note</a:t>
             </a:r>
           </a:p>
         </p:txBody>
@@ -4656,6 +4613,402 @@
           </a:prstGeom>
         </p:spPr>
       </p:pic>
+      <p:sp>
+        <p:nvSpPr>
+          <p:cNvPr id="6" name="TextBox 5"/>
+          <p:cNvSpPr txBox="1"/>
+          <p:nvPr/>
+        </p:nvSpPr>
+        <p:spPr>
+          <a:xfrm>
+            <a:off x="411480" y="0"/>
+            <a:ext cx="7682781" cy="960120"/>
+          </a:xfrm>
+          <a:prstGeom prst="rect">
+            <a:avLst/>
+          </a:prstGeom>
+          <a:noFill/>
+        </p:spPr>
+        <p:txBody>
+          <a:bodyPr wrap="square" lIns="0" rIns="0" tIns="0" bIns="0" anchor="ctr">
+            <a:spAutoFit/>
+          </a:bodyPr>
+          <a:lstStyle/>
+          <a:p>
+            <a:pPr algn="l"/>
+            <a:r>
+              <a:rPr sz="1600" b="1" i="1">
+                <a:solidFill>
+                  <a:srgbClr val="D94A1C"/>
+                </a:solidFill>
+                <a:latin typeface="Calibri"/>
+              </a:rPr>
+              <a:t>Now:  </a:t>
+            </a:r>
+            <a:r>
+              <a:rPr sz="2600" b="1" i="1">
+                <a:solidFill>
+                  <a:srgbClr val="1F1F1F"/>
+                </a:solidFill>
+                <a:latin typeface="Calibri"/>
+              </a:rPr>
+              <a:t>Slide title</a:t>
+            </a:r>
+          </a:p>
+        </p:txBody>
+      </p:sp>
+      <p:cxnSp>
+        <p:nvCxnSpPr>
+          <p:cNvPr id="7" name="Connector 6"/>
+          <p:cNvCxnSpPr/>
+          <p:nvPr/>
+        </p:nvCxnSpPr>
+        <p:spPr>
+          <a:xfrm>
+            <a:off x="0" y="960120"/>
+            <a:ext cx="12191695" cy="0"/>
+          </a:xfrm>
+          <a:prstGeom prst="line">
+            <a:avLst/>
+          </a:prstGeom>
+          <a:ln w="19050">
+            <a:solidFill>
+              <a:srgbClr val="D94A1C"/>
+            </a:solidFill>
+          </a:ln>
+        </p:spPr>
+        <p:style>
+          <a:lnRef idx="2">
+            <a:schemeClr val="accent1"/>
+          </a:lnRef>
+          <a:fillRef idx="0">
+            <a:schemeClr val="accent1"/>
+          </a:fillRef>
+          <a:effectRef idx="1">
+            <a:schemeClr val="accent1"/>
+          </a:effectRef>
+          <a:fontRef idx="minor">
+            <a:schemeClr val="tx1"/>
+          </a:fontRef>
+        </p:style>
+      </p:cxnSp>
+      <p:sp>
+        <p:nvSpPr>
+          <p:cNvPr id="8" name="Rectangle 7"/>
+          <p:cNvSpPr/>
+          <p:nvPr/>
+        </p:nvSpPr>
+        <p:spPr>
+          <a:xfrm>
+            <a:off x="594360" y="1280160"/>
+            <a:ext cx="5486400" cy="5120640"/>
+          </a:xfrm>
+          <a:prstGeom prst="rect">
+            <a:avLst/>
+          </a:prstGeom>
+          <a:noFill/>
+          <a:ln w="6350">
+            <a:solidFill>
+              <a:srgbClr val="555555"/>
+            </a:solidFill>
+          </a:ln>
+        </p:spPr>
+        <p:style>
+          <a:lnRef idx="1">
+            <a:schemeClr val="accent1"/>
+          </a:lnRef>
+          <a:fillRef idx="3">
+            <a:schemeClr val="accent1"/>
+          </a:fillRef>
+          <a:effectRef idx="2">
+            <a:schemeClr val="accent1"/>
+          </a:effectRef>
+          <a:fontRef idx="minor">
+            <a:schemeClr val="lt1"/>
+          </a:fontRef>
+        </p:style>
+        <p:txBody>
+          <a:bodyPr rtlCol="0" anchor="ctr"/>
+          <a:lstStyle/>
+          <a:p>
+            <a:pPr algn="ctr"/>
+          </a:p>
+        </p:txBody>
+      </p:sp>
+      <p:sp>
+        <p:nvSpPr>
+          <p:cNvPr id="9" name="TextBox 8"/>
+          <p:cNvSpPr txBox="1"/>
+          <p:nvPr/>
+        </p:nvSpPr>
+        <p:spPr>
+          <a:xfrm>
+            <a:off x="594360" y="1280160"/>
+            <a:ext cx="5486400" cy="5120640"/>
+          </a:xfrm>
+          <a:prstGeom prst="rect">
+            <a:avLst/>
+          </a:prstGeom>
+          <a:noFill/>
+        </p:spPr>
+        <p:txBody>
+          <a:bodyPr wrap="square" lIns="0" rIns="0" tIns="0" bIns="0" anchor="ctr">
+            <a:spAutoFit/>
+          </a:bodyPr>
+          <a:lstStyle/>
+          <a:p>
+            <a:pPr algn="ctr"/>
+            <a:r>
+              <a:rPr sz="1800" b="0" i="1">
+                <a:solidFill>
+                  <a:srgbClr val="555555"/>
+                </a:solidFill>
+                <a:latin typeface="Calibri"/>
+              </a:rPr>
+              <a:t>[ figure / diagram ]</a:t>
+            </a:r>
+          </a:p>
+        </p:txBody>
+      </p:sp>
+      <p:sp>
+        <p:nvSpPr>
+          <p:cNvPr id="10" name="TextBox 9"/>
+          <p:cNvSpPr txBox="1"/>
+          <p:nvPr/>
+        </p:nvSpPr>
+        <p:spPr>
+          <a:xfrm>
+            <a:off x="6537960" y="1280160"/>
+            <a:ext cx="5242255" cy="457200"/>
+          </a:xfrm>
+          <a:prstGeom prst="rect">
+            <a:avLst/>
+          </a:prstGeom>
+          <a:noFill/>
+        </p:spPr>
+        <p:txBody>
+          <a:bodyPr wrap="square" lIns="0" rIns="0" tIns="0" bIns="0" anchor="t">
+            <a:spAutoFit/>
+          </a:bodyPr>
+          <a:lstStyle/>
+          <a:p>
+            <a:pPr algn="l"/>
+            <a:r>
+              <a:rPr sz="2200" b="1" i="0">
+                <a:solidFill>
+                  <a:srgbClr val="1F1F1F"/>
+                </a:solidFill>
+                <a:latin typeface="Calibri"/>
+              </a:rPr>
+              <a:t>Caption or claim</a:t>
+            </a:r>
+          </a:p>
+        </p:txBody>
+      </p:sp>
+      <p:sp>
+        <p:nvSpPr>
+          <p:cNvPr id="11" name="TextBox 10"/>
+          <p:cNvSpPr txBox="1"/>
+          <p:nvPr/>
+        </p:nvSpPr>
+        <p:spPr>
+          <a:xfrm>
+            <a:off x="6537960" y="2011680"/>
+            <a:ext cx="5242255" cy="4389120"/>
+          </a:xfrm>
+          <a:prstGeom prst="rect">
+            <a:avLst/>
+          </a:prstGeom>
+          <a:noFill/>
+        </p:spPr>
+        <p:txBody>
+          <a:bodyPr wrap="square" lIns="0" rIns="0" tIns="0" bIns="0">
+            <a:spAutoFit/>
+          </a:bodyPr>
+          <a:lstStyle/>
+          <a:p>
+            <a:pPr algn="l">
+              <a:spcAft>
+                <a:spcPts val="1000"/>
+              </a:spcAft>
+            </a:pPr>
+            <a:r>
+              <a:rPr sz="1800">
+                <a:solidFill>
+                  <a:srgbClr val="1F1F1F"/>
+                </a:solidFill>
+                <a:latin typeface="Calibri"/>
+              </a:rPr>
+              <a:t>•  Explain what the figure shows</a:t>
+            </a:r>
+          </a:p>
+          <a:p>
+            <a:pPr algn="l">
+              <a:spcAft>
+                <a:spcPts val="1000"/>
+              </a:spcAft>
+            </a:pPr>
+            <a:r>
+              <a:rPr sz="1800">
+                <a:solidFill>
+                  <a:srgbClr val="1F1F1F"/>
+                </a:solidFill>
+                <a:latin typeface="Calibri"/>
+              </a:rPr>
+              <a:t>•  Call out the one feature worth noting</a:t>
+            </a:r>
+          </a:p>
+          <a:p>
+            <a:pPr algn="l">
+              <a:spcAft>
+                <a:spcPts val="1000"/>
+              </a:spcAft>
+            </a:pPr>
+            <a:r>
+              <a:rPr sz="1800">
+                <a:solidFill>
+                  <a:srgbClr val="1F1F1F"/>
+                </a:solidFill>
+                <a:latin typeface="Calibri"/>
+              </a:rPr>
+              <a:t>•  Relate it back to the slide's main point</a:t>
+            </a:r>
+          </a:p>
+        </p:txBody>
+      </p:sp>
+    </p:spTree>
+  </p:cSld>
+  <p:clrMapOvr>
+    <a:masterClrMapping/>
+  </p:clrMapOvr>
+</p:sld>
+</file>
+
+<file path=ppt/slides/slide6.xml><?xml version="1.0" encoding="utf-8"?>
+<p:sld xmlns:a="http://schemas.openxmlformats.org/drawingml/2006/main" xmlns:p="http://schemas.openxmlformats.org/presentationml/2006/main" xmlns:r="http://schemas.openxmlformats.org/officeDocument/2006/relationships">
+  <p:cSld>
+    <p:spTree>
+      <p:nvGrpSpPr>
+        <p:cNvPr id="1" name=""/>
+        <p:cNvGrpSpPr/>
+        <p:nvPr/>
+      </p:nvGrpSpPr>
+      <p:grpSpPr/>
+      <p:sp>
+        <p:nvSpPr>
+          <p:cNvPr id="2" name="Rectangle 1"/>
+          <p:cNvSpPr/>
+          <p:nvPr/>
+        </p:nvSpPr>
+        <p:spPr>
+          <a:xfrm>
+            <a:off x="0" y="0"/>
+            <a:ext cx="12191695" cy="960120"/>
+          </a:xfrm>
+          <a:prstGeom prst="rect">
+            <a:avLst/>
+          </a:prstGeom>
+          <a:solidFill>
+            <a:srgbClr val="F2E6CC"/>
+          </a:solidFill>
+          <a:ln>
+            <a:noFill/>
+          </a:ln>
+        </p:spPr>
+        <p:style>
+          <a:lnRef idx="1">
+            <a:schemeClr val="accent1"/>
+          </a:lnRef>
+          <a:fillRef idx="3">
+            <a:schemeClr val="accent1"/>
+          </a:fillRef>
+          <a:effectRef idx="2">
+            <a:schemeClr val="accent1"/>
+          </a:effectRef>
+          <a:fontRef idx="minor">
+            <a:schemeClr val="lt1"/>
+          </a:fontRef>
+        </p:style>
+        <p:txBody>
+          <a:bodyPr rtlCol="0" anchor="ctr"/>
+          <a:lstStyle/>
+          <a:p>
+            <a:pPr algn="ctr"/>
+          </a:p>
+        </p:txBody>
+      </p:sp>
+      <p:pic>
+        <p:nvPicPr>
+          <p:cNvPr id="3" name="Picture 2" descr="KCL.png"/>
+          <p:cNvPicPr>
+            <a:picLocks noChangeAspect="1"/>
+          </p:cNvPicPr>
+          <p:nvPr/>
+        </p:nvPicPr>
+        <p:blipFill>
+          <a:blip r:embed="rId2"/>
+          <a:stretch>
+            <a:fillRect/>
+          </a:stretch>
+        </p:blipFill>
+        <p:spPr>
+          <a:xfrm>
+            <a:off x="8368581" y="205740"/>
+            <a:ext cx="1108061" cy="548640"/>
+          </a:xfrm>
+          <a:prstGeom prst="rect">
+            <a:avLst/>
+          </a:prstGeom>
+        </p:spPr>
+      </p:pic>
+      <p:pic>
+        <p:nvPicPr>
+          <p:cNvPr id="4" name="Picture 3" descr="KCLNLP.png"/>
+          <p:cNvPicPr>
+            <a:picLocks noChangeAspect="1"/>
+          </p:cNvPicPr>
+          <p:nvPr/>
+        </p:nvPicPr>
+        <p:blipFill>
+          <a:blip r:embed="rId3"/>
+          <a:stretch>
+            <a:fillRect/>
+          </a:stretch>
+        </p:blipFill>
+        <p:spPr>
+          <a:xfrm>
+            <a:off x="9677810" y="205740"/>
+            <a:ext cx="603709" cy="548640"/>
+          </a:xfrm>
+          <a:prstGeom prst="rect">
+            <a:avLst/>
+          </a:prstGeom>
+        </p:spPr>
+      </p:pic>
+      <p:pic>
+        <p:nvPicPr>
+          <p:cNvPr id="5" name="Picture 4" descr="Alan.png"/>
+          <p:cNvPicPr>
+            <a:picLocks noChangeAspect="1"/>
+          </p:cNvPicPr>
+          <p:nvPr/>
+        </p:nvPicPr>
+        <p:blipFill>
+          <a:blip r:embed="rId4"/>
+          <a:stretch>
+            <a:fillRect/>
+          </a:stretch>
+        </p:blipFill>
+        <p:spPr>
+          <a:xfrm>
+            <a:off x="10482687" y="205740"/>
+            <a:ext cx="1297528" cy="548640"/>
+          </a:xfrm>
+          <a:prstGeom prst="rect">
+            <a:avLst/>
+          </a:prstGeom>
+        </p:spPr>
+      </p:pic>
       <p:cxnSp>
         <p:nvCxnSpPr>
           <p:cNvPr id="6" name="Connector 5"/>
@@ -4862,6 +5215,322 @@
           <a:lstStyle/>
           <a:p>
             <a:pPr algn="l"/>
+            <a:r>
+              <a:rPr sz="1600" b="0" i="0">
+                <a:solidFill>
+                  <a:srgbClr val="1F1F1F"/>
+                </a:solidFill>
+                <a:latin typeface="Calibri"/>
+              </a:rPr>
+              <a:t>speaker@kcl.ac.uk  ·  kclnlp.github.io</a:t>
+            </a:r>
+          </a:p>
+        </p:txBody>
+      </p:sp>
+    </p:spTree>
+  </p:cSld>
+  <p:clrMapOvr>
+    <a:masterClrMapping/>
+  </p:clrMapOvr>
+</p:sld>
+</file>
+
+<file path=ppt/slides/slide7.xml><?xml version="1.0" encoding="utf-8"?>
+<p:sld xmlns:a="http://schemas.openxmlformats.org/drawingml/2006/main" xmlns:p="http://schemas.openxmlformats.org/presentationml/2006/main" xmlns:r="http://schemas.openxmlformats.org/officeDocument/2006/relationships">
+  <p:cSld>
+    <p:spTree>
+      <p:nvGrpSpPr>
+        <p:cNvPr id="1" name=""/>
+        <p:cNvGrpSpPr/>
+        <p:nvPr/>
+      </p:nvGrpSpPr>
+      <p:grpSpPr/>
+      <p:sp>
+        <p:nvSpPr>
+          <p:cNvPr id="2" name="Rectangle 1"/>
+          <p:cNvSpPr/>
+          <p:nvPr/>
+        </p:nvSpPr>
+        <p:spPr>
+          <a:xfrm>
+            <a:off x="0" y="0"/>
+            <a:ext cx="12191695" cy="960120"/>
+          </a:xfrm>
+          <a:prstGeom prst="rect">
+            <a:avLst/>
+          </a:prstGeom>
+          <a:solidFill>
+            <a:srgbClr val="F2E6CC"/>
+          </a:solidFill>
+          <a:ln>
+            <a:noFill/>
+          </a:ln>
+        </p:spPr>
+        <p:style>
+          <a:lnRef idx="1">
+            <a:schemeClr val="accent1"/>
+          </a:lnRef>
+          <a:fillRef idx="3">
+            <a:schemeClr val="accent1"/>
+          </a:fillRef>
+          <a:effectRef idx="2">
+            <a:schemeClr val="accent1"/>
+          </a:effectRef>
+          <a:fontRef idx="minor">
+            <a:schemeClr val="lt1"/>
+          </a:fontRef>
+        </p:style>
+        <p:txBody>
+          <a:bodyPr rtlCol="0" anchor="ctr"/>
+          <a:lstStyle/>
+          <a:p>
+            <a:pPr algn="ctr"/>
+          </a:p>
+        </p:txBody>
+      </p:sp>
+      <p:pic>
+        <p:nvPicPr>
+          <p:cNvPr id="3" name="Picture 2" descr="KCL.png"/>
+          <p:cNvPicPr>
+            <a:picLocks noChangeAspect="1"/>
+          </p:cNvPicPr>
+          <p:nvPr/>
+        </p:nvPicPr>
+        <p:blipFill>
+          <a:blip r:embed="rId2"/>
+          <a:stretch>
+            <a:fillRect/>
+          </a:stretch>
+        </p:blipFill>
+        <p:spPr>
+          <a:xfrm>
+            <a:off x="8368581" y="205740"/>
+            <a:ext cx="1108061" cy="548640"/>
+          </a:xfrm>
+          <a:prstGeom prst="rect">
+            <a:avLst/>
+          </a:prstGeom>
+        </p:spPr>
+      </p:pic>
+      <p:pic>
+        <p:nvPicPr>
+          <p:cNvPr id="4" name="Picture 3" descr="KCLNLP.png"/>
+          <p:cNvPicPr>
+            <a:picLocks noChangeAspect="1"/>
+          </p:cNvPicPr>
+          <p:nvPr/>
+        </p:nvPicPr>
+        <p:blipFill>
+          <a:blip r:embed="rId3"/>
+          <a:stretch>
+            <a:fillRect/>
+          </a:stretch>
+        </p:blipFill>
+        <p:spPr>
+          <a:xfrm>
+            <a:off x="9677810" y="205740"/>
+            <a:ext cx="603709" cy="548640"/>
+          </a:xfrm>
+          <a:prstGeom prst="rect">
+            <a:avLst/>
+          </a:prstGeom>
+        </p:spPr>
+      </p:pic>
+      <p:pic>
+        <p:nvPicPr>
+          <p:cNvPr id="5" name="Picture 4" descr="Alan.png"/>
+          <p:cNvPicPr>
+            <a:picLocks noChangeAspect="1"/>
+          </p:cNvPicPr>
+          <p:nvPr/>
+        </p:nvPicPr>
+        <p:blipFill>
+          <a:blip r:embed="rId4"/>
+          <a:stretch>
+            <a:fillRect/>
+          </a:stretch>
+        </p:blipFill>
+        <p:spPr>
+          <a:xfrm>
+            <a:off x="10482687" y="205740"/>
+            <a:ext cx="1297528" cy="548640"/>
+          </a:xfrm>
+          <a:prstGeom prst="rect">
+            <a:avLst/>
+          </a:prstGeom>
+        </p:spPr>
+      </p:pic>
+      <p:cxnSp>
+        <p:nvCxnSpPr>
+          <p:cNvPr id="6" name="Connector 5"/>
+          <p:cNvCxnSpPr/>
+          <p:nvPr/>
+        </p:nvCxnSpPr>
+        <p:spPr>
+          <a:xfrm>
+            <a:off x="0" y="960120"/>
+            <a:ext cx="12191695" cy="0"/>
+          </a:xfrm>
+          <a:prstGeom prst="line">
+            <a:avLst/>
+          </a:prstGeom>
+          <a:ln w="19050">
+            <a:solidFill>
+              <a:srgbClr val="D94A1C"/>
+            </a:solidFill>
+          </a:ln>
+        </p:spPr>
+        <p:style>
+          <a:lnRef idx="2">
+            <a:schemeClr val="accent1"/>
+          </a:lnRef>
+          <a:fillRef idx="0">
+            <a:schemeClr val="accent1"/>
+          </a:fillRef>
+          <a:effectRef idx="1">
+            <a:schemeClr val="accent1"/>
+          </a:effectRef>
+          <a:fontRef idx="minor">
+            <a:schemeClr val="tx1"/>
+          </a:fontRef>
+        </p:style>
+      </p:cxnSp>
+      <p:sp>
+        <p:nvSpPr>
+          <p:cNvPr id="7" name="Rectangle 6"/>
+          <p:cNvSpPr/>
+          <p:nvPr/>
+        </p:nvSpPr>
+        <p:spPr>
+          <a:xfrm>
+            <a:off x="5272887" y="2354580"/>
+            <a:ext cx="1645920" cy="54864"/>
+          </a:xfrm>
+          <a:prstGeom prst="rect">
+            <a:avLst/>
+          </a:prstGeom>
+          <a:solidFill>
+            <a:srgbClr val="D94A1C"/>
+          </a:solidFill>
+          <a:ln>
+            <a:noFill/>
+          </a:ln>
+        </p:spPr>
+        <p:style>
+          <a:lnRef idx="1">
+            <a:schemeClr val="accent1"/>
+          </a:lnRef>
+          <a:fillRef idx="3">
+            <a:schemeClr val="accent1"/>
+          </a:fillRef>
+          <a:effectRef idx="2">
+            <a:schemeClr val="accent1"/>
+          </a:effectRef>
+          <a:fontRef idx="minor">
+            <a:schemeClr val="lt1"/>
+          </a:fontRef>
+        </p:style>
+        <p:txBody>
+          <a:bodyPr rtlCol="0" anchor="ctr"/>
+          <a:lstStyle/>
+          <a:p>
+            <a:pPr algn="ctr"/>
+          </a:p>
+        </p:txBody>
+      </p:sp>
+      <p:sp>
+        <p:nvSpPr>
+          <p:cNvPr id="8" name="TextBox 7"/>
+          <p:cNvSpPr txBox="1"/>
+          <p:nvPr/>
+        </p:nvSpPr>
+        <p:spPr>
+          <a:xfrm>
+            <a:off x="0" y="2674620"/>
+            <a:ext cx="12191695" cy="1463040"/>
+          </a:xfrm>
+          <a:prstGeom prst="rect">
+            <a:avLst/>
+          </a:prstGeom>
+          <a:noFill/>
+        </p:spPr>
+        <p:txBody>
+          <a:bodyPr wrap="square" lIns="0" rIns="0" tIns="0" bIns="0" anchor="ctr">
+            <a:spAutoFit/>
+          </a:bodyPr>
+          <a:lstStyle/>
+          <a:p>
+            <a:pPr algn="ctr"/>
+            <a:r>
+              <a:rPr sz="5600" b="1" i="0">
+                <a:solidFill>
+                  <a:srgbClr val="1F1F1F"/>
+                </a:solidFill>
+                <a:latin typeface="Calibri"/>
+              </a:rPr>
+              <a:t>Thank you</a:t>
+            </a:r>
+          </a:p>
+        </p:txBody>
+      </p:sp>
+      <p:sp>
+        <p:nvSpPr>
+          <p:cNvPr id="9" name="TextBox 8"/>
+          <p:cNvSpPr txBox="1"/>
+          <p:nvPr/>
+        </p:nvSpPr>
+        <p:spPr>
+          <a:xfrm>
+            <a:off x="0" y="4274820"/>
+            <a:ext cx="12191695" cy="548640"/>
+          </a:xfrm>
+          <a:prstGeom prst="rect">
+            <a:avLst/>
+          </a:prstGeom>
+          <a:noFill/>
+        </p:spPr>
+        <p:txBody>
+          <a:bodyPr wrap="square" lIns="0" rIns="0" tIns="0" bIns="0" anchor="ctr">
+            <a:spAutoFit/>
+          </a:bodyPr>
+          <a:lstStyle/>
+          <a:p>
+            <a:pPr algn="ctr"/>
+            <a:r>
+              <a:rPr sz="2200" b="0" i="1">
+                <a:solidFill>
+                  <a:srgbClr val="555555"/>
+                </a:solidFill>
+                <a:latin typeface="Calibri"/>
+              </a:rPr>
+              <a:t>Questions &amp; discussion</a:t>
+            </a:r>
+          </a:p>
+        </p:txBody>
+      </p:sp>
+      <p:sp>
+        <p:nvSpPr>
+          <p:cNvPr id="10" name="TextBox 9"/>
+          <p:cNvSpPr txBox="1"/>
+          <p:nvPr/>
+        </p:nvSpPr>
+        <p:spPr>
+          <a:xfrm>
+            <a:off x="0" y="4960620"/>
+            <a:ext cx="12191695" cy="411480"/>
+          </a:xfrm>
+          <a:prstGeom prst="rect">
+            <a:avLst/>
+          </a:prstGeom>
+          <a:noFill/>
+        </p:spPr>
+        <p:txBody>
+          <a:bodyPr wrap="square" lIns="0" rIns="0" tIns="0" bIns="0" anchor="t">
+            <a:spAutoFit/>
+          </a:bodyPr>
+          <a:lstStyle/>
+          <a:p>
+            <a:pPr algn="ctr"/>
             <a:r>
               <a:rPr sz="1600" b="0" i="0">
                 <a:solidFill>

</xml_diff>

<commit_message>
trim logos to alpha bbox so visible heights and gaps match
The raw KCL / KCLNLP / Alan PNGs carry different amounts of
transparent padding, so scaling them to the same image height
produced different visible heights and uneven inter-logo gaps.
Crop each logo to its non-transparent bounding box (cached in
assets/logos/_trimmed/) and use those trimmed copies when
placing the header. Result: logos now share the same visible
baseline/cap and a uniform gap between them.

Co-Authored-By: Claude Opus 4.7 (1M context) <noreply@anthropic.com>
</commit_message>
<xml_diff>
--- a/templates/tree_yellow_texture/KCLNLP_TreeYellow.pptx
+++ b/templates/tree_yellow_texture/KCLNLP_TreeYellow.pptx
@@ -3153,8 +3153,8 @@
         </p:blipFill>
         <p:spPr>
           <a:xfrm>
-            <a:off x="8368581" y="205740"/>
-            <a:ext cx="1108061" cy="548640"/>
+            <a:off x="8598181" y="205740"/>
+            <a:ext cx="873549" cy="548640"/>
           </a:xfrm>
           <a:prstGeom prst="rect">
             <a:avLst/>
@@ -3177,7 +3177,7 @@
         </p:blipFill>
         <p:spPr>
           <a:xfrm>
-            <a:off x="9677810" y="205740"/>
+            <a:off x="9672897" y="205740"/>
             <a:ext cx="603709" cy="548640"/>
           </a:xfrm>
           <a:prstGeom prst="rect">
@@ -3201,8 +3201,8 @@
         </p:blipFill>
         <p:spPr>
           <a:xfrm>
-            <a:off x="10482687" y="205740"/>
-            <a:ext cx="1297528" cy="548640"/>
+            <a:off x="10477774" y="205740"/>
+            <a:ext cx="1302442" cy="548640"/>
           </a:xfrm>
           <a:prstGeom prst="rect">
             <a:avLst/>
@@ -3504,8 +3504,8 @@
         </p:blipFill>
         <p:spPr>
           <a:xfrm>
-            <a:off x="8368581" y="205740"/>
-            <a:ext cx="1108061" cy="548640"/>
+            <a:off x="8598181" y="205740"/>
+            <a:ext cx="873549" cy="548640"/>
           </a:xfrm>
           <a:prstGeom prst="rect">
             <a:avLst/>
@@ -3528,7 +3528,7 @@
         </p:blipFill>
         <p:spPr>
           <a:xfrm>
-            <a:off x="9677810" y="205740"/>
+            <a:off x="9672897" y="205740"/>
             <a:ext cx="603709" cy="548640"/>
           </a:xfrm>
           <a:prstGeom prst="rect">
@@ -3552,8 +3552,8 @@
         </p:blipFill>
         <p:spPr>
           <a:xfrm>
-            <a:off x="10482687" y="205740"/>
-            <a:ext cx="1297528" cy="548640"/>
+            <a:off x="10477774" y="205740"/>
+            <a:ext cx="1302442" cy="548640"/>
           </a:xfrm>
           <a:prstGeom prst="rect">
             <a:avLst/>
@@ -3855,8 +3855,8 @@
         </p:blipFill>
         <p:spPr>
           <a:xfrm>
-            <a:off x="8368581" y="205740"/>
-            <a:ext cx="1108061" cy="548640"/>
+            <a:off x="8598181" y="205740"/>
+            <a:ext cx="873549" cy="548640"/>
           </a:xfrm>
           <a:prstGeom prst="rect">
             <a:avLst/>
@@ -3879,7 +3879,7 @@
         </p:blipFill>
         <p:spPr>
           <a:xfrm>
-            <a:off x="9677810" y="205740"/>
+            <a:off x="9672897" y="205740"/>
             <a:ext cx="603709" cy="548640"/>
           </a:xfrm>
           <a:prstGeom prst="rect">
@@ -3903,8 +3903,8 @@
         </p:blipFill>
         <p:spPr>
           <a:xfrm>
-            <a:off x="10482687" y="205740"/>
-            <a:ext cx="1297528" cy="548640"/>
+            <a:off x="10477774" y="205740"/>
+            <a:ext cx="1302442" cy="548640"/>
           </a:xfrm>
           <a:prstGeom prst="rect">
             <a:avLst/>
@@ -3920,7 +3920,7 @@
         <p:spPr>
           <a:xfrm>
             <a:off x="411480" y="0"/>
-            <a:ext cx="7682781" cy="960120"/>
+            <a:ext cx="7912381" cy="960120"/>
           </a:xfrm>
           <a:prstGeom prst="rect">
             <a:avLst/>
@@ -4207,8 +4207,8 @@
         </p:blipFill>
         <p:spPr>
           <a:xfrm>
-            <a:off x="8368581" y="205740"/>
-            <a:ext cx="1108061" cy="548640"/>
+            <a:off x="8598181" y="205740"/>
+            <a:ext cx="873549" cy="548640"/>
           </a:xfrm>
           <a:prstGeom prst="rect">
             <a:avLst/>
@@ -4231,7 +4231,7 @@
         </p:blipFill>
         <p:spPr>
           <a:xfrm>
-            <a:off x="9677810" y="205740"/>
+            <a:off x="9672897" y="205740"/>
             <a:ext cx="603709" cy="548640"/>
           </a:xfrm>
           <a:prstGeom prst="rect">
@@ -4255,8 +4255,8 @@
         </p:blipFill>
         <p:spPr>
           <a:xfrm>
-            <a:off x="10482687" y="205740"/>
-            <a:ext cx="1297528" cy="548640"/>
+            <a:off x="10477774" y="205740"/>
+            <a:ext cx="1302442" cy="548640"/>
           </a:xfrm>
           <a:prstGeom prst="rect">
             <a:avLst/>
@@ -4272,7 +4272,7 @@
         <p:spPr>
           <a:xfrm>
             <a:off x="411480" y="0"/>
-            <a:ext cx="7682781" cy="960120"/>
+            <a:ext cx="7912381" cy="960120"/>
           </a:xfrm>
           <a:prstGeom prst="rect">
             <a:avLst/>
@@ -4557,8 +4557,8 @@
         </p:blipFill>
         <p:spPr>
           <a:xfrm>
-            <a:off x="8368581" y="205740"/>
-            <a:ext cx="1108061" cy="548640"/>
+            <a:off x="8598181" y="205740"/>
+            <a:ext cx="873549" cy="548640"/>
           </a:xfrm>
           <a:prstGeom prst="rect">
             <a:avLst/>
@@ -4581,7 +4581,7 @@
         </p:blipFill>
         <p:spPr>
           <a:xfrm>
-            <a:off x="9677810" y="205740"/>
+            <a:off x="9672897" y="205740"/>
             <a:ext cx="603709" cy="548640"/>
           </a:xfrm>
           <a:prstGeom prst="rect">
@@ -4605,8 +4605,8 @@
         </p:blipFill>
         <p:spPr>
           <a:xfrm>
-            <a:off x="10482687" y="205740"/>
-            <a:ext cx="1297528" cy="548640"/>
+            <a:off x="10477774" y="205740"/>
+            <a:ext cx="1302442" cy="548640"/>
           </a:xfrm>
           <a:prstGeom prst="rect">
             <a:avLst/>
@@ -4622,7 +4622,7 @@
         <p:spPr>
           <a:xfrm>
             <a:off x="411480" y="0"/>
-            <a:ext cx="7682781" cy="960120"/>
+            <a:ext cx="7912381" cy="960120"/>
           </a:xfrm>
           <a:prstGeom prst="rect">
             <a:avLst/>
@@ -4953,8 +4953,8 @@
         </p:blipFill>
         <p:spPr>
           <a:xfrm>
-            <a:off x="8368581" y="205740"/>
-            <a:ext cx="1108061" cy="548640"/>
+            <a:off x="8598181" y="205740"/>
+            <a:ext cx="873549" cy="548640"/>
           </a:xfrm>
           <a:prstGeom prst="rect">
             <a:avLst/>
@@ -4977,7 +4977,7 @@
         </p:blipFill>
         <p:spPr>
           <a:xfrm>
-            <a:off x="9677810" y="205740"/>
+            <a:off x="9672897" y="205740"/>
             <a:ext cx="603709" cy="548640"/>
           </a:xfrm>
           <a:prstGeom prst="rect">
@@ -5001,8 +5001,8 @@
         </p:blipFill>
         <p:spPr>
           <a:xfrm>
-            <a:off x="10482687" y="205740"/>
-            <a:ext cx="1297528" cy="548640"/>
+            <a:off x="10477774" y="205740"/>
+            <a:ext cx="1302442" cy="548640"/>
           </a:xfrm>
           <a:prstGeom prst="rect">
             <a:avLst/>
@@ -5304,8 +5304,8 @@
         </p:blipFill>
         <p:spPr>
           <a:xfrm>
-            <a:off x="8368581" y="205740"/>
-            <a:ext cx="1108061" cy="548640"/>
+            <a:off x="8598181" y="205740"/>
+            <a:ext cx="873549" cy="548640"/>
           </a:xfrm>
           <a:prstGeom prst="rect">
             <a:avLst/>
@@ -5328,7 +5328,7 @@
         </p:blipFill>
         <p:spPr>
           <a:xfrm>
-            <a:off x="9677810" y="205740"/>
+            <a:off x="9672897" y="205740"/>
             <a:ext cx="603709" cy="548640"/>
           </a:xfrm>
           <a:prstGeom prst="rect">
@@ -5352,8 +5352,8 @@
         </p:blipFill>
         <p:spPr>
           <a:xfrm>
-            <a:off x="10482687" y="205740"/>
-            <a:ext cx="1297528" cy="548640"/>
+            <a:off x="10477774" y="205740"/>
+            <a:ext cx="1302442" cy="548640"/>
           </a:xfrm>
           <a:prstGeom prst="rect">
             <a:avLst/>

</xml_diff>